<commit_message>
end 27/03: normalized the images
</commit_message>
<xml_diff>
--- a/Seminar.pptx
+++ b/Seminar.pptx
@@ -5,7 +5,7 @@
     <p:sldMasterId id="2147483684" r:id="rId1"/>
   </p:sldMasterIdLst>
   <p:notesMasterIdLst>
-    <p:notesMasterId r:id="rId18"/>
+    <p:notesMasterId r:id="rId20"/>
   </p:notesMasterIdLst>
   <p:sldIdLst>
     <p:sldId id="276" r:id="rId2"/>
@@ -21,9 +21,11 @@
     <p:sldId id="337" r:id="rId12"/>
     <p:sldId id="338" r:id="rId13"/>
     <p:sldId id="328" r:id="rId14"/>
-    <p:sldId id="327" r:id="rId15"/>
-    <p:sldId id="289" r:id="rId16"/>
-    <p:sldId id="290" r:id="rId17"/>
+    <p:sldId id="339" r:id="rId15"/>
+    <p:sldId id="340" r:id="rId16"/>
+    <p:sldId id="327" r:id="rId17"/>
+    <p:sldId id="289" r:id="rId18"/>
+    <p:sldId id="290" r:id="rId19"/>
   </p:sldIdLst>
   <p:sldSz cx="12192000" cy="6858000"/>
   <p:notesSz cx="6858000" cy="9144000"/>
@@ -7150,6 +7152,50 @@
           </a:p>
         </p:txBody>
       </p:sp>
+      <p:sp>
+        <p:nvSpPr>
+          <p:cNvPr id="2" name="CasellaDiTesto 1">
+            <a:extLst>
+              <a:ext uri="{FF2B5EF4-FFF2-40B4-BE49-F238E27FC236}">
+                <a16:creationId xmlns:a16="http://schemas.microsoft.com/office/drawing/2014/main" id="{7AF8C996-0060-96F7-826D-A5B59B5CCB6B}"/>
+              </a:ext>
+            </a:extLst>
+          </p:cNvPr>
+          <p:cNvSpPr txBox="1"/>
+          <p:nvPr/>
+        </p:nvSpPr>
+        <p:spPr>
+          <a:xfrm>
+            <a:off x="6688476" y="2178121"/>
+            <a:ext cx="2630185" cy="369332"/>
+          </a:xfrm>
+          <a:prstGeom prst="rect">
+            <a:avLst/>
+          </a:prstGeom>
+          <a:noFill/>
+        </p:spPr>
+        <p:txBody>
+          <a:bodyPr wrap="square" rtlCol="0">
+            <a:spAutoFit/>
+          </a:bodyPr>
+          <a:lstStyle/>
+          <a:p>
+            <a:r>
+              <a:rPr lang="it-IT" dirty="0" err="1"/>
+              <a:t>Hist</a:t>
+            </a:r>
+            <a:r>
+              <a:rPr lang="it-IT" dirty="0"/>
+              <a:t> par </a:t>
+            </a:r>
+            <a:r>
+              <a:rPr lang="it-IT" dirty="0" err="1"/>
+              <a:t>img</a:t>
+            </a:r>
+            <a:endParaRPr lang="it-IT" dirty="0"/>
+          </a:p>
+        </p:txBody>
+      </p:sp>
     </p:spTree>
     <p:extLst>
       <p:ext uri="{BB962C8B-B14F-4D97-AF65-F5344CB8AC3E}">
@@ -8179,6 +8225,644 @@
         <p:cNvPr id="1" name="">
           <a:extLst>
             <a:ext uri="{FF2B5EF4-FFF2-40B4-BE49-F238E27FC236}">
+              <a16:creationId xmlns:a16="http://schemas.microsoft.com/office/drawing/2014/main" id="{C0A026A7-7C5E-E914-F984-A40B37CCE10B}"/>
+            </a:ext>
+          </a:extLst>
+        </p:cNvPr>
+        <p:cNvGrpSpPr/>
+        <p:nvPr/>
+      </p:nvGrpSpPr>
+      <p:grpSpPr>
+        <a:xfrm>
+          <a:off x="0" y="0"/>
+          <a:ext cx="0" cy="0"/>
+          <a:chOff x="0" y="0"/>
+          <a:chExt cx="0" cy="0"/>
+        </a:xfrm>
+      </p:grpSpPr>
+      <mc:AlternateContent xmlns:mc="http://schemas.openxmlformats.org/markup-compatibility/2006" xmlns:a14="http://schemas.microsoft.com/office/drawing/2010/main">
+        <mc:Choice Requires="a14">
+          <p:sp>
+            <p:nvSpPr>
+              <p:cNvPr id="4" name="Titolo 1">
+                <a:extLst>
+                  <a:ext uri="{FF2B5EF4-FFF2-40B4-BE49-F238E27FC236}">
+                    <a16:creationId xmlns:a16="http://schemas.microsoft.com/office/drawing/2014/main" id="{D67CD9F1-19DB-7679-A1E8-A3FE1AAFC7BD}"/>
+                  </a:ext>
+                </a:extLst>
+              </p:cNvPr>
+              <p:cNvSpPr>
+                <a:spLocks noGrp="1"/>
+              </p:cNvSpPr>
+              <p:nvPr>
+                <p:ph type="title"/>
+              </p:nvPr>
+            </p:nvSpPr>
+            <p:spPr>
+              <a:xfrm>
+                <a:off x="642938" y="288925"/>
+                <a:ext cx="10227120" cy="1235075"/>
+              </a:xfrm>
+            </p:spPr>
+            <p:txBody>
+              <a:bodyPr>
+                <a:normAutofit/>
+              </a:bodyPr>
+              <a:lstStyle/>
+              <a:p>
+                <a:r>
+                  <a:rPr lang="en-GB" noProof="0" dirty="0"/>
+                  <a:t>Classification on </a:t>
+                </a:r>
+                <a14:m>
+                  <m:oMath xmlns:m="http://schemas.openxmlformats.org/officeDocument/2006/math">
+                    <m:func>
+                      <m:funcPr>
+                        <m:ctrlPr>
+                          <a:rPr lang="en-GB" i="1" noProof="0" smtClean="0">
+                            <a:latin typeface="Cambria Math" panose="02040503050406030204" pitchFamily="18" charset="0"/>
+                          </a:rPr>
+                        </m:ctrlPr>
+                      </m:funcPr>
+                      <m:fName>
+                        <m:r>
+                          <m:rPr>
+                            <m:sty m:val="p"/>
+                          </m:rPr>
+                          <a:rPr lang="en-GB" noProof="0" smtClean="0">
+                            <a:latin typeface="Cambria Math" panose="02040503050406030204" pitchFamily="18" charset="0"/>
+                          </a:rPr>
+                          <m:t>log</m:t>
+                        </m:r>
+                      </m:fName>
+                      <m:e>
+                        <m:d>
+                          <m:dPr>
+                            <m:ctrlPr>
+                              <a:rPr lang="en-GB" i="1" noProof="0" smtClean="0">
+                                <a:latin typeface="Cambria Math" panose="02040503050406030204" pitchFamily="18" charset="0"/>
+                              </a:rPr>
+                            </m:ctrlPr>
+                          </m:dPr>
+                          <m:e>
+                            <m:sSub>
+                              <m:sSubPr>
+                                <m:ctrlPr>
+                                  <a:rPr lang="en-GB" i="1" noProof="0">
+                                    <a:latin typeface="Cambria Math" panose="02040503050406030204" pitchFamily="18" charset="0"/>
+                                  </a:rPr>
+                                </m:ctrlPr>
+                              </m:sSubPr>
+                              <m:e>
+                                <m:r>
+                                  <a:rPr lang="en-GB" i="1" noProof="0">
+                                    <a:latin typeface="Cambria Math" panose="02040503050406030204" pitchFamily="18" charset="0"/>
+                                  </a:rPr>
+                                  <m:t>𝑇</m:t>
+                                </m:r>
+                              </m:e>
+                              <m:sub>
+                                <m:r>
+                                  <a:rPr lang="en-GB" i="1" noProof="0">
+                                    <a:latin typeface="Cambria Math" panose="02040503050406030204" pitchFamily="18" charset="0"/>
+                                  </a:rPr>
+                                  <m:t>9</m:t>
+                                </m:r>
+                                <m:r>
+                                  <a:rPr lang="en-GB" i="1" noProof="0" smtClean="0">
+                                    <a:latin typeface="Cambria Math" panose="02040503050406030204" pitchFamily="18" charset="0"/>
+                                  </a:rPr>
+                                  <m:t>0</m:t>
+                                </m:r>
+                              </m:sub>
+                            </m:sSub>
+                          </m:e>
+                        </m:d>
+                      </m:e>
+                    </m:func>
+                  </m:oMath>
+                </a14:m>
+                <a:r>
+                  <a:rPr lang="en-GB" noProof="0" dirty="0"/>
+                  <a:t>: final model </a:t>
+                </a:r>
+              </a:p>
+            </p:txBody>
+          </p:sp>
+        </mc:Choice>
+        <mc:Fallback xmlns="">
+          <p:sp>
+            <p:nvSpPr>
+              <p:cNvPr id="4" name="Titolo 1">
+                <a:extLst>
+                  <a:ext uri="{FF2B5EF4-FFF2-40B4-BE49-F238E27FC236}">
+                    <a16:creationId xmlns:a16="http://schemas.microsoft.com/office/drawing/2014/main" id="{D67CD9F1-19DB-7679-A1E8-A3FE1AAFC7BD}"/>
+                  </a:ext>
+                </a:extLst>
+              </p:cNvPr>
+              <p:cNvSpPr>
+                <a:spLocks noGrp="1" noRot="1" noChangeAspect="1" noMove="1" noResize="1" noEditPoints="1" noAdjustHandles="1" noChangeArrowheads="1" noChangeShapeType="1" noTextEdit="1"/>
+              </p:cNvSpPr>
+              <p:nvPr>
+                <p:ph type="title"/>
+              </p:nvPr>
+            </p:nvSpPr>
+            <p:spPr>
+              <a:xfrm>
+                <a:off x="642938" y="288925"/>
+                <a:ext cx="10227120" cy="1235075"/>
+              </a:xfrm>
+              <a:blipFill>
+                <a:blip r:embed="rId2"/>
+                <a:stretch>
+                  <a:fillRect l="-2384" t="-15271"/>
+                </a:stretch>
+              </a:blipFill>
+            </p:spPr>
+            <p:txBody>
+              <a:bodyPr/>
+              <a:lstStyle/>
+              <a:p>
+                <a:r>
+                  <a:rPr lang="it-IT">
+                    <a:noFill/>
+                  </a:rPr>
+                  <a:t> </a:t>
+                </a:r>
+              </a:p>
+            </p:txBody>
+          </p:sp>
+        </mc:Fallback>
+      </mc:AlternateContent>
+      <p:sp>
+        <p:nvSpPr>
+          <p:cNvPr id="12" name="CasellaDiTesto 11">
+            <a:extLst>
+              <a:ext uri="{FF2B5EF4-FFF2-40B4-BE49-F238E27FC236}">
+                <a16:creationId xmlns:a16="http://schemas.microsoft.com/office/drawing/2014/main" id="{C02E9209-318D-37B3-6915-51823614E145}"/>
+              </a:ext>
+            </a:extLst>
+          </p:cNvPr>
+          <p:cNvSpPr txBox="1"/>
+          <p:nvPr/>
+        </p:nvSpPr>
+        <p:spPr>
+          <a:xfrm>
+            <a:off x="642938" y="1517151"/>
+            <a:ext cx="3387047" cy="3139321"/>
+          </a:xfrm>
+          <a:prstGeom prst="rect">
+            <a:avLst/>
+          </a:prstGeom>
+          <a:noFill/>
+        </p:spPr>
+        <p:txBody>
+          <a:bodyPr wrap="square" rtlCol="0">
+            <a:spAutoFit/>
+          </a:bodyPr>
+          <a:lstStyle/>
+          <a:p>
+            <a:r>
+              <a:rPr lang="it-IT" dirty="0" err="1"/>
+              <a:t>Finally</a:t>
+            </a:r>
+            <a:r>
+              <a:rPr lang="it-IT" dirty="0"/>
+              <a:t> we look </a:t>
+            </a:r>
+            <a:r>
+              <a:rPr lang="it-IT" dirty="0" err="1"/>
+              <a:t>at</a:t>
+            </a:r>
+            <a:r>
+              <a:rPr lang="it-IT" dirty="0"/>
+              <a:t> the </a:t>
+            </a:r>
+            <a:r>
+              <a:rPr lang="it-IT" dirty="0" err="1"/>
+              <a:t>final</a:t>
+            </a:r>
+            <a:r>
+              <a:rPr lang="it-IT" dirty="0"/>
+              <a:t> model, </a:t>
+            </a:r>
+            <a:r>
+              <a:rPr lang="it-IT" dirty="0" err="1"/>
+              <a:t>computed</a:t>
+            </a:r>
+            <a:r>
+              <a:rPr lang="it-IT" dirty="0"/>
+              <a:t> </a:t>
+            </a:r>
+            <a:r>
+              <a:rPr lang="it-IT" dirty="0" err="1"/>
+              <a:t>as</a:t>
+            </a:r>
+            <a:r>
+              <a:rPr lang="it-IT" dirty="0"/>
+              <a:t> the </a:t>
+            </a:r>
+            <a:r>
+              <a:rPr lang="it-IT" dirty="0" err="1"/>
+              <a:t>median</a:t>
+            </a:r>
+            <a:r>
+              <a:rPr lang="it-IT" dirty="0"/>
+              <a:t> of the models </a:t>
+            </a:r>
+            <a:r>
+              <a:rPr lang="it-IT" dirty="0" err="1"/>
+              <a:t>computed</a:t>
+            </a:r>
+            <a:r>
+              <a:rPr lang="it-IT" dirty="0"/>
+              <a:t> on </a:t>
+            </a:r>
+            <a:r>
+              <a:rPr lang="it-IT" dirty="0" err="1"/>
+              <a:t>each</a:t>
+            </a:r>
+            <a:r>
+              <a:rPr lang="it-IT" dirty="0"/>
+              <a:t> sample (and not the model on the </a:t>
+            </a:r>
+            <a:r>
+              <a:rPr lang="it-IT" dirty="0" err="1"/>
+              <a:t>median</a:t>
+            </a:r>
+            <a:r>
+              <a:rPr lang="it-IT" dirty="0"/>
+              <a:t> </a:t>
+            </a:r>
+            <a:r>
+              <a:rPr lang="it-IT" dirty="0" err="1"/>
+              <a:t>values</a:t>
+            </a:r>
+            <a:r>
+              <a:rPr lang="it-IT" dirty="0"/>
+              <a:t>) and we </a:t>
+            </a:r>
+            <a:r>
+              <a:rPr lang="it-IT" dirty="0" err="1"/>
+              <a:t>also</a:t>
+            </a:r>
+            <a:r>
+              <a:rPr lang="it-IT" dirty="0"/>
+              <a:t> plot the </a:t>
+            </a:r>
+            <a:r>
+              <a:rPr lang="it-IT" dirty="0" err="1"/>
+              <a:t>interval</a:t>
+            </a:r>
+            <a:r>
+              <a:rPr lang="it-IT" dirty="0"/>
+              <a:t> </a:t>
+            </a:r>
+            <a:r>
+              <a:rPr lang="it-IT" dirty="0" err="1"/>
+              <a:t>corrisponding</a:t>
+            </a:r>
+            <a:r>
+              <a:rPr lang="it-IT" dirty="0"/>
+              <a:t> to 68% </a:t>
+            </a:r>
+            <a:r>
+              <a:rPr lang="it-IT" dirty="0" err="1"/>
+              <a:t>level</a:t>
+            </a:r>
+            <a:r>
+              <a:rPr lang="it-IT" dirty="0"/>
+              <a:t> of confidence. We </a:t>
+            </a:r>
+            <a:r>
+              <a:rPr lang="it-IT" dirty="0" err="1"/>
+              <a:t>also</a:t>
+            </a:r>
+            <a:r>
+              <a:rPr lang="it-IT" dirty="0"/>
+              <a:t> show the </a:t>
+            </a:r>
+            <a:r>
+              <a:rPr lang="it-IT" dirty="0" err="1"/>
+              <a:t>two</a:t>
+            </a:r>
+            <a:r>
+              <a:rPr lang="it-IT" dirty="0"/>
+              <a:t> </a:t>
+            </a:r>
+            <a:r>
+              <a:rPr lang="it-IT" dirty="0" err="1"/>
+              <a:t>separete</a:t>
+            </a:r>
+            <a:r>
+              <a:rPr lang="it-IT" dirty="0"/>
+              <a:t> </a:t>
+            </a:r>
+            <a:r>
+              <a:rPr lang="it-IT" dirty="0" err="1"/>
+              <a:t>components</a:t>
+            </a:r>
+            <a:r>
+              <a:rPr lang="it-IT" dirty="0"/>
+              <a:t> of the model</a:t>
+            </a:r>
+          </a:p>
+        </p:txBody>
+      </p:sp>
+      <p:sp>
+        <p:nvSpPr>
+          <p:cNvPr id="2" name="CasellaDiTesto 1">
+            <a:extLst>
+              <a:ext uri="{FF2B5EF4-FFF2-40B4-BE49-F238E27FC236}">
+                <a16:creationId xmlns:a16="http://schemas.microsoft.com/office/drawing/2014/main" id="{A813098C-0858-D030-C73E-CCE714DEEA2F}"/>
+              </a:ext>
+            </a:extLst>
+          </p:cNvPr>
+          <p:cNvSpPr txBox="1"/>
+          <p:nvPr/>
+        </p:nvSpPr>
+        <p:spPr>
+          <a:xfrm>
+            <a:off x="6688476" y="2178121"/>
+            <a:ext cx="2630185" cy="369332"/>
+          </a:xfrm>
+          <a:prstGeom prst="rect">
+            <a:avLst/>
+          </a:prstGeom>
+          <a:noFill/>
+        </p:spPr>
+        <p:txBody>
+          <a:bodyPr wrap="square" rtlCol="0">
+            <a:spAutoFit/>
+          </a:bodyPr>
+          <a:lstStyle/>
+          <a:p>
+            <a:r>
+              <a:rPr lang="it-IT" dirty="0" err="1"/>
+              <a:t>Final</a:t>
+            </a:r>
+            <a:r>
+              <a:rPr lang="it-IT" dirty="0"/>
+              <a:t> model </a:t>
+            </a:r>
+            <a:r>
+              <a:rPr lang="it-IT" dirty="0" err="1"/>
+              <a:t>img</a:t>
+            </a:r>
+            <a:endParaRPr lang="it-IT" dirty="0"/>
+          </a:p>
+        </p:txBody>
+      </p:sp>
+    </p:spTree>
+    <p:extLst>
+      <p:ext uri="{BB962C8B-B14F-4D97-AF65-F5344CB8AC3E}">
+        <p14:creationId xmlns:p14="http://schemas.microsoft.com/office/powerpoint/2010/main" val="1196759426"/>
+      </p:ext>
+    </p:extLst>
+  </p:cSld>
+  <p:clrMapOvr>
+    <a:masterClrMapping/>
+  </p:clrMapOvr>
+</p:sld>
+</file>
+
+<file path=ppt/slides/slide15.xml><?xml version="1.0" encoding="utf-8"?>
+<p:sld xmlns:a="http://schemas.openxmlformats.org/drawingml/2006/main" xmlns:r="http://schemas.openxmlformats.org/officeDocument/2006/relationships" xmlns:p="http://schemas.openxmlformats.org/presentationml/2006/main">
+  <p:cSld>
+    <p:spTree>
+      <p:nvGrpSpPr>
+        <p:cNvPr id="1" name="">
+          <a:extLst>
+            <a:ext uri="{FF2B5EF4-FFF2-40B4-BE49-F238E27FC236}">
+              <a16:creationId xmlns:a16="http://schemas.microsoft.com/office/drawing/2014/main" id="{C58B4848-BCDE-BE79-9846-0785787D7874}"/>
+            </a:ext>
+          </a:extLst>
+        </p:cNvPr>
+        <p:cNvGrpSpPr/>
+        <p:nvPr/>
+      </p:nvGrpSpPr>
+      <p:grpSpPr>
+        <a:xfrm>
+          <a:off x="0" y="0"/>
+          <a:ext cx="0" cy="0"/>
+          <a:chOff x="0" y="0"/>
+          <a:chExt cx="0" cy="0"/>
+        </a:xfrm>
+      </p:grpSpPr>
+      <mc:AlternateContent xmlns:mc="http://schemas.openxmlformats.org/markup-compatibility/2006">
+        <mc:Choice xmlns:a14="http://schemas.microsoft.com/office/drawing/2010/main" Requires="a14">
+          <p:sp>
+            <p:nvSpPr>
+              <p:cNvPr id="4" name="Titolo 1">
+                <a:extLst>
+                  <a:ext uri="{FF2B5EF4-FFF2-40B4-BE49-F238E27FC236}">
+                    <a16:creationId xmlns:a16="http://schemas.microsoft.com/office/drawing/2014/main" id="{635BCE01-13DF-C903-4E4A-E887A64201E3}"/>
+                  </a:ext>
+                </a:extLst>
+              </p:cNvPr>
+              <p:cNvSpPr>
+                <a:spLocks noGrp="1"/>
+              </p:cNvSpPr>
+              <p:nvPr>
+                <p:ph type="title"/>
+              </p:nvPr>
+            </p:nvSpPr>
+            <p:spPr>
+              <a:xfrm>
+                <a:off x="642938" y="288925"/>
+                <a:ext cx="10227120" cy="1235075"/>
+              </a:xfrm>
+            </p:spPr>
+            <p:txBody>
+              <a:bodyPr>
+                <a:normAutofit/>
+              </a:bodyPr>
+              <a:lstStyle/>
+              <a:p>
+                <a:r>
+                  <a:rPr lang="en-GB" noProof="0" dirty="0"/>
+                  <a:t>Classification on </a:t>
+                </a:r>
+                <a14:m>
+                  <m:oMath xmlns:m="http://schemas.openxmlformats.org/officeDocument/2006/math">
+                    <m:func>
+                      <m:funcPr>
+                        <m:ctrlPr>
+                          <a:rPr lang="en-GB" i="1" noProof="0" smtClean="0">
+                            <a:latin typeface="Cambria Math" panose="02040503050406030204" pitchFamily="18" charset="0"/>
+                          </a:rPr>
+                        </m:ctrlPr>
+                      </m:funcPr>
+                      <m:fName>
+                        <m:r>
+                          <m:rPr>
+                            <m:sty m:val="p"/>
+                          </m:rPr>
+                          <a:rPr lang="en-GB" noProof="0" smtClean="0">
+                            <a:latin typeface="Cambria Math" panose="02040503050406030204" pitchFamily="18" charset="0"/>
+                          </a:rPr>
+                          <m:t>log</m:t>
+                        </m:r>
+                      </m:fName>
+                      <m:e>
+                        <m:d>
+                          <m:dPr>
+                            <m:ctrlPr>
+                              <a:rPr lang="en-GB" i="1" noProof="0" smtClean="0">
+                                <a:latin typeface="Cambria Math" panose="02040503050406030204" pitchFamily="18" charset="0"/>
+                              </a:rPr>
+                            </m:ctrlPr>
+                          </m:dPr>
+                          <m:e>
+                            <m:sSub>
+                              <m:sSubPr>
+                                <m:ctrlPr>
+                                  <a:rPr lang="en-GB" i="1" noProof="0">
+                                    <a:latin typeface="Cambria Math" panose="02040503050406030204" pitchFamily="18" charset="0"/>
+                                  </a:rPr>
+                                </m:ctrlPr>
+                              </m:sSubPr>
+                              <m:e>
+                                <m:r>
+                                  <a:rPr lang="en-GB" i="1" noProof="0">
+                                    <a:latin typeface="Cambria Math" panose="02040503050406030204" pitchFamily="18" charset="0"/>
+                                  </a:rPr>
+                                  <m:t>𝑇</m:t>
+                                </m:r>
+                              </m:e>
+                              <m:sub>
+                                <m:r>
+                                  <a:rPr lang="en-GB" i="1" noProof="0">
+                                    <a:latin typeface="Cambria Math" panose="02040503050406030204" pitchFamily="18" charset="0"/>
+                                  </a:rPr>
+                                  <m:t>9</m:t>
+                                </m:r>
+                                <m:r>
+                                  <a:rPr lang="en-GB" i="1" noProof="0" smtClean="0">
+                                    <a:latin typeface="Cambria Math" panose="02040503050406030204" pitchFamily="18" charset="0"/>
+                                  </a:rPr>
+                                  <m:t>0</m:t>
+                                </m:r>
+                              </m:sub>
+                            </m:sSub>
+                          </m:e>
+                        </m:d>
+                      </m:e>
+                    </m:func>
+                  </m:oMath>
+                </a14:m>
+                <a:r>
+                  <a:rPr lang="en-GB" noProof="0" dirty="0"/>
+                  <a:t> with errors </a:t>
+                </a:r>
+              </a:p>
+            </p:txBody>
+          </p:sp>
+        </mc:Choice>
+        <mc:Fallback>
+          <p:sp>
+            <p:nvSpPr>
+              <p:cNvPr id="4" name="Titolo 1">
+                <a:extLst>
+                  <a:ext uri="{FF2B5EF4-FFF2-40B4-BE49-F238E27FC236}">
+                    <a16:creationId xmlns:a16="http://schemas.microsoft.com/office/drawing/2014/main" id="{635BCE01-13DF-C903-4E4A-E887A64201E3}"/>
+                  </a:ext>
+                </a:extLst>
+              </p:cNvPr>
+              <p:cNvSpPr>
+                <a:spLocks noGrp="1" noRot="1" noChangeAspect="1" noMove="1" noResize="1" noEditPoints="1" noAdjustHandles="1" noChangeArrowheads="1" noChangeShapeType="1" noTextEdit="1"/>
+              </p:cNvSpPr>
+              <p:nvPr>
+                <p:ph type="title"/>
+              </p:nvPr>
+            </p:nvSpPr>
+            <p:spPr>
+              <a:xfrm>
+                <a:off x="642938" y="288925"/>
+                <a:ext cx="10227120" cy="1235075"/>
+              </a:xfrm>
+              <a:blipFill>
+                <a:blip r:embed="rId2"/>
+                <a:stretch>
+                  <a:fillRect l="-2384" t="-15271"/>
+                </a:stretch>
+              </a:blipFill>
+            </p:spPr>
+            <p:txBody>
+              <a:bodyPr/>
+              <a:lstStyle/>
+              <a:p>
+                <a:r>
+                  <a:rPr lang="it-IT">
+                    <a:noFill/>
+                  </a:rPr>
+                  <a:t> </a:t>
+                </a:r>
+              </a:p>
+            </p:txBody>
+          </p:sp>
+        </mc:Fallback>
+      </mc:AlternateContent>
+      <p:sp>
+        <p:nvSpPr>
+          <p:cNvPr id="12" name="CasellaDiTesto 11">
+            <a:extLst>
+              <a:ext uri="{FF2B5EF4-FFF2-40B4-BE49-F238E27FC236}">
+                <a16:creationId xmlns:a16="http://schemas.microsoft.com/office/drawing/2014/main" id="{7F1FAD3D-7226-39C2-4F69-F003E58656CF}"/>
+              </a:ext>
+            </a:extLst>
+          </p:cNvPr>
+          <p:cNvSpPr txBox="1"/>
+          <p:nvPr/>
+        </p:nvSpPr>
+        <p:spPr>
+          <a:xfrm>
+            <a:off x="642938" y="1517151"/>
+            <a:ext cx="3387047" cy="369332"/>
+          </a:xfrm>
+          <a:prstGeom prst="rect">
+            <a:avLst/>
+          </a:prstGeom>
+          <a:noFill/>
+        </p:spPr>
+        <p:txBody>
+          <a:bodyPr wrap="square" rtlCol="0">
+            <a:spAutoFit/>
+          </a:bodyPr>
+          <a:lstStyle/>
+          <a:p>
+            <a:r>
+              <a:rPr lang="it-IT" dirty="0" err="1"/>
+              <a:t>Consider</a:t>
+            </a:r>
+            <a:r>
+              <a:rPr lang="it-IT" dirty="0"/>
+              <a:t> </a:t>
+            </a:r>
+          </a:p>
+        </p:txBody>
+      </p:sp>
+    </p:spTree>
+    <p:extLst>
+      <p:ext uri="{BB962C8B-B14F-4D97-AF65-F5344CB8AC3E}">
+        <p14:creationId xmlns:p14="http://schemas.microsoft.com/office/powerpoint/2010/main" val="2651039601"/>
+      </p:ext>
+    </p:extLst>
+  </p:cSld>
+  <p:clrMapOvr>
+    <a:masterClrMapping/>
+  </p:clrMapOvr>
+</p:sld>
+</file>
+
+<file path=ppt/slides/slide16.xml><?xml version="1.0" encoding="utf-8"?>
+<p:sld xmlns:a="http://schemas.openxmlformats.org/drawingml/2006/main" xmlns:r="http://schemas.openxmlformats.org/officeDocument/2006/relationships" xmlns:p="http://schemas.openxmlformats.org/presentationml/2006/main">
+  <p:cSld>
+    <p:spTree>
+      <p:nvGrpSpPr>
+        <p:cNvPr id="1" name="">
+          <a:extLst>
+            <a:ext uri="{FF2B5EF4-FFF2-40B4-BE49-F238E27FC236}">
               <a16:creationId xmlns:a16="http://schemas.microsoft.com/office/drawing/2014/main" id="{94B4B57A-6293-2976-B48B-555FE2F44DE3}"/>
             </a:ext>
           </a:extLst>
@@ -8216,10 +8900,9 @@
           <a:lstStyle/>
           <a:p>
             <a:r>
-              <a:rPr lang="en-GB" noProof="0" dirty="0" err="1"/>
-              <a:t>Conclusioni</a:t>
-            </a:r>
-            <a:endParaRPr lang="en-GB" noProof="0" dirty="0"/>
+              <a:rPr lang="en-GB" noProof="0" dirty="0"/>
+              <a:t>Conclusions</a:t>
+            </a:r>
           </a:p>
         </p:txBody>
       </p:sp>
@@ -8258,279 +8941,7 @@
             </a:pPr>
             <a:r>
               <a:rPr lang="en-GB" sz="2400" noProof="0" dirty="0"/>
-              <a:t> Le </a:t>
-            </a:r>
-            <a:r>
-              <a:rPr lang="en-GB" sz="2400" noProof="0" dirty="0" err="1"/>
-              <a:t>onde</a:t>
-            </a:r>
-            <a:r>
-              <a:rPr lang="en-GB" sz="2400" noProof="0" dirty="0"/>
-              <a:t> di Alfvén con </a:t>
-            </a:r>
-            <a:r>
-              <a:rPr lang="en-GB" sz="2400" noProof="0" dirty="0" err="1"/>
-              <a:t>conduttività</a:t>
-            </a:r>
-            <a:r>
-              <a:rPr lang="en-GB" sz="2400" noProof="0" dirty="0"/>
               <a:t> </a:t>
-            </a:r>
-            <a:r>
-              <a:rPr lang="en-GB" sz="2400" noProof="0" dirty="0" err="1"/>
-              <a:t>finita</a:t>
-            </a:r>
-            <a:r>
-              <a:rPr lang="en-GB" sz="2400" noProof="0" dirty="0"/>
-              <a:t> </a:t>
-            </a:r>
-            <a:r>
-              <a:rPr lang="en-GB" sz="2400" noProof="0" dirty="0" err="1"/>
-              <a:t>vengono</a:t>
-            </a:r>
-            <a:r>
-              <a:rPr lang="en-GB" sz="2400" noProof="0" dirty="0"/>
-              <a:t> </a:t>
-            </a:r>
-            <a:r>
-              <a:rPr lang="en-GB" sz="2400" noProof="0" dirty="0" err="1"/>
-              <a:t>smorzate</a:t>
-            </a:r>
-            <a:endParaRPr lang="en-GB" sz="2400" noProof="0" dirty="0"/>
-          </a:p>
-          <a:p>
-            <a:pPr>
-              <a:buSzPct val="90000"/>
-              <a:buFont typeface="Wingdings" panose="05000000000000000000" pitchFamily="2" charset="2"/>
-              <a:buChar char="Ø"/>
-            </a:pPr>
-            <a:r>
-              <a:rPr lang="en-GB" sz="2400" noProof="0" dirty="0"/>
-              <a:t> Il Sole ha </a:t>
-            </a:r>
-            <a:r>
-              <a:rPr lang="en-GB" sz="2400" noProof="0" dirty="0" err="1"/>
-              <a:t>diversi</a:t>
-            </a:r>
-            <a:r>
-              <a:rPr lang="en-GB" sz="2400" noProof="0" dirty="0"/>
-              <a:t> </a:t>
-            </a:r>
-            <a:r>
-              <a:rPr lang="en-GB" sz="2400" noProof="0" dirty="0" err="1"/>
-              <a:t>modi</a:t>
-            </a:r>
-            <a:r>
-              <a:rPr lang="en-GB" sz="2400" noProof="0" dirty="0"/>
-              <a:t> di </a:t>
-            </a:r>
-            <a:r>
-              <a:rPr lang="en-GB" sz="2400" noProof="0" dirty="0" err="1"/>
-              <a:t>generare</a:t>
-            </a:r>
-            <a:r>
-              <a:rPr lang="en-GB" sz="2400" noProof="0" dirty="0"/>
-              <a:t> </a:t>
-            </a:r>
-            <a:r>
-              <a:rPr lang="en-GB" sz="2400" noProof="0" dirty="0" err="1"/>
-              <a:t>onde</a:t>
-            </a:r>
-            <a:r>
-              <a:rPr lang="en-GB" sz="2400" noProof="0" dirty="0"/>
-              <a:t> magneto-</a:t>
-            </a:r>
-            <a:r>
-              <a:rPr lang="en-GB" sz="2400" noProof="0" dirty="0" err="1"/>
-              <a:t>idrodinamiche</a:t>
-            </a:r>
-            <a:endParaRPr lang="en-GB" sz="2400" noProof="0" dirty="0"/>
-          </a:p>
-          <a:p>
-            <a:pPr>
-              <a:buSzPct val="90000"/>
-              <a:buFont typeface="Wingdings" panose="05000000000000000000" pitchFamily="2" charset="2"/>
-              <a:buChar char="Ø"/>
-            </a:pPr>
-            <a:r>
-              <a:rPr lang="en-GB" sz="2400" noProof="0" dirty="0"/>
-              <a:t> Le </a:t>
-            </a:r>
-            <a:r>
-              <a:rPr lang="en-GB" sz="2400" noProof="0" dirty="0" err="1"/>
-              <a:t>perturbazioni</a:t>
-            </a:r>
-            <a:r>
-              <a:rPr lang="en-GB" sz="2400" noProof="0" dirty="0"/>
-              <a:t> </a:t>
-            </a:r>
-            <a:r>
-              <a:rPr lang="en-GB" sz="2400" noProof="0" dirty="0" err="1"/>
-              <a:t>della</a:t>
-            </a:r>
-            <a:r>
-              <a:rPr lang="en-GB" sz="2400" noProof="0" dirty="0"/>
-              <a:t> </a:t>
-            </a:r>
-            <a:r>
-              <a:rPr lang="en-GB" sz="2400" noProof="0" dirty="0" err="1"/>
-              <a:t>fotosfera</a:t>
-            </a:r>
-            <a:r>
-              <a:rPr lang="en-GB" sz="2400" noProof="0" dirty="0"/>
-              <a:t> </a:t>
-            </a:r>
-            <a:r>
-              <a:rPr lang="en-GB" sz="2400" noProof="0" dirty="0" err="1"/>
-              <a:t>viste</a:t>
-            </a:r>
-            <a:r>
-              <a:rPr lang="en-GB" sz="2400" noProof="0" dirty="0"/>
-              <a:t> come </a:t>
-            </a:r>
-            <a:r>
-              <a:rPr lang="en-GB" sz="2400" noProof="0" dirty="0" err="1"/>
-              <a:t>granulazione</a:t>
-            </a:r>
-            <a:r>
-              <a:rPr lang="en-GB" sz="2400" noProof="0" dirty="0"/>
-              <a:t> </a:t>
-            </a:r>
-            <a:r>
-              <a:rPr lang="en-GB" sz="2400" noProof="0" dirty="0" err="1"/>
-              <a:t>danno</a:t>
-            </a:r>
-            <a:r>
-              <a:rPr lang="en-GB" sz="2400" noProof="0" dirty="0"/>
-              <a:t> </a:t>
-            </a:r>
-            <a:r>
-              <a:rPr lang="en-GB" sz="2400" noProof="0" dirty="0" err="1"/>
-              <a:t>onde</a:t>
-            </a:r>
-            <a:r>
-              <a:rPr lang="en-GB" sz="2400" noProof="0" dirty="0"/>
-              <a:t> magneto-</a:t>
-            </a:r>
-            <a:r>
-              <a:rPr lang="en-GB" sz="2400" noProof="0" dirty="0" err="1"/>
-              <a:t>idrodinamiche</a:t>
-            </a:r>
-            <a:endParaRPr lang="en-GB" sz="2400" noProof="0" dirty="0"/>
-          </a:p>
-          <a:p>
-            <a:pPr>
-              <a:buSzPct val="90000"/>
-              <a:buFont typeface="Wingdings" panose="05000000000000000000" pitchFamily="2" charset="2"/>
-              <a:buChar char="Ø"/>
-            </a:pPr>
-            <a:r>
-              <a:rPr lang="en-GB" sz="2400" noProof="0" dirty="0"/>
-              <a:t> </a:t>
-            </a:r>
-            <a:r>
-              <a:rPr lang="en-GB" sz="2400" noProof="0" dirty="0" err="1"/>
-              <a:t>Vengono</a:t>
-            </a:r>
-            <a:r>
-              <a:rPr lang="en-GB" sz="2400" noProof="0" dirty="0"/>
-              <a:t> </a:t>
-            </a:r>
-            <a:r>
-              <a:rPr lang="en-GB" sz="2400" noProof="0" dirty="0" err="1"/>
-              <a:t>più</a:t>
-            </a:r>
-            <a:r>
-              <a:rPr lang="en-GB" sz="2400" noProof="0" dirty="0"/>
-              <a:t> </a:t>
-            </a:r>
-            <a:r>
-              <a:rPr lang="en-GB" sz="2400" noProof="0" dirty="0" err="1"/>
-              <a:t>facilmente</a:t>
-            </a:r>
-            <a:r>
-              <a:rPr lang="en-GB" sz="2400" noProof="0" dirty="0"/>
-              <a:t> </a:t>
-            </a:r>
-            <a:r>
-              <a:rPr lang="en-GB" sz="2400" noProof="0" dirty="0" err="1"/>
-              <a:t>assorbite</a:t>
-            </a:r>
-            <a:r>
-              <a:rPr lang="en-GB" sz="2400" noProof="0" dirty="0"/>
-              <a:t> </a:t>
-            </a:r>
-            <a:r>
-              <a:rPr lang="en-GB" sz="2400" noProof="0" dirty="0" err="1"/>
-              <a:t>nella</a:t>
-            </a:r>
-            <a:r>
-              <a:rPr lang="en-GB" sz="2400" noProof="0" dirty="0"/>
-              <a:t> corona </a:t>
-            </a:r>
-            <a:r>
-              <a:rPr lang="en-GB" sz="2400" noProof="0" dirty="0" err="1"/>
-              <a:t>solare</a:t>
-            </a:r>
-            <a:endParaRPr lang="en-GB" sz="2400" noProof="0" dirty="0"/>
-          </a:p>
-          <a:p>
-            <a:pPr>
-              <a:buSzPct val="90000"/>
-              <a:buFont typeface="Wingdings" panose="05000000000000000000" pitchFamily="2" charset="2"/>
-              <a:buChar char="Ø"/>
-            </a:pPr>
-            <a:r>
-              <a:rPr lang="en-GB" sz="2400" noProof="0" dirty="0"/>
-              <a:t> </a:t>
-            </a:r>
-            <a:r>
-              <a:rPr lang="en-GB" sz="2400" noProof="0" dirty="0" err="1"/>
-              <a:t>Possibile</a:t>
-            </a:r>
-            <a:r>
-              <a:rPr lang="en-GB" sz="2400" noProof="0" dirty="0"/>
-              <a:t> </a:t>
-            </a:r>
-            <a:r>
-              <a:rPr lang="en-GB" sz="2400" noProof="0" dirty="0" err="1"/>
-              <a:t>spiegazione</a:t>
-            </a:r>
-            <a:r>
-              <a:rPr lang="en-GB" sz="2400" noProof="0" dirty="0"/>
-              <a:t> </a:t>
-            </a:r>
-            <a:r>
-              <a:rPr lang="en-GB" sz="2400" noProof="0" dirty="0" err="1"/>
-              <a:t>della</a:t>
-            </a:r>
-            <a:r>
-              <a:rPr lang="en-GB" sz="2400" noProof="0" dirty="0"/>
-              <a:t> </a:t>
-            </a:r>
-            <a:r>
-              <a:rPr lang="en-GB" sz="2400" noProof="0" dirty="0" err="1"/>
-              <a:t>maggiore</a:t>
-            </a:r>
-            <a:r>
-              <a:rPr lang="en-GB" sz="2400" noProof="0" dirty="0"/>
-              <a:t> </a:t>
-            </a:r>
-            <a:r>
-              <a:rPr lang="en-GB" sz="2400" noProof="0" dirty="0" err="1"/>
-              <a:t>temperatura</a:t>
-            </a:r>
-            <a:r>
-              <a:rPr lang="en-GB" sz="2400" noProof="0" dirty="0"/>
-              <a:t> </a:t>
-            </a:r>
-            <a:r>
-              <a:rPr lang="en-GB" sz="2400" noProof="0" dirty="0" err="1"/>
-              <a:t>della</a:t>
-            </a:r>
-            <a:r>
-              <a:rPr lang="en-GB" sz="2400" noProof="0" dirty="0"/>
-              <a:t> corona</a:t>
             </a:r>
           </a:p>
         </p:txBody>
@@ -8548,7 +8959,7 @@
 </p:sld>
 </file>
 
-<file path=ppt/slides/slide15.xml><?xml version="1.0" encoding="utf-8"?>
+<file path=ppt/slides/slide17.xml><?xml version="1.0" encoding="utf-8"?>
 <p:sld xmlns:a="http://schemas.openxmlformats.org/drawingml/2006/main" xmlns:r="http://schemas.openxmlformats.org/officeDocument/2006/relationships" xmlns:p="http://schemas.openxmlformats.org/presentationml/2006/main">
   <p:cSld>
     <p:spTree>
@@ -8753,7 +9164,7 @@
 </p:sld>
 </file>
 
-<file path=ppt/slides/slide16.xml><?xml version="1.0" encoding="utf-8"?>
+<file path=ppt/slides/slide18.xml><?xml version="1.0" encoding="utf-8"?>
 <p:sld xmlns:a="http://schemas.openxmlformats.org/drawingml/2006/main" xmlns:r="http://schemas.openxmlformats.org/officeDocument/2006/relationships" xmlns:p="http://schemas.openxmlformats.org/presentationml/2006/main">
   <p:cSld>
     <p:spTree>
@@ -14083,7 +14494,7 @@
         </p:nvSpPr>
         <p:spPr>
           <a:xfrm>
-            <a:off x="791110" y="2280863"/>
+            <a:off x="7071590" y="1330571"/>
             <a:ext cx="2969232" cy="369332"/>
           </a:xfrm>
           <a:prstGeom prst="rect">
@@ -14118,7 +14529,7 @@
         </p:nvSpPr>
         <p:spPr>
           <a:xfrm>
-            <a:off x="4475199" y="2280863"/>
+            <a:off x="6789051" y="1848677"/>
             <a:ext cx="3534310" cy="369332"/>
           </a:xfrm>
           <a:prstGeom prst="rect">
@@ -14147,94 +14558,146 @@
           </a:p>
         </p:txBody>
       </p:sp>
-      <mc:AlternateContent xmlns:mc="http://schemas.openxmlformats.org/markup-compatibility/2006" xmlns:a14="http://schemas.microsoft.com/office/drawing/2010/main">
-        <mc:Choice Requires="a14">
-          <p:sp>
-            <p:nvSpPr>
-              <p:cNvPr id="14" name="CasellaDiTesto 13">
-                <a:extLst>
-                  <a:ext uri="{FF2B5EF4-FFF2-40B4-BE49-F238E27FC236}">
-                    <a16:creationId xmlns:a16="http://schemas.microsoft.com/office/drawing/2014/main" id="{BC4AC2BC-522C-CF7C-A8BC-2F88B1C1C828}"/>
-                  </a:ext>
-                </a:extLst>
-              </p:cNvPr>
-              <p:cNvSpPr txBox="1"/>
-              <p:nvPr/>
-            </p:nvSpPr>
-            <p:spPr>
-              <a:xfrm>
-                <a:off x="2024009" y="3688422"/>
-                <a:ext cx="4654193" cy="923330"/>
-              </a:xfrm>
-              <a:prstGeom prst="rect">
-                <a:avLst/>
-              </a:prstGeom>
-              <a:noFill/>
-            </p:spPr>
-            <p:txBody>
-              <a:bodyPr wrap="square" rtlCol="0">
-                <a:spAutoFit/>
-              </a:bodyPr>
-              <a:lstStyle/>
-              <a:p>
-                <a:pPr marL="285750" indent="-285750">
-                  <a:buFont typeface="Arial" panose="020B0604020202020204" pitchFamily="34" charset="0"/>
-                  <a:buChar char="•"/>
-                </a:pPr>
-                <a:r>
-                  <a:rPr lang="it-IT" dirty="0"/>
-                  <a:t>Sample a </a:t>
-                </a:r>
-                <a14:m>
-                  <m:oMath xmlns:m="http://schemas.openxmlformats.org/officeDocument/2006/math">
-                    <m:sSub>
-                      <m:sSubPr>
-                        <m:ctrlPr>
-                          <a:rPr lang="it-IT" i="1" dirty="0" smtClean="0">
-                            <a:latin typeface="Cambria Math" panose="02040503050406030204" pitchFamily="18" charset="0"/>
-                          </a:rPr>
-                        </m:ctrlPr>
-                      </m:sSubPr>
-                      <m:e>
-                        <m:r>
-                          <a:rPr lang="it-IT" i="1" dirty="0" smtClean="0">
-                            <a:latin typeface="Cambria Math" panose="02040503050406030204" pitchFamily="18" charset="0"/>
-                          </a:rPr>
-                          <m:t>𝜃</m:t>
-                        </m:r>
-                      </m:e>
-                      <m:sub>
-                        <m:r>
-                          <a:rPr lang="it-IT" i="1" dirty="0" err="1">
-                            <a:latin typeface="Cambria Math" panose="02040503050406030204" pitchFamily="18" charset="0"/>
-                          </a:rPr>
-                          <m:t>𝑡</m:t>
-                        </m:r>
-                      </m:sub>
-                    </m:sSub>
-                  </m:oMath>
-                </a14:m>
-                <a:r>
-                  <a:rPr lang="it-IT" dirty="0"/>
-                  <a:t> from </a:t>
-                </a:r>
-                <a14:m>
-                  <m:oMath xmlns:m="http://schemas.openxmlformats.org/officeDocument/2006/math">
-                    <m:r>
-                      <a:rPr lang="it-IT" i="1" dirty="0" smtClean="0">
-                        <a:latin typeface="Cambria Math" panose="02040503050406030204" pitchFamily="18" charset="0"/>
-                      </a:rPr>
-                      <m:t>𝑞</m:t>
-                    </m:r>
-                    <m:d>
-                      <m:dPr>
-                        <m:ctrlPr>
-                          <a:rPr lang="it-IT" i="1" dirty="0" smtClean="0">
-                            <a:latin typeface="Cambria Math" panose="02040503050406030204" pitchFamily="18" charset="0"/>
-                          </a:rPr>
-                        </m:ctrlPr>
-                      </m:dPr>
-                      <m:e>
+      <p:grpSp>
+        <p:nvGrpSpPr>
+          <p:cNvPr id="7" name="Gruppo 6">
+            <a:extLst>
+              <a:ext uri="{FF2B5EF4-FFF2-40B4-BE49-F238E27FC236}">
+                <a16:creationId xmlns:a16="http://schemas.microsoft.com/office/drawing/2014/main" id="{946C42DD-B232-038E-21BD-8D5EEE795BA1}"/>
+              </a:ext>
+            </a:extLst>
+          </p:cNvPr>
+          <p:cNvGrpSpPr/>
+          <p:nvPr/>
+        </p:nvGrpSpPr>
+        <p:grpSpPr>
+          <a:xfrm>
+            <a:off x="561427" y="2800792"/>
+            <a:ext cx="4972692" cy="3339101"/>
+            <a:chOff x="561427" y="2800792"/>
+            <a:chExt cx="4972692" cy="3339101"/>
+          </a:xfrm>
+        </p:grpSpPr>
+        <p:sp>
+          <p:nvSpPr>
+            <p:cNvPr id="6" name="Rettangolo con angoli arrotondati 5">
+              <a:extLst>
+                <a:ext uri="{FF2B5EF4-FFF2-40B4-BE49-F238E27FC236}">
+                  <a16:creationId xmlns:a16="http://schemas.microsoft.com/office/drawing/2014/main" id="{E1A0B8FE-DF38-0332-111E-C639C0E0DEB7}"/>
+                </a:ext>
+              </a:extLst>
+            </p:cNvPr>
+            <p:cNvSpPr/>
+            <p:nvPr/>
+          </p:nvSpPr>
+          <p:spPr>
+            <a:xfrm>
+              <a:off x="561427" y="2800792"/>
+              <a:ext cx="4972692" cy="3339101"/>
+            </a:xfrm>
+            <a:prstGeom prst="roundRect">
+              <a:avLst/>
+            </a:prstGeom>
+            <a:solidFill>
+              <a:schemeClr val="accent2">
+                <a:lumMod val="60000"/>
+                <a:lumOff val="40000"/>
+              </a:schemeClr>
+            </a:solidFill>
+            <a:ln w="19050">
+              <a:solidFill>
+                <a:schemeClr val="tx2"/>
+              </a:solidFill>
+            </a:ln>
+          </p:spPr>
+          <p:style>
+            <a:lnRef idx="2">
+              <a:schemeClr val="accent1">
+                <a:shade val="15000"/>
+              </a:schemeClr>
+            </a:lnRef>
+            <a:fillRef idx="1">
+              <a:schemeClr val="accent1"/>
+            </a:fillRef>
+            <a:effectRef idx="0">
+              <a:schemeClr val="accent1"/>
+            </a:effectRef>
+            <a:fontRef idx="minor">
+              <a:schemeClr val="lt1"/>
+            </a:fontRef>
+          </p:style>
+          <p:txBody>
+            <a:bodyPr rtlCol="0" anchor="ctr"/>
+            <a:lstStyle/>
+            <a:p>
+              <a:pPr algn="ctr"/>
+              <a:endParaRPr lang="it-IT"/>
+            </a:p>
+          </p:txBody>
+        </p:sp>
+        <p:grpSp>
+          <p:nvGrpSpPr>
+            <p:cNvPr id="5" name="Gruppo 4">
+              <a:extLst>
+                <a:ext uri="{FF2B5EF4-FFF2-40B4-BE49-F238E27FC236}">
+                  <a16:creationId xmlns:a16="http://schemas.microsoft.com/office/drawing/2014/main" id="{C9398639-BF95-06D2-C975-337D3707176F}"/>
+                </a:ext>
+              </a:extLst>
+            </p:cNvPr>
+            <p:cNvGrpSpPr/>
+            <p:nvPr/>
+          </p:nvGrpSpPr>
+          <p:grpSpPr>
+            <a:xfrm>
+              <a:off x="656865" y="2882993"/>
+              <a:ext cx="4781817" cy="3174698"/>
+              <a:chOff x="642938" y="2402526"/>
+              <a:chExt cx="4781817" cy="3174698"/>
+            </a:xfrm>
+          </p:grpSpPr>
+          <mc:AlternateContent xmlns:mc="http://schemas.openxmlformats.org/markup-compatibility/2006" xmlns:a14="http://schemas.microsoft.com/office/drawing/2010/main">
+            <mc:Choice Requires="a14">
+              <p:sp>
+                <p:nvSpPr>
+                  <p:cNvPr id="14" name="CasellaDiTesto 13">
+                    <a:extLst>
+                      <a:ext uri="{FF2B5EF4-FFF2-40B4-BE49-F238E27FC236}">
+                        <a16:creationId xmlns:a16="http://schemas.microsoft.com/office/drawing/2014/main" id="{BC4AC2BC-522C-CF7C-A8BC-2F88B1C1C828}"/>
+                      </a:ext>
+                    </a:extLst>
+                  </p:cNvPr>
+                  <p:cNvSpPr txBox="1"/>
+                  <p:nvPr/>
+                </p:nvSpPr>
+                <p:spPr>
+                  <a:xfrm>
+                    <a:off x="1282103" y="2968316"/>
+                    <a:ext cx="3503487" cy="923330"/>
+                  </a:xfrm>
+                  <a:prstGeom prst="rect">
+                    <a:avLst/>
+                  </a:prstGeom>
+                  <a:noFill/>
+                  <a:ln>
+                    <a:noFill/>
+                  </a:ln>
+                </p:spPr>
+                <p:txBody>
+                  <a:bodyPr wrap="square" rtlCol="0">
+                    <a:spAutoFit/>
+                  </a:bodyPr>
+                  <a:lstStyle/>
+                  <a:p>
+                    <a:pPr marL="285750" indent="-285750">
+                      <a:buFont typeface="Arial" panose="020B0604020202020204" pitchFamily="34" charset="0"/>
+                      <a:buChar char="•"/>
+                    </a:pPr>
+                    <a:r>
+                      <a:rPr lang="it-IT" dirty="0"/>
+                      <a:t>Sample a </a:t>
+                    </a:r>
+                    <a14:m>
+                      <m:oMath xmlns:m="http://schemas.openxmlformats.org/officeDocument/2006/math">
                         <m:sSub>
                           <m:sSubPr>
                             <m:ctrlPr>
@@ -14253,83 +14716,1072 @@
                           </m:e>
                           <m:sub>
                             <m:r>
+                              <a:rPr lang="it-IT" i="1" dirty="0" err="1">
+                                <a:latin typeface="Cambria Math" panose="02040503050406030204" pitchFamily="18" charset="0"/>
+                              </a:rPr>
+                              <m:t>𝑡</m:t>
+                            </m:r>
+                          </m:sub>
+                        </m:sSub>
+                      </m:oMath>
+                    </a14:m>
+                    <a:r>
+                      <a:rPr lang="it-IT" dirty="0"/>
+                      <a:t> from </a:t>
+                    </a:r>
+                    <a14:m>
+                      <m:oMath xmlns:m="http://schemas.openxmlformats.org/officeDocument/2006/math">
+                        <m:r>
+                          <a:rPr lang="it-IT" i="1" dirty="0" smtClean="0">
+                            <a:latin typeface="Cambria Math" panose="02040503050406030204" pitchFamily="18" charset="0"/>
+                          </a:rPr>
+                          <m:t>𝑞</m:t>
+                        </m:r>
+                        <m:d>
+                          <m:dPr>
+                            <m:ctrlPr>
                               <a:rPr lang="it-IT" i="1" dirty="0" smtClean="0">
                                 <a:latin typeface="Cambria Math" panose="02040503050406030204" pitchFamily="18" charset="0"/>
                               </a:rPr>
-                              <m:t>0</m:t>
+                            </m:ctrlPr>
+                          </m:dPr>
+                          <m:e>
+                            <m:sSub>
+                              <m:sSubPr>
+                                <m:ctrlPr>
+                                  <a:rPr lang="it-IT" i="1" dirty="0" smtClean="0">
+                                    <a:latin typeface="Cambria Math" panose="02040503050406030204" pitchFamily="18" charset="0"/>
+                                  </a:rPr>
+                                </m:ctrlPr>
+                              </m:sSubPr>
+                              <m:e>
+                                <m:r>
+                                  <a:rPr lang="it-IT" i="1" dirty="0" smtClean="0">
+                                    <a:latin typeface="Cambria Math" panose="02040503050406030204" pitchFamily="18" charset="0"/>
+                                  </a:rPr>
+                                  <m:t>𝜃</m:t>
+                                </m:r>
+                              </m:e>
+                              <m:sub>
+                                <m:r>
+                                  <a:rPr lang="it-IT" i="1" dirty="0" smtClean="0">
+                                    <a:latin typeface="Cambria Math" panose="02040503050406030204" pitchFamily="18" charset="0"/>
+                                  </a:rPr>
+                                  <m:t>0</m:t>
+                                </m:r>
+                              </m:sub>
+                            </m:sSub>
+                          </m:e>
+                        </m:d>
+                      </m:oMath>
+                    </a14:m>
+                    <a:endParaRPr lang="it-IT" dirty="0"/>
+                  </a:p>
+                  <a:p>
+                    <a:pPr marL="285750" indent="-285750">
+                      <a:buFont typeface="Arial" panose="020B0604020202020204" pitchFamily="34" charset="0"/>
+                      <a:buChar char="•"/>
+                    </a:pPr>
+                    <a:r>
+                      <a:rPr lang="it-IT" dirty="0"/>
+                      <a:t>Compute the </a:t>
+                    </a:r>
+                    <a:r>
+                      <a:rPr lang="it-IT" dirty="0" err="1"/>
+                      <a:t>posterior</a:t>
+                    </a:r>
+                    <a:r>
+                      <a:rPr lang="it-IT" dirty="0"/>
+                      <a:t> on </a:t>
+                    </a:r>
+                    <a14:m>
+                      <m:oMath xmlns:m="http://schemas.openxmlformats.org/officeDocument/2006/math">
+                        <m:sSub>
+                          <m:sSubPr>
+                            <m:ctrlPr>
+                              <a:rPr lang="it-IT" i="1" dirty="0" smtClean="0">
+                                <a:latin typeface="Cambria Math" panose="02040503050406030204" pitchFamily="18" charset="0"/>
+                              </a:rPr>
+                            </m:ctrlPr>
+                          </m:sSubPr>
+                          <m:e>
+                            <m:r>
+                              <a:rPr lang="it-IT" i="1" dirty="0" smtClean="0">
+                                <a:latin typeface="Cambria Math" panose="02040503050406030204" pitchFamily="18" charset="0"/>
+                              </a:rPr>
+                              <m:t>𝜃</m:t>
+                            </m:r>
+                          </m:e>
+                          <m:sub>
+                            <m:r>
+                              <a:rPr lang="it-IT" i="1" dirty="0" err="1">
+                                <a:latin typeface="Cambria Math" panose="02040503050406030204" pitchFamily="18" charset="0"/>
+                              </a:rPr>
+                              <m:t>𝑡</m:t>
                             </m:r>
                           </m:sub>
                         </m:sSub>
-                      </m:e>
-                    </m:d>
-                  </m:oMath>
-                </a14:m>
-                <a:endParaRPr lang="it-IT" dirty="0"/>
-              </a:p>
-              <a:p>
-                <a:pPr marL="285750" indent="-285750">
-                  <a:buFont typeface="Arial" panose="020B0604020202020204" pitchFamily="34" charset="0"/>
-                  <a:buChar char="•"/>
-                </a:pPr>
-                <a:r>
-                  <a:rPr lang="it-IT" dirty="0"/>
-                  <a:t>Compute the </a:t>
-                </a:r>
-                <a:r>
-                  <a:rPr lang="it-IT" dirty="0" err="1"/>
-                  <a:t>posterior</a:t>
-                </a:r>
-                <a:r>
-                  <a:rPr lang="it-IT" dirty="0"/>
-                  <a:t> on </a:t>
-                </a:r>
-                <a14:m>
-                  <m:oMath xmlns:m="http://schemas.openxmlformats.org/officeDocument/2006/math">
-                    <m:sSub>
-                      <m:sSubPr>
-                        <m:ctrlPr>
-                          <a:rPr lang="it-IT" i="1" dirty="0" smtClean="0">
-                            <a:latin typeface="Cambria Math" panose="02040503050406030204" pitchFamily="18" charset="0"/>
-                          </a:rPr>
-                        </m:ctrlPr>
-                      </m:sSubPr>
-                      <m:e>
+                      </m:oMath>
+                    </a14:m>
+                    <a:endParaRPr lang="it-IT" dirty="0"/>
+                  </a:p>
+                  <a:p>
+                    <a:pPr marL="285750" indent="-285750">
+                      <a:buFont typeface="Arial" panose="020B0604020202020204" pitchFamily="34" charset="0"/>
+                      <a:buChar char="•"/>
+                    </a:pPr>
+                    <a:r>
+                      <a:rPr lang="it-IT" dirty="0"/>
+                      <a:t>Check </a:t>
+                    </a:r>
+                    <a:r>
+                      <a:rPr lang="it-IT" dirty="0" err="1"/>
+                      <a:t>acceptance</a:t>
+                    </a:r>
+                    <a:r>
+                      <a:rPr lang="it-IT" dirty="0"/>
+                      <a:t> rule</a:t>
+                    </a:r>
+                  </a:p>
+                </p:txBody>
+              </p:sp>
+            </mc:Choice>
+            <mc:Fallback xmlns="">
+              <p:sp>
+                <p:nvSpPr>
+                  <p:cNvPr id="14" name="CasellaDiTesto 13">
+                    <a:extLst>
+                      <a:ext uri="{FF2B5EF4-FFF2-40B4-BE49-F238E27FC236}">
+                        <a16:creationId xmlns:a16="http://schemas.microsoft.com/office/drawing/2014/main" id="{BC4AC2BC-522C-CF7C-A8BC-2F88B1C1C828}"/>
+                      </a:ext>
+                    </a:extLst>
+                  </p:cNvPr>
+                  <p:cNvSpPr txBox="1">
+                    <a:spLocks noRot="1" noChangeAspect="1" noMove="1" noResize="1" noEditPoints="1" noAdjustHandles="1" noChangeArrowheads="1" noChangeShapeType="1" noTextEdit="1"/>
+                  </p:cNvSpPr>
+                  <p:nvPr/>
+                </p:nvSpPr>
+                <p:spPr>
+                  <a:xfrm>
+                    <a:off x="1282103" y="2968316"/>
+                    <a:ext cx="3503487" cy="923330"/>
+                  </a:xfrm>
+                  <a:prstGeom prst="rect">
+                    <a:avLst/>
+                  </a:prstGeom>
+                  <a:blipFill>
+                    <a:blip r:embed="rId2"/>
+                    <a:stretch>
+                      <a:fillRect l="-1220" t="-3974" b="-9934"/>
+                    </a:stretch>
+                  </a:blipFill>
+                  <a:ln>
+                    <a:noFill/>
+                  </a:ln>
+                </p:spPr>
+                <p:txBody>
+                  <a:bodyPr/>
+                  <a:lstStyle/>
+                  <a:p>
+                    <a:r>
+                      <a:rPr lang="it-IT">
+                        <a:noFill/>
+                      </a:rPr>
+                      <a:t> </a:t>
+                    </a:r>
+                  </a:p>
+                </p:txBody>
+              </p:sp>
+            </mc:Fallback>
+          </mc:AlternateContent>
+          <p:grpSp>
+            <p:nvGrpSpPr>
+              <p:cNvPr id="3" name="Gruppo 2">
+                <a:extLst>
+                  <a:ext uri="{FF2B5EF4-FFF2-40B4-BE49-F238E27FC236}">
+                    <a16:creationId xmlns:a16="http://schemas.microsoft.com/office/drawing/2014/main" id="{68E45162-7B70-551D-EEDD-0C813345039A}"/>
+                  </a:ext>
+                </a:extLst>
+              </p:cNvPr>
+              <p:cNvGrpSpPr/>
+              <p:nvPr/>
+            </p:nvGrpSpPr>
+            <p:grpSpPr>
+              <a:xfrm>
+                <a:off x="864688" y="4088104"/>
+                <a:ext cx="4338316" cy="646331"/>
+                <a:chOff x="740543" y="4035967"/>
+                <a:chExt cx="4338316" cy="646331"/>
+              </a:xfrm>
+            </p:grpSpPr>
+            <mc:AlternateContent xmlns:mc="http://schemas.openxmlformats.org/markup-compatibility/2006" xmlns:a14="http://schemas.microsoft.com/office/drawing/2010/main">
+              <mc:Choice Requires="a14">
+                <p:sp>
+                  <p:nvSpPr>
+                    <p:cNvPr id="15" name="CasellaDiTesto 14">
+                      <a:extLst>
+                        <a:ext uri="{FF2B5EF4-FFF2-40B4-BE49-F238E27FC236}">
+                          <a16:creationId xmlns:a16="http://schemas.microsoft.com/office/drawing/2014/main" id="{A8346508-EC61-0A86-CF73-51AB617DF50E}"/>
+                        </a:ext>
+                      </a:extLst>
+                    </p:cNvPr>
+                    <p:cNvSpPr txBox="1"/>
+                    <p:nvPr/>
+                  </p:nvSpPr>
+                  <p:spPr>
+                    <a:xfrm>
+                      <a:off x="740543" y="4035967"/>
+                      <a:ext cx="1684962" cy="646331"/>
+                    </a:xfrm>
+                    <a:prstGeom prst="rect">
+                      <a:avLst/>
+                    </a:prstGeom>
+                    <a:noFill/>
+                    <a:ln>
+                      <a:noFill/>
+                    </a:ln>
+                  </p:spPr>
+                  <p:txBody>
+                    <a:bodyPr wrap="square" rtlCol="0">
+                      <a:spAutoFit/>
+                    </a:bodyPr>
+                    <a:lstStyle/>
+                    <a:p>
+                      <a:r>
+                        <a:rPr lang="it-IT" dirty="0" err="1"/>
+                        <a:t>If</a:t>
+                      </a:r>
+                      <a:r>
+                        <a:rPr lang="it-IT" dirty="0"/>
+                        <a:t> </a:t>
+                      </a:r>
+                      <a:r>
+                        <a:rPr lang="it-IT" dirty="0" err="1"/>
+                        <a:t>true</a:t>
+                      </a:r>
+                      <a:r>
+                        <a:rPr lang="it-IT" dirty="0"/>
+                        <a:t> </a:t>
+                      </a:r>
+                      <a:r>
+                        <a:rPr lang="it-IT" dirty="0" err="1"/>
+                        <a:t>move</a:t>
+                      </a:r>
+                      <a:r>
+                        <a:rPr lang="it-IT" dirty="0"/>
+                        <a:t> to </a:t>
+                      </a:r>
+                      <a14:m>
+                        <m:oMath xmlns:m="http://schemas.openxmlformats.org/officeDocument/2006/math">
+                          <m:sSub>
+                            <m:sSubPr>
+                              <m:ctrlPr>
+                                <a:rPr lang="it-IT" i="1" dirty="0" smtClean="0">
+                                  <a:latin typeface="Cambria Math" panose="02040503050406030204" pitchFamily="18" charset="0"/>
+                                </a:rPr>
+                              </m:ctrlPr>
+                            </m:sSubPr>
+                            <m:e>
+                              <m:r>
+                                <a:rPr lang="it-IT" i="1" dirty="0" smtClean="0">
+                                  <a:latin typeface="Cambria Math" panose="02040503050406030204" pitchFamily="18" charset="0"/>
+                                </a:rPr>
+                                <m:t>𝜃</m:t>
+                              </m:r>
+                            </m:e>
+                            <m:sub>
+                              <m:r>
+                                <a:rPr lang="it-IT" i="1" dirty="0" smtClean="0">
+                                  <a:latin typeface="Cambria Math" panose="02040503050406030204" pitchFamily="18" charset="0"/>
+                                </a:rPr>
+                                <m:t>0</m:t>
+                              </m:r>
+                            </m:sub>
+                          </m:sSub>
+                          <m:r>
+                            <a:rPr lang="it-IT" i="1" dirty="0" smtClean="0">
+                              <a:latin typeface="Cambria Math" panose="02040503050406030204" pitchFamily="18" charset="0"/>
+                            </a:rPr>
+                            <m:t>=</m:t>
+                          </m:r>
+                          <m:sSub>
+                            <m:sSubPr>
+                              <m:ctrlPr>
+                                <a:rPr lang="it-IT" i="1" dirty="0" err="1" smtClean="0">
+                                  <a:latin typeface="Cambria Math" panose="02040503050406030204" pitchFamily="18" charset="0"/>
+                                </a:rPr>
+                              </m:ctrlPr>
+                            </m:sSubPr>
+                            <m:e>
+                              <m:r>
+                                <a:rPr lang="it-IT" i="1" dirty="0" smtClean="0">
+                                  <a:latin typeface="Cambria Math" panose="02040503050406030204" pitchFamily="18" charset="0"/>
+                                </a:rPr>
+                                <m:t>𝜃</m:t>
+                              </m:r>
+                            </m:e>
+                            <m:sub>
+                              <m:r>
+                                <a:rPr lang="it-IT" i="1" dirty="0" err="1" smtClean="0">
+                                  <a:latin typeface="Cambria Math" panose="02040503050406030204" pitchFamily="18" charset="0"/>
+                                </a:rPr>
+                                <m:t>𝑡</m:t>
+                              </m:r>
+                            </m:sub>
+                          </m:sSub>
+                        </m:oMath>
+                      </a14:m>
+                      <a:endParaRPr lang="it-IT" dirty="0"/>
+                    </a:p>
+                  </p:txBody>
+                </p:sp>
+              </mc:Choice>
+              <mc:Fallback xmlns="">
+                <p:sp>
+                  <p:nvSpPr>
+                    <p:cNvPr id="15" name="CasellaDiTesto 14">
+                      <a:extLst>
+                        <a:ext uri="{FF2B5EF4-FFF2-40B4-BE49-F238E27FC236}">
+                          <a16:creationId xmlns:a16="http://schemas.microsoft.com/office/drawing/2014/main" id="{A8346508-EC61-0A86-CF73-51AB617DF50E}"/>
+                        </a:ext>
+                      </a:extLst>
+                    </p:cNvPr>
+                    <p:cNvSpPr txBox="1">
+                      <a:spLocks noRot="1" noChangeAspect="1" noMove="1" noResize="1" noEditPoints="1" noAdjustHandles="1" noChangeArrowheads="1" noChangeShapeType="1" noTextEdit="1"/>
+                    </p:cNvSpPr>
+                    <p:nvPr/>
+                  </p:nvSpPr>
+                  <p:spPr>
+                    <a:xfrm>
+                      <a:off x="740543" y="4035967"/>
+                      <a:ext cx="1684962" cy="646331"/>
+                    </a:xfrm>
+                    <a:prstGeom prst="rect">
+                      <a:avLst/>
+                    </a:prstGeom>
+                    <a:blipFill>
+                      <a:blip r:embed="rId3"/>
+                      <a:stretch>
+                        <a:fillRect l="-2888" t="-4717" b="-14151"/>
+                      </a:stretch>
+                    </a:blipFill>
+                    <a:ln>
+                      <a:noFill/>
+                    </a:ln>
+                  </p:spPr>
+                  <p:txBody>
+                    <a:bodyPr/>
+                    <a:lstStyle/>
+                    <a:p>
+                      <a:r>
+                        <a:rPr lang="it-IT">
+                          <a:noFill/>
+                        </a:rPr>
+                        <a:t> </a:t>
+                      </a:r>
+                    </a:p>
+                  </p:txBody>
+                </p:sp>
+              </mc:Fallback>
+            </mc:AlternateContent>
+            <mc:AlternateContent xmlns:mc="http://schemas.openxmlformats.org/markup-compatibility/2006" xmlns:a14="http://schemas.microsoft.com/office/drawing/2010/main">
+              <mc:Choice Requires="a14">
+                <p:sp>
+                  <p:nvSpPr>
+                    <p:cNvPr id="16" name="CasellaDiTesto 15">
+                      <a:extLst>
+                        <a:ext uri="{FF2B5EF4-FFF2-40B4-BE49-F238E27FC236}">
+                          <a16:creationId xmlns:a16="http://schemas.microsoft.com/office/drawing/2014/main" id="{1A45A8E9-92A5-F272-C0D9-0FF6E89C39A8}"/>
+                        </a:ext>
+                      </a:extLst>
+                    </p:cNvPr>
+                    <p:cNvSpPr txBox="1"/>
+                    <p:nvPr/>
+                  </p:nvSpPr>
+                  <p:spPr>
+                    <a:xfrm>
+                      <a:off x="3008616" y="4174466"/>
+                      <a:ext cx="2070243" cy="369332"/>
+                    </a:xfrm>
+                    <a:prstGeom prst="rect">
+                      <a:avLst/>
+                    </a:prstGeom>
+                    <a:noFill/>
+                    <a:ln>
+                      <a:noFill/>
+                    </a:ln>
+                  </p:spPr>
+                  <p:txBody>
+                    <a:bodyPr wrap="square" rtlCol="0">
+                      <a:spAutoFit/>
+                    </a:bodyPr>
+                    <a:lstStyle/>
+                    <a:p>
+                      <a:r>
+                        <a:rPr lang="it-IT" dirty="0" err="1"/>
+                        <a:t>If</a:t>
+                      </a:r>
+                      <a:r>
+                        <a:rPr lang="it-IT" dirty="0"/>
+                        <a:t> false stay </a:t>
+                      </a:r>
+                      <a:r>
+                        <a:rPr lang="it-IT" dirty="0" err="1"/>
+                        <a:t>at</a:t>
+                      </a:r>
+                      <a:r>
+                        <a:rPr lang="it-IT" dirty="0"/>
+                        <a:t> </a:t>
+                      </a:r>
+                      <a14:m>
+                        <m:oMath xmlns:m="http://schemas.openxmlformats.org/officeDocument/2006/math">
+                          <m:sSub>
+                            <m:sSubPr>
+                              <m:ctrlPr>
+                                <a:rPr lang="it-IT" i="1" dirty="0" smtClean="0">
+                                  <a:latin typeface="Cambria Math" panose="02040503050406030204" pitchFamily="18" charset="0"/>
+                                </a:rPr>
+                              </m:ctrlPr>
+                            </m:sSubPr>
+                            <m:e>
+                              <m:r>
+                                <a:rPr lang="it-IT" i="1" dirty="0" smtClean="0">
+                                  <a:latin typeface="Cambria Math" panose="02040503050406030204" pitchFamily="18" charset="0"/>
+                                </a:rPr>
+                                <m:t>𝜃</m:t>
+                              </m:r>
+                            </m:e>
+                            <m:sub>
+                              <m:r>
+                                <a:rPr lang="it-IT" i="1" dirty="0" smtClean="0">
+                                  <a:latin typeface="Cambria Math" panose="02040503050406030204" pitchFamily="18" charset="0"/>
+                                </a:rPr>
+                                <m:t>0</m:t>
+                              </m:r>
+                            </m:sub>
+                          </m:sSub>
+                        </m:oMath>
+                      </a14:m>
+                      <a:endParaRPr lang="it-IT" dirty="0"/>
+                    </a:p>
+                  </p:txBody>
+                </p:sp>
+              </mc:Choice>
+              <mc:Fallback xmlns="">
+                <p:sp>
+                  <p:nvSpPr>
+                    <p:cNvPr id="16" name="CasellaDiTesto 15">
+                      <a:extLst>
+                        <a:ext uri="{FF2B5EF4-FFF2-40B4-BE49-F238E27FC236}">
+                          <a16:creationId xmlns:a16="http://schemas.microsoft.com/office/drawing/2014/main" id="{1A45A8E9-92A5-F272-C0D9-0FF6E89C39A8}"/>
+                        </a:ext>
+                      </a:extLst>
+                    </p:cNvPr>
+                    <p:cNvSpPr txBox="1">
+                      <a:spLocks noRot="1" noChangeAspect="1" noMove="1" noResize="1" noEditPoints="1" noAdjustHandles="1" noChangeArrowheads="1" noChangeShapeType="1" noTextEdit="1"/>
+                    </p:cNvSpPr>
+                    <p:nvPr/>
+                  </p:nvSpPr>
+                  <p:spPr>
+                    <a:xfrm>
+                      <a:off x="3008616" y="4174466"/>
+                      <a:ext cx="2070243" cy="369332"/>
+                    </a:xfrm>
+                    <a:prstGeom prst="rect">
+                      <a:avLst/>
+                    </a:prstGeom>
+                    <a:blipFill>
+                      <a:blip r:embed="rId4"/>
+                      <a:stretch>
+                        <a:fillRect l="-2353" t="-8197" b="-24590"/>
+                      </a:stretch>
+                    </a:blipFill>
+                    <a:ln>
+                      <a:noFill/>
+                    </a:ln>
+                  </p:spPr>
+                  <p:txBody>
+                    <a:bodyPr/>
+                    <a:lstStyle/>
+                    <a:p>
+                      <a:r>
+                        <a:rPr lang="it-IT">
+                          <a:noFill/>
+                        </a:rPr>
+                        <a:t> </a:t>
+                      </a:r>
+                    </a:p>
+                  </p:txBody>
+                </p:sp>
+              </mc:Fallback>
+            </mc:AlternateContent>
+          </p:grpSp>
+          <mc:AlternateContent xmlns:mc="http://schemas.openxmlformats.org/markup-compatibility/2006" xmlns:a14="http://schemas.microsoft.com/office/drawing/2010/main">
+            <mc:Choice Requires="a14">
+              <p:sp>
+                <p:nvSpPr>
+                  <p:cNvPr id="17" name="CasellaDiTesto 16">
+                    <a:extLst>
+                      <a:ext uri="{FF2B5EF4-FFF2-40B4-BE49-F238E27FC236}">
+                        <a16:creationId xmlns:a16="http://schemas.microsoft.com/office/drawing/2014/main" id="{7F281147-055D-0C36-6BC8-FBB7FEF09A80}"/>
+                      </a:ext>
+                    </a:extLst>
+                  </p:cNvPr>
+                  <p:cNvSpPr txBox="1"/>
+                  <p:nvPr/>
+                </p:nvSpPr>
+                <p:spPr>
+                  <a:xfrm>
+                    <a:off x="642938" y="4930893"/>
+                    <a:ext cx="4781817" cy="646331"/>
+                  </a:xfrm>
+                  <a:prstGeom prst="rect">
+                    <a:avLst/>
+                  </a:prstGeom>
+                  <a:noFill/>
+                  <a:ln>
+                    <a:noFill/>
+                  </a:ln>
+                </p:spPr>
+                <p:txBody>
+                  <a:bodyPr wrap="square" rtlCol="0">
+                    <a:spAutoFit/>
+                  </a:bodyPr>
+                  <a:lstStyle/>
+                  <a:p>
+                    <a:r>
+                      <a:rPr lang="it-IT" dirty="0"/>
+                      <a:t>In </a:t>
+                    </a:r>
+                    <a:r>
+                      <a:rPr lang="it-IT" dirty="0" err="1"/>
+                      <a:t>this</a:t>
+                    </a:r>
+                    <a:r>
+                      <a:rPr lang="it-IT" dirty="0"/>
+                      <a:t> way we </a:t>
+                    </a:r>
+                    <a:r>
+                      <a:rPr lang="it-IT" dirty="0" err="1"/>
+                      <a:t>will</a:t>
+                    </a:r>
+                    <a:r>
+                      <a:rPr lang="it-IT" dirty="0"/>
+                      <a:t> have the </a:t>
+                    </a:r>
+                    <a14:m>
+                      <m:oMath xmlns:m="http://schemas.openxmlformats.org/officeDocument/2006/math">
                         <m:r>
                           <a:rPr lang="it-IT" i="1" dirty="0" smtClean="0">
                             <a:latin typeface="Cambria Math" panose="02040503050406030204" pitchFamily="18" charset="0"/>
                           </a:rPr>
                           <m:t>𝜃</m:t>
                         </m:r>
-                      </m:e>
-                      <m:sub>
-                        <m:r>
-                          <a:rPr lang="it-IT" i="1" dirty="0" err="1">
+                      </m:oMath>
+                    </a14:m>
+                    <a:r>
+                      <a:rPr lang="it-IT" dirty="0"/>
+                      <a:t> with </a:t>
+                    </a:r>
+                    <a:r>
+                      <a:rPr lang="it-IT" dirty="0" err="1"/>
+                      <a:t>higher</a:t>
+                    </a:r>
+                    <a:r>
+                      <a:rPr lang="it-IT" dirty="0"/>
+                      <a:t> </a:t>
+                    </a:r>
+                    <a:r>
+                      <a:rPr lang="it-IT" dirty="0" err="1"/>
+                      <a:t>posterior</a:t>
+                    </a:r>
+                    <a:r>
+                      <a:rPr lang="it-IT" dirty="0"/>
+                      <a:t> more times so more </a:t>
+                    </a:r>
+                    <a:r>
+                      <a:rPr lang="it-IT" dirty="0" err="1"/>
+                      <a:t>probable</a:t>
+                    </a:r>
+                    <a:r>
+                      <a:rPr lang="it-IT" dirty="0"/>
+                      <a:t>! </a:t>
+                    </a:r>
+                  </a:p>
+                </p:txBody>
+              </p:sp>
+            </mc:Choice>
+            <mc:Fallback xmlns="">
+              <p:sp>
+                <p:nvSpPr>
+                  <p:cNvPr id="17" name="CasellaDiTesto 16">
+                    <a:extLst>
+                      <a:ext uri="{FF2B5EF4-FFF2-40B4-BE49-F238E27FC236}">
+                        <a16:creationId xmlns:a16="http://schemas.microsoft.com/office/drawing/2014/main" id="{7F281147-055D-0C36-6BC8-FBB7FEF09A80}"/>
+                      </a:ext>
+                    </a:extLst>
+                  </p:cNvPr>
+                  <p:cNvSpPr txBox="1">
+                    <a:spLocks noRot="1" noChangeAspect="1" noMove="1" noResize="1" noEditPoints="1" noAdjustHandles="1" noChangeArrowheads="1" noChangeShapeType="1" noTextEdit="1"/>
+                  </p:cNvSpPr>
+                  <p:nvPr/>
+                </p:nvSpPr>
+                <p:spPr>
+                  <a:xfrm>
+                    <a:off x="642938" y="4930893"/>
+                    <a:ext cx="4781817" cy="646331"/>
+                  </a:xfrm>
+                  <a:prstGeom prst="rect">
+                    <a:avLst/>
+                  </a:prstGeom>
+                  <a:blipFill>
+                    <a:blip r:embed="rId5"/>
+                    <a:stretch>
+                      <a:fillRect l="-1148" t="-5660" b="-14151"/>
+                    </a:stretch>
+                  </a:blipFill>
+                  <a:ln>
+                    <a:noFill/>
+                  </a:ln>
+                </p:spPr>
+                <p:txBody>
+                  <a:bodyPr/>
+                  <a:lstStyle/>
+                  <a:p>
+                    <a:r>
+                      <a:rPr lang="it-IT">
+                        <a:noFill/>
+                      </a:rPr>
+                      <a:t> </a:t>
+                    </a:r>
+                  </a:p>
+                </p:txBody>
+              </p:sp>
+            </mc:Fallback>
+          </mc:AlternateContent>
+          <p:sp>
+            <p:nvSpPr>
+              <p:cNvPr id="2" name="CasellaDiTesto 1">
+                <a:extLst>
+                  <a:ext uri="{FF2B5EF4-FFF2-40B4-BE49-F238E27FC236}">
+                    <a16:creationId xmlns:a16="http://schemas.microsoft.com/office/drawing/2014/main" id="{75813D49-40A6-C2C2-4605-7CEE31A305CD}"/>
+                  </a:ext>
+                </a:extLst>
+              </p:cNvPr>
+              <p:cNvSpPr txBox="1"/>
+              <p:nvPr/>
+            </p:nvSpPr>
+            <p:spPr>
+              <a:xfrm>
+                <a:off x="2386575" y="2402526"/>
+                <a:ext cx="1294543" cy="369332"/>
+              </a:xfrm>
+              <a:prstGeom prst="rect">
+                <a:avLst/>
+              </a:prstGeom>
+              <a:noFill/>
+              <a:ln>
+                <a:noFill/>
+              </a:ln>
+            </p:spPr>
+            <p:txBody>
+              <a:bodyPr wrap="square" rtlCol="0">
+                <a:spAutoFit/>
+              </a:bodyPr>
+              <a:lstStyle/>
+              <a:p>
+                <a:r>
+                  <a:rPr lang="it-IT" dirty="0"/>
+                  <a:t>Base idea</a:t>
+                </a:r>
+              </a:p>
+            </p:txBody>
+          </p:sp>
+        </p:grpSp>
+      </p:grpSp>
+      <p:sp>
+        <p:nvSpPr>
+          <p:cNvPr id="8" name="CasellaDiTesto 7">
+            <a:extLst>
+              <a:ext uri="{FF2B5EF4-FFF2-40B4-BE49-F238E27FC236}">
+                <a16:creationId xmlns:a16="http://schemas.microsoft.com/office/drawing/2014/main" id="{61CCC5EB-30E8-0FFC-3F1C-39CAC283583D}"/>
+              </a:ext>
+            </a:extLst>
+          </p:cNvPr>
+          <p:cNvSpPr txBox="1"/>
+          <p:nvPr/>
+        </p:nvSpPr>
+        <p:spPr>
+          <a:xfrm>
+            <a:off x="6421348" y="2882993"/>
+            <a:ext cx="3287731" cy="646331"/>
+          </a:xfrm>
+          <a:prstGeom prst="rect">
+            <a:avLst/>
+          </a:prstGeom>
+          <a:noFill/>
+        </p:spPr>
+        <p:txBody>
+          <a:bodyPr wrap="square" rtlCol="0">
+            <a:spAutoFit/>
+          </a:bodyPr>
+          <a:lstStyle/>
+          <a:p>
+            <a:r>
+              <a:rPr lang="it-IT" dirty="0" err="1"/>
+              <a:t>Proposal</a:t>
+            </a:r>
+            <a:r>
+              <a:rPr lang="it-IT" dirty="0"/>
+              <a:t>: multivariate </a:t>
+            </a:r>
+            <a:r>
+              <a:rPr lang="it-IT" dirty="0" err="1"/>
+              <a:t>normal</a:t>
+            </a:r>
+            <a:r>
+              <a:rPr lang="it-IT" dirty="0"/>
+              <a:t>, blind or not</a:t>
+            </a:r>
+          </a:p>
+        </p:txBody>
+      </p:sp>
+      <p:sp>
+        <p:nvSpPr>
+          <p:cNvPr id="9" name="CasellaDiTesto 8">
+            <a:extLst>
+              <a:ext uri="{FF2B5EF4-FFF2-40B4-BE49-F238E27FC236}">
+                <a16:creationId xmlns:a16="http://schemas.microsoft.com/office/drawing/2014/main" id="{12A952C8-5E1B-56F5-C6C0-6C3EA1C18B0E}"/>
+              </a:ext>
+            </a:extLst>
+          </p:cNvPr>
+          <p:cNvSpPr txBox="1"/>
+          <p:nvPr/>
+        </p:nvSpPr>
+        <p:spPr>
+          <a:xfrm>
+            <a:off x="6789051" y="4372113"/>
+            <a:ext cx="2211111" cy="369332"/>
+          </a:xfrm>
+          <a:prstGeom prst="rect">
+            <a:avLst/>
+          </a:prstGeom>
+          <a:noFill/>
+        </p:spPr>
+        <p:txBody>
+          <a:bodyPr wrap="square" rtlCol="0">
+            <a:spAutoFit/>
+          </a:bodyPr>
+          <a:lstStyle/>
+          <a:p>
+            <a:r>
+              <a:rPr lang="it-IT" dirty="0" err="1"/>
+              <a:t>Acceptance</a:t>
+            </a:r>
+            <a:r>
+              <a:rPr lang="it-IT" dirty="0"/>
+              <a:t> rule</a:t>
+            </a:r>
+          </a:p>
+        </p:txBody>
+      </p:sp>
+      <mc:AlternateContent xmlns:mc="http://schemas.openxmlformats.org/markup-compatibility/2006" xmlns:a14="http://schemas.microsoft.com/office/drawing/2010/main">
+        <mc:Choice Requires="a14">
+          <p:sp>
+            <p:nvSpPr>
+              <p:cNvPr id="10" name="CasellaDiTesto 9">
+                <a:extLst>
+                  <a:ext uri="{FF2B5EF4-FFF2-40B4-BE49-F238E27FC236}">
+                    <a16:creationId xmlns:a16="http://schemas.microsoft.com/office/drawing/2014/main" id="{9374EB6B-02FF-46C4-5965-0A5BE147449F}"/>
+                  </a:ext>
+                </a:extLst>
+              </p:cNvPr>
+              <p:cNvSpPr txBox="1"/>
+              <p:nvPr/>
+            </p:nvSpPr>
+            <p:spPr>
+              <a:xfrm>
+                <a:off x="6789051" y="4916711"/>
+                <a:ext cx="1834968" cy="596382"/>
+              </a:xfrm>
+              <a:prstGeom prst="rect">
+                <a:avLst/>
+              </a:prstGeom>
+              <a:noFill/>
+            </p:spPr>
+            <p:txBody>
+              <a:bodyPr wrap="square" rtlCol="0">
+                <a:spAutoFit/>
+              </a:bodyPr>
+              <a:lstStyle/>
+              <a:p>
+                <a14:m>
+                  <m:oMath xmlns:m="http://schemas.openxmlformats.org/officeDocument/2006/math">
+                    <m:f>
+                      <m:fPr>
+                        <m:ctrlPr>
+                          <a:rPr lang="it-IT" i="1" dirty="0" smtClean="0">
                             <a:latin typeface="Cambria Math" panose="02040503050406030204" pitchFamily="18" charset="0"/>
                           </a:rPr>
-                          <m:t>𝑡</m:t>
+                        </m:ctrlPr>
+                      </m:fPr>
+                      <m:num>
+                        <m:r>
+                          <a:rPr lang="it-IT" i="1" dirty="0" smtClean="0">
+                            <a:latin typeface="Cambria Math" panose="02040503050406030204" pitchFamily="18" charset="0"/>
+                          </a:rPr>
+                          <m:t>𝑝</m:t>
                         </m:r>
-                      </m:sub>
-                    </m:sSub>
+                        <m:d>
+                          <m:dPr>
+                            <m:ctrlPr>
+                              <a:rPr lang="it-IT" i="1" dirty="0" smtClean="0">
+                                <a:latin typeface="Cambria Math" panose="02040503050406030204" pitchFamily="18" charset="0"/>
+                              </a:rPr>
+                            </m:ctrlPr>
+                          </m:dPr>
+                          <m:e>
+                            <m:sSub>
+                              <m:sSubPr>
+                                <m:ctrlPr>
+                                  <a:rPr lang="it-IT" i="1" dirty="0" err="1" smtClean="0">
+                                    <a:latin typeface="Cambria Math" panose="02040503050406030204" pitchFamily="18" charset="0"/>
+                                  </a:rPr>
+                                </m:ctrlPr>
+                              </m:sSubPr>
+                              <m:e>
+                                <m:r>
+                                  <a:rPr lang="it-IT" i="1" dirty="0" smtClean="0">
+                                    <a:latin typeface="Cambria Math" panose="02040503050406030204" pitchFamily="18" charset="0"/>
+                                  </a:rPr>
+                                  <m:t>𝜃</m:t>
+                                </m:r>
+                              </m:e>
+                              <m:sub>
+                                <m:r>
+                                  <a:rPr lang="it-IT" i="1" dirty="0" err="1" smtClean="0">
+                                    <a:latin typeface="Cambria Math" panose="02040503050406030204" pitchFamily="18" charset="0"/>
+                                  </a:rPr>
+                                  <m:t>𝑡</m:t>
+                                </m:r>
+                              </m:sub>
+                            </m:sSub>
+                          </m:e>
+                        </m:d>
+                      </m:num>
+                      <m:den>
+                        <m:r>
+                          <a:rPr lang="it-IT" i="1" dirty="0" smtClean="0">
+                            <a:latin typeface="Cambria Math" panose="02040503050406030204" pitchFamily="18" charset="0"/>
+                          </a:rPr>
+                          <m:t>𝑝</m:t>
+                        </m:r>
+                        <m:d>
+                          <m:dPr>
+                            <m:ctrlPr>
+                              <a:rPr lang="it-IT" i="1" dirty="0" smtClean="0">
+                                <a:latin typeface="Cambria Math" panose="02040503050406030204" pitchFamily="18" charset="0"/>
+                              </a:rPr>
+                            </m:ctrlPr>
+                          </m:dPr>
+                          <m:e>
+                            <m:sSub>
+                              <m:sSubPr>
+                                <m:ctrlPr>
+                                  <a:rPr lang="it-IT" i="1" dirty="0" smtClean="0">
+                                    <a:latin typeface="Cambria Math" panose="02040503050406030204" pitchFamily="18" charset="0"/>
+                                  </a:rPr>
+                                </m:ctrlPr>
+                              </m:sSubPr>
+                              <m:e>
+                                <m:r>
+                                  <a:rPr lang="it-IT" i="1" dirty="0" smtClean="0">
+                                    <a:latin typeface="Cambria Math" panose="02040503050406030204" pitchFamily="18" charset="0"/>
+                                  </a:rPr>
+                                  <m:t>𝜃</m:t>
+                                </m:r>
+                              </m:e>
+                              <m:sub>
+                                <m:r>
+                                  <a:rPr lang="it-IT" i="1" dirty="0" smtClean="0">
+                                    <a:latin typeface="Cambria Math" panose="02040503050406030204" pitchFamily="18" charset="0"/>
+                                  </a:rPr>
+                                  <m:t>0</m:t>
+                                </m:r>
+                              </m:sub>
+                            </m:sSub>
+                          </m:e>
+                        </m:d>
+                      </m:den>
+                    </m:f>
+                    <m:f>
+                      <m:fPr>
+                        <m:ctrlPr>
+                          <a:rPr lang="it-IT" i="1" dirty="0" smtClean="0">
+                            <a:latin typeface="Cambria Math" panose="02040503050406030204" pitchFamily="18" charset="0"/>
+                          </a:rPr>
+                        </m:ctrlPr>
+                      </m:fPr>
+                      <m:num>
+                        <m:r>
+                          <a:rPr lang="it-IT" i="1" dirty="0" smtClean="0">
+                            <a:latin typeface="Cambria Math" panose="02040503050406030204" pitchFamily="18" charset="0"/>
+                          </a:rPr>
+                          <m:t>𝑞</m:t>
+                        </m:r>
+                        <m:d>
+                          <m:dPr>
+                            <m:ctrlPr>
+                              <a:rPr lang="it-IT" i="1" dirty="0" smtClean="0">
+                                <a:latin typeface="Cambria Math" panose="02040503050406030204" pitchFamily="18" charset="0"/>
+                              </a:rPr>
+                            </m:ctrlPr>
+                          </m:dPr>
+                          <m:e>
+                            <m:sSub>
+                              <m:sSubPr>
+                                <m:ctrlPr>
+                                  <a:rPr lang="it-IT" i="1" dirty="0" err="1" smtClean="0">
+                                    <a:latin typeface="Cambria Math" panose="02040503050406030204" pitchFamily="18" charset="0"/>
+                                  </a:rPr>
+                                </m:ctrlPr>
+                              </m:sSubPr>
+                              <m:e>
+                                <m:r>
+                                  <a:rPr lang="it-IT" i="1" dirty="0" smtClean="0">
+                                    <a:latin typeface="Cambria Math" panose="02040503050406030204" pitchFamily="18" charset="0"/>
+                                  </a:rPr>
+                                  <m:t>𝜃</m:t>
+                                </m:r>
+                              </m:e>
+                              <m:sub>
+                                <m:r>
+                                  <a:rPr lang="it-IT" i="1" dirty="0" err="1" smtClean="0">
+                                    <a:latin typeface="Cambria Math" panose="02040503050406030204" pitchFamily="18" charset="0"/>
+                                  </a:rPr>
+                                  <m:t>𝑡</m:t>
+                                </m:r>
+                              </m:sub>
+                            </m:sSub>
+                          </m:e>
+                          <m:e>
+                            <m:sSub>
+                              <m:sSubPr>
+                                <m:ctrlPr>
+                                  <a:rPr lang="it-IT" i="1" dirty="0" smtClean="0">
+                                    <a:latin typeface="Cambria Math" panose="02040503050406030204" pitchFamily="18" charset="0"/>
+                                  </a:rPr>
+                                </m:ctrlPr>
+                              </m:sSubPr>
+                              <m:e>
+                                <m:r>
+                                  <a:rPr lang="it-IT" i="1" dirty="0" smtClean="0">
+                                    <a:latin typeface="Cambria Math" panose="02040503050406030204" pitchFamily="18" charset="0"/>
+                                  </a:rPr>
+                                  <m:t>𝜃</m:t>
+                                </m:r>
+                              </m:e>
+                              <m:sub>
+                                <m:r>
+                                  <a:rPr lang="it-IT" i="1" dirty="0" smtClean="0">
+                                    <a:latin typeface="Cambria Math" panose="02040503050406030204" pitchFamily="18" charset="0"/>
+                                  </a:rPr>
+                                  <m:t>0</m:t>
+                                </m:r>
+                              </m:sub>
+                            </m:sSub>
+                          </m:e>
+                        </m:d>
+                      </m:num>
+                      <m:den>
+                        <m:r>
+                          <a:rPr lang="it-IT" i="1" dirty="0" smtClean="0">
+                            <a:latin typeface="Cambria Math" panose="02040503050406030204" pitchFamily="18" charset="0"/>
+                          </a:rPr>
+                          <m:t>𝑞</m:t>
+                        </m:r>
+                        <m:d>
+                          <m:dPr>
+                            <m:ctrlPr>
+                              <a:rPr lang="it-IT" i="1" dirty="0" smtClean="0">
+                                <a:latin typeface="Cambria Math" panose="02040503050406030204" pitchFamily="18" charset="0"/>
+                              </a:rPr>
+                            </m:ctrlPr>
+                          </m:dPr>
+                          <m:e>
+                            <m:sSub>
+                              <m:sSubPr>
+                                <m:ctrlPr>
+                                  <a:rPr lang="it-IT" i="1" dirty="0" smtClean="0">
+                                    <a:latin typeface="Cambria Math" panose="02040503050406030204" pitchFamily="18" charset="0"/>
+                                  </a:rPr>
+                                </m:ctrlPr>
+                              </m:sSubPr>
+                              <m:e>
+                                <m:r>
+                                  <a:rPr lang="it-IT" i="1" dirty="0" smtClean="0">
+                                    <a:latin typeface="Cambria Math" panose="02040503050406030204" pitchFamily="18" charset="0"/>
+                                  </a:rPr>
+                                  <m:t>𝜃</m:t>
+                                </m:r>
+                              </m:e>
+                              <m:sub>
+                                <m:r>
+                                  <a:rPr lang="it-IT" i="1" dirty="0" smtClean="0">
+                                    <a:latin typeface="Cambria Math" panose="02040503050406030204" pitchFamily="18" charset="0"/>
+                                  </a:rPr>
+                                  <m:t>0</m:t>
+                                </m:r>
+                              </m:sub>
+                            </m:sSub>
+                          </m:e>
+                          <m:e>
+                            <m:sSub>
+                              <m:sSubPr>
+                                <m:ctrlPr>
+                                  <a:rPr lang="it-IT" i="1" dirty="0" err="1" smtClean="0">
+                                    <a:latin typeface="Cambria Math" panose="02040503050406030204" pitchFamily="18" charset="0"/>
+                                  </a:rPr>
+                                </m:ctrlPr>
+                              </m:sSubPr>
+                              <m:e>
+                                <m:r>
+                                  <a:rPr lang="it-IT" i="1" dirty="0" smtClean="0">
+                                    <a:latin typeface="Cambria Math" panose="02040503050406030204" pitchFamily="18" charset="0"/>
+                                  </a:rPr>
+                                  <m:t>𝜃</m:t>
+                                </m:r>
+                              </m:e>
+                              <m:sub>
+                                <m:r>
+                                  <a:rPr lang="it-IT" i="1" dirty="0" err="1" smtClean="0">
+                                    <a:latin typeface="Cambria Math" panose="02040503050406030204" pitchFamily="18" charset="0"/>
+                                  </a:rPr>
+                                  <m:t>𝑡</m:t>
+                                </m:r>
+                              </m:sub>
+                            </m:sSub>
+                          </m:e>
+                        </m:d>
+                      </m:den>
+                    </m:f>
+                    <m:r>
+                      <a:rPr lang="it-IT" i="1" dirty="0" smtClean="0">
+                        <a:latin typeface="Cambria Math" panose="02040503050406030204" pitchFamily="18" charset="0"/>
+                      </a:rPr>
+                      <m:t>≥</m:t>
+                    </m:r>
+                    <m:r>
+                      <a:rPr lang="it-IT" i="1" dirty="0" smtClean="0">
+                        <a:latin typeface="Cambria Math" panose="02040503050406030204" pitchFamily="18" charset="0"/>
+                      </a:rPr>
+                      <m:t>𝑎</m:t>
+                    </m:r>
                   </m:oMath>
                 </a14:m>
-                <a:endParaRPr lang="it-IT" dirty="0"/>
-              </a:p>
-              <a:p>
-                <a:pPr marL="285750" indent="-285750">
-                  <a:buFont typeface="Arial" panose="020B0604020202020204" pitchFamily="34" charset="0"/>
-                  <a:buChar char="•"/>
-                </a:pPr>
                 <a:r>
                   <a:rPr lang="it-IT" dirty="0"/>
-                  <a:t>Check </a:t>
-                </a:r>
-                <a:r>
-                  <a:rPr lang="it-IT" dirty="0" err="1"/>
-                  <a:t>acceptance</a:t>
-                </a:r>
-                <a:r>
-                  <a:rPr lang="it-IT" dirty="0"/>
-                  <a:t> rule</a:t>
+                  <a:t> </a:t>
                 </a:r>
               </a:p>
             </p:txBody>
@@ -14338,10 +15790,10 @@
         <mc:Fallback xmlns="">
           <p:sp>
             <p:nvSpPr>
-              <p:cNvPr id="14" name="CasellaDiTesto 13">
+              <p:cNvPr id="10" name="CasellaDiTesto 9">
                 <a:extLst>
                   <a:ext uri="{FF2B5EF4-FFF2-40B4-BE49-F238E27FC236}">
-                    <a16:creationId xmlns:a16="http://schemas.microsoft.com/office/drawing/2014/main" id="{BC4AC2BC-522C-CF7C-A8BC-2F88B1C1C828}"/>
+                    <a16:creationId xmlns:a16="http://schemas.microsoft.com/office/drawing/2014/main" id="{9374EB6B-02FF-46C4-5965-0A5BE147449F}"/>
                   </a:ext>
                 </a:extLst>
               </p:cNvPr>
@@ -14352,16 +15804,16 @@
             </p:nvSpPr>
             <p:spPr>
               <a:xfrm>
-                <a:off x="2024009" y="3688422"/>
-                <a:ext cx="4654193" cy="923330"/>
+                <a:off x="6789051" y="4916711"/>
+                <a:ext cx="1834968" cy="596382"/>
               </a:xfrm>
               <a:prstGeom prst="rect">
                 <a:avLst/>
               </a:prstGeom>
               <a:blipFill>
-                <a:blip r:embed="rId2"/>
+                <a:blip r:embed="rId6"/>
                 <a:stretch>
-                  <a:fillRect l="-785" t="-3289" b="-9211"/>
+                  <a:fillRect/>
                 </a:stretch>
               </a:blipFill>
             </p:spPr>
@@ -14380,432 +15832,164 @@
           </p:sp>
         </mc:Fallback>
       </mc:AlternateContent>
-      <mc:AlternateContent xmlns:mc="http://schemas.openxmlformats.org/markup-compatibility/2006" xmlns:a14="http://schemas.microsoft.com/office/drawing/2010/main">
-        <mc:Choice Requires="a14">
-          <p:sp>
-            <p:nvSpPr>
-              <p:cNvPr id="15" name="CasellaDiTesto 14">
-                <a:extLst>
-                  <a:ext uri="{FF2B5EF4-FFF2-40B4-BE49-F238E27FC236}">
-                    <a16:creationId xmlns:a16="http://schemas.microsoft.com/office/drawing/2014/main" id="{A8346508-EC61-0A86-CF73-51AB617DF50E}"/>
-                  </a:ext>
-                </a:extLst>
-              </p:cNvPr>
-              <p:cNvSpPr txBox="1"/>
-              <p:nvPr/>
-            </p:nvSpPr>
-            <p:spPr>
-              <a:xfrm>
-                <a:off x="1757684" y="4860348"/>
-                <a:ext cx="1684962" cy="646331"/>
-              </a:xfrm>
-              <a:prstGeom prst="rect">
-                <a:avLst/>
-              </a:prstGeom>
-              <a:noFill/>
-            </p:spPr>
-            <p:txBody>
-              <a:bodyPr wrap="square" rtlCol="0">
-                <a:spAutoFit/>
-              </a:bodyPr>
-              <a:lstStyle/>
-              <a:p>
-                <a:r>
-                  <a:rPr lang="it-IT" dirty="0" err="1"/>
-                  <a:t>If</a:t>
-                </a:r>
-                <a:r>
-                  <a:rPr lang="it-IT" dirty="0"/>
-                  <a:t> </a:t>
-                </a:r>
-                <a:r>
-                  <a:rPr lang="it-IT" dirty="0" err="1"/>
-                  <a:t>true</a:t>
-                </a:r>
-                <a:r>
-                  <a:rPr lang="it-IT" dirty="0"/>
-                  <a:t> </a:t>
-                </a:r>
-                <a:r>
-                  <a:rPr lang="it-IT" dirty="0" err="1"/>
-                  <a:t>move</a:t>
-                </a:r>
-                <a:r>
-                  <a:rPr lang="it-IT" dirty="0"/>
-                  <a:t> to </a:t>
-                </a:r>
-                <a14:m>
-                  <m:oMath xmlns:m="http://schemas.openxmlformats.org/officeDocument/2006/math">
-                    <m:sSub>
-                      <m:sSubPr>
-                        <m:ctrlPr>
-                          <a:rPr lang="it-IT" i="1" dirty="0" smtClean="0">
-                            <a:latin typeface="Cambria Math" panose="02040503050406030204" pitchFamily="18" charset="0"/>
-                          </a:rPr>
-                        </m:ctrlPr>
-                      </m:sSubPr>
-                      <m:e>
-                        <m:r>
-                          <a:rPr lang="it-IT" i="1" dirty="0" smtClean="0">
-                            <a:latin typeface="Cambria Math" panose="02040503050406030204" pitchFamily="18" charset="0"/>
-                          </a:rPr>
-                          <m:t>𝜃</m:t>
-                        </m:r>
-                      </m:e>
-                      <m:sub>
-                        <m:r>
-                          <a:rPr lang="it-IT" i="1" dirty="0" smtClean="0">
-                            <a:latin typeface="Cambria Math" panose="02040503050406030204" pitchFamily="18" charset="0"/>
-                          </a:rPr>
-                          <m:t>0</m:t>
-                        </m:r>
-                      </m:sub>
-                    </m:sSub>
-                    <m:r>
-                      <a:rPr lang="it-IT" i="1" dirty="0" smtClean="0">
-                        <a:latin typeface="Cambria Math" panose="02040503050406030204" pitchFamily="18" charset="0"/>
-                      </a:rPr>
-                      <m:t>=</m:t>
-                    </m:r>
-                    <m:sSub>
-                      <m:sSubPr>
-                        <m:ctrlPr>
-                          <a:rPr lang="it-IT" i="1" dirty="0" err="1" smtClean="0">
-                            <a:latin typeface="Cambria Math" panose="02040503050406030204" pitchFamily="18" charset="0"/>
-                          </a:rPr>
-                        </m:ctrlPr>
-                      </m:sSubPr>
-                      <m:e>
-                        <m:r>
-                          <a:rPr lang="it-IT" i="1" dirty="0" smtClean="0">
-                            <a:latin typeface="Cambria Math" panose="02040503050406030204" pitchFamily="18" charset="0"/>
-                          </a:rPr>
-                          <m:t>𝜃</m:t>
-                        </m:r>
-                      </m:e>
-                      <m:sub>
-                        <m:r>
-                          <a:rPr lang="it-IT" i="1" dirty="0" err="1" smtClean="0">
-                            <a:latin typeface="Cambria Math" panose="02040503050406030204" pitchFamily="18" charset="0"/>
-                          </a:rPr>
-                          <m:t>𝑡</m:t>
-                        </m:r>
-                      </m:sub>
-                    </m:sSub>
-                  </m:oMath>
-                </a14:m>
-                <a:endParaRPr lang="it-IT" dirty="0"/>
-              </a:p>
-            </p:txBody>
-          </p:sp>
-        </mc:Choice>
-        <mc:Fallback xmlns="">
-          <p:sp>
-            <p:nvSpPr>
-              <p:cNvPr id="15" name="CasellaDiTesto 14">
-                <a:extLst>
-                  <a:ext uri="{FF2B5EF4-FFF2-40B4-BE49-F238E27FC236}">
-                    <a16:creationId xmlns:a16="http://schemas.microsoft.com/office/drawing/2014/main" id="{A8346508-EC61-0A86-CF73-51AB617DF50E}"/>
-                  </a:ext>
-                </a:extLst>
-              </p:cNvPr>
-              <p:cNvSpPr txBox="1">
-                <a:spLocks noRot="1" noChangeAspect="1" noMove="1" noResize="1" noEditPoints="1" noAdjustHandles="1" noChangeArrowheads="1" noChangeShapeType="1" noTextEdit="1"/>
-              </p:cNvSpPr>
-              <p:nvPr/>
-            </p:nvSpPr>
-            <p:spPr>
-              <a:xfrm>
-                <a:off x="1757684" y="4860348"/>
-                <a:ext cx="1684962" cy="646331"/>
-              </a:xfrm>
-              <a:prstGeom prst="rect">
-                <a:avLst/>
-              </a:prstGeom>
-              <a:blipFill>
-                <a:blip r:embed="rId3"/>
-                <a:stretch>
-                  <a:fillRect l="-2888" t="-4717" b="-14151"/>
-                </a:stretch>
-              </a:blipFill>
-            </p:spPr>
-            <p:txBody>
-              <a:bodyPr/>
-              <a:lstStyle/>
-              <a:p>
-                <a:r>
-                  <a:rPr lang="it-IT">
-                    <a:noFill/>
-                  </a:rPr>
-                  <a:t> </a:t>
-                </a:r>
-              </a:p>
-            </p:txBody>
-          </p:sp>
-        </mc:Fallback>
-      </mc:AlternateContent>
-      <mc:AlternateContent xmlns:mc="http://schemas.openxmlformats.org/markup-compatibility/2006" xmlns:a14="http://schemas.microsoft.com/office/drawing/2010/main">
-        <mc:Choice Requires="a14">
-          <p:sp>
-            <p:nvSpPr>
-              <p:cNvPr id="16" name="CasellaDiTesto 15">
-                <a:extLst>
-                  <a:ext uri="{FF2B5EF4-FFF2-40B4-BE49-F238E27FC236}">
-                    <a16:creationId xmlns:a16="http://schemas.microsoft.com/office/drawing/2014/main" id="{1A45A8E9-92A5-F272-C0D9-0FF6E89C39A8}"/>
-                  </a:ext>
-                </a:extLst>
-              </p:cNvPr>
-              <p:cNvSpPr txBox="1"/>
-              <p:nvPr/>
-            </p:nvSpPr>
-            <p:spPr>
-              <a:xfrm>
-                <a:off x="4025757" y="4998847"/>
-                <a:ext cx="2070243" cy="369332"/>
-              </a:xfrm>
-              <a:prstGeom prst="rect">
-                <a:avLst/>
-              </a:prstGeom>
-              <a:noFill/>
-            </p:spPr>
-            <p:txBody>
-              <a:bodyPr wrap="square" rtlCol="0">
-                <a:spAutoFit/>
-              </a:bodyPr>
-              <a:lstStyle/>
-              <a:p>
-                <a:r>
-                  <a:rPr lang="it-IT" dirty="0" err="1"/>
-                  <a:t>If</a:t>
-                </a:r>
-                <a:r>
-                  <a:rPr lang="it-IT" dirty="0"/>
-                  <a:t> false stay </a:t>
-                </a:r>
-                <a:r>
-                  <a:rPr lang="it-IT" dirty="0" err="1"/>
-                  <a:t>at</a:t>
-                </a:r>
-                <a:r>
-                  <a:rPr lang="it-IT" dirty="0"/>
-                  <a:t> </a:t>
-                </a:r>
-                <a14:m>
-                  <m:oMath xmlns:m="http://schemas.openxmlformats.org/officeDocument/2006/math">
-                    <m:sSub>
-                      <m:sSubPr>
-                        <m:ctrlPr>
-                          <a:rPr lang="it-IT" i="1" dirty="0" smtClean="0">
-                            <a:latin typeface="Cambria Math" panose="02040503050406030204" pitchFamily="18" charset="0"/>
-                          </a:rPr>
-                        </m:ctrlPr>
-                      </m:sSubPr>
-                      <m:e>
-                        <m:r>
-                          <a:rPr lang="it-IT" i="1" dirty="0" smtClean="0">
-                            <a:latin typeface="Cambria Math" panose="02040503050406030204" pitchFamily="18" charset="0"/>
-                          </a:rPr>
-                          <m:t>𝜃</m:t>
-                        </m:r>
-                      </m:e>
-                      <m:sub>
-                        <m:r>
-                          <a:rPr lang="it-IT" i="1" dirty="0" smtClean="0">
-                            <a:latin typeface="Cambria Math" panose="02040503050406030204" pitchFamily="18" charset="0"/>
-                          </a:rPr>
-                          <m:t>0</m:t>
-                        </m:r>
-                      </m:sub>
-                    </m:sSub>
-                  </m:oMath>
-                </a14:m>
-                <a:endParaRPr lang="it-IT" dirty="0"/>
-              </a:p>
-            </p:txBody>
-          </p:sp>
-        </mc:Choice>
-        <mc:Fallback xmlns="">
-          <p:sp>
-            <p:nvSpPr>
-              <p:cNvPr id="16" name="CasellaDiTesto 15">
-                <a:extLst>
-                  <a:ext uri="{FF2B5EF4-FFF2-40B4-BE49-F238E27FC236}">
-                    <a16:creationId xmlns:a16="http://schemas.microsoft.com/office/drawing/2014/main" id="{1A45A8E9-92A5-F272-C0D9-0FF6E89C39A8}"/>
-                  </a:ext>
-                </a:extLst>
-              </p:cNvPr>
-              <p:cNvSpPr txBox="1">
-                <a:spLocks noRot="1" noChangeAspect="1" noMove="1" noResize="1" noEditPoints="1" noAdjustHandles="1" noChangeArrowheads="1" noChangeShapeType="1" noTextEdit="1"/>
-              </p:cNvSpPr>
-              <p:nvPr/>
-            </p:nvSpPr>
-            <p:spPr>
-              <a:xfrm>
-                <a:off x="4025757" y="4998847"/>
-                <a:ext cx="2070243" cy="369332"/>
-              </a:xfrm>
-              <a:prstGeom prst="rect">
-                <a:avLst/>
-              </a:prstGeom>
-              <a:blipFill>
-                <a:blip r:embed="rId4"/>
-                <a:stretch>
-                  <a:fillRect l="-2353" t="-8197" b="-24590"/>
-                </a:stretch>
-              </a:blipFill>
-            </p:spPr>
-            <p:txBody>
-              <a:bodyPr/>
-              <a:lstStyle/>
-              <a:p>
-                <a:r>
-                  <a:rPr lang="it-IT">
-                    <a:noFill/>
-                  </a:rPr>
-                  <a:t> </a:t>
-                </a:r>
-              </a:p>
-            </p:txBody>
-          </p:sp>
-        </mc:Fallback>
-      </mc:AlternateContent>
-      <mc:AlternateContent xmlns:mc="http://schemas.openxmlformats.org/markup-compatibility/2006" xmlns:a14="http://schemas.microsoft.com/office/drawing/2010/main">
-        <mc:Choice Requires="a14">
-          <p:sp>
-            <p:nvSpPr>
-              <p:cNvPr id="17" name="CasellaDiTesto 16">
-                <a:extLst>
-                  <a:ext uri="{FF2B5EF4-FFF2-40B4-BE49-F238E27FC236}">
-                    <a16:creationId xmlns:a16="http://schemas.microsoft.com/office/drawing/2014/main" id="{7F281147-055D-0C36-6BC8-FBB7FEF09A80}"/>
-                  </a:ext>
-                </a:extLst>
-              </p:cNvPr>
-              <p:cNvSpPr txBox="1"/>
-              <p:nvPr/>
-            </p:nvSpPr>
-            <p:spPr>
-              <a:xfrm>
-                <a:off x="6883685" y="4448710"/>
-                <a:ext cx="3113070" cy="1200329"/>
-              </a:xfrm>
-              <a:prstGeom prst="rect">
-                <a:avLst/>
-              </a:prstGeom>
-              <a:noFill/>
-            </p:spPr>
-            <p:txBody>
-              <a:bodyPr wrap="square" rtlCol="0">
-                <a:spAutoFit/>
-              </a:bodyPr>
-              <a:lstStyle/>
-              <a:p>
-                <a:r>
-                  <a:rPr lang="it-IT" dirty="0"/>
-                  <a:t>In </a:t>
-                </a:r>
-                <a:r>
-                  <a:rPr lang="it-IT" dirty="0" err="1"/>
-                  <a:t>this</a:t>
-                </a:r>
-                <a:r>
-                  <a:rPr lang="it-IT" dirty="0"/>
-                  <a:t> way we </a:t>
-                </a:r>
-                <a:r>
-                  <a:rPr lang="it-IT" dirty="0" err="1"/>
-                  <a:t>will</a:t>
-                </a:r>
-                <a:r>
-                  <a:rPr lang="it-IT" dirty="0"/>
-                  <a:t> have the </a:t>
-                </a:r>
-                <a14:m>
-                  <m:oMath xmlns:m="http://schemas.openxmlformats.org/officeDocument/2006/math">
-                    <m:r>
-                      <a:rPr lang="it-IT" i="1" dirty="0" smtClean="0">
-                        <a:latin typeface="Cambria Math" panose="02040503050406030204" pitchFamily="18" charset="0"/>
-                      </a:rPr>
-                      <m:t>𝜃</m:t>
-                    </m:r>
-                  </m:oMath>
-                </a14:m>
-                <a:r>
-                  <a:rPr lang="it-IT" dirty="0"/>
-                  <a:t> with </a:t>
-                </a:r>
-                <a:r>
-                  <a:rPr lang="it-IT" dirty="0" err="1"/>
-                  <a:t>higher</a:t>
-                </a:r>
-                <a:r>
-                  <a:rPr lang="it-IT" dirty="0"/>
-                  <a:t> </a:t>
-                </a:r>
-                <a:r>
-                  <a:rPr lang="it-IT" dirty="0" err="1"/>
-                  <a:t>posterior</a:t>
-                </a:r>
-                <a:r>
-                  <a:rPr lang="it-IT" dirty="0"/>
-                  <a:t> more times so more </a:t>
-                </a:r>
-                <a:r>
-                  <a:rPr lang="it-IT" dirty="0" err="1"/>
-                  <a:t>probable</a:t>
-                </a:r>
-                <a:r>
-                  <a:rPr lang="it-IT" dirty="0"/>
-                  <a:t>! </a:t>
-                </a:r>
-              </a:p>
-            </p:txBody>
-          </p:sp>
-        </mc:Choice>
-        <mc:Fallback xmlns="">
-          <p:sp>
-            <p:nvSpPr>
-              <p:cNvPr id="17" name="CasellaDiTesto 16">
-                <a:extLst>
-                  <a:ext uri="{FF2B5EF4-FFF2-40B4-BE49-F238E27FC236}">
-                    <a16:creationId xmlns:a16="http://schemas.microsoft.com/office/drawing/2014/main" id="{7F281147-055D-0C36-6BC8-FBB7FEF09A80}"/>
-                  </a:ext>
-                </a:extLst>
-              </p:cNvPr>
-              <p:cNvSpPr txBox="1">
-                <a:spLocks noRot="1" noChangeAspect="1" noMove="1" noResize="1" noEditPoints="1" noAdjustHandles="1" noChangeArrowheads="1" noChangeShapeType="1" noTextEdit="1"/>
-              </p:cNvSpPr>
-              <p:nvPr/>
-            </p:nvSpPr>
-            <p:spPr>
-              <a:xfrm>
-                <a:off x="6883685" y="4448710"/>
-                <a:ext cx="3113070" cy="1200329"/>
-              </a:xfrm>
-              <a:prstGeom prst="rect">
-                <a:avLst/>
-              </a:prstGeom>
-              <a:blipFill>
-                <a:blip r:embed="rId5"/>
-                <a:stretch>
-                  <a:fillRect l="-1566" t="-3046" b="-7107"/>
-                </a:stretch>
-              </a:blipFill>
-            </p:spPr>
-            <p:txBody>
-              <a:bodyPr/>
-              <a:lstStyle/>
-              <a:p>
-                <a:r>
-                  <a:rPr lang="it-IT">
-                    <a:noFill/>
-                  </a:rPr>
-                  <a:t> </a:t>
-                </a:r>
-              </a:p>
-            </p:txBody>
-          </p:sp>
-        </mc:Fallback>
-      </mc:AlternateContent>
+      <p:sp>
+        <p:nvSpPr>
+          <p:cNvPr id="18" name="CasellaDiTesto 17">
+            <a:extLst>
+              <a:ext uri="{FF2B5EF4-FFF2-40B4-BE49-F238E27FC236}">
+                <a16:creationId xmlns:a16="http://schemas.microsoft.com/office/drawing/2014/main" id="{2205BEA0-5222-B972-F404-5C0B82B16295}"/>
+              </a:ext>
+            </a:extLst>
+          </p:cNvPr>
+          <p:cNvSpPr txBox="1"/>
+          <p:nvPr/>
+        </p:nvSpPr>
+        <p:spPr>
+          <a:xfrm>
+            <a:off x="8624019" y="5493562"/>
+            <a:ext cx="1834968" cy="646331"/>
+          </a:xfrm>
+          <a:prstGeom prst="rect">
+            <a:avLst/>
+          </a:prstGeom>
+          <a:noFill/>
+        </p:spPr>
+        <p:txBody>
+          <a:bodyPr wrap="square" rtlCol="0">
+            <a:spAutoFit/>
+          </a:bodyPr>
+          <a:lstStyle/>
+          <a:p>
+            <a:r>
+              <a:rPr lang="it-IT" dirty="0"/>
+              <a:t>Random </a:t>
+            </a:r>
+            <a:r>
+              <a:rPr lang="it-IT" dirty="0" err="1"/>
+              <a:t>extract</a:t>
+            </a:r>
+            <a:r>
+              <a:rPr lang="it-IT" dirty="0"/>
+              <a:t> in [0,1]</a:t>
+            </a:r>
+          </a:p>
+        </p:txBody>
+      </p:sp>
+      <p:sp>
+        <p:nvSpPr>
+          <p:cNvPr id="19" name="CasellaDiTesto 18">
+            <a:extLst>
+              <a:ext uri="{FF2B5EF4-FFF2-40B4-BE49-F238E27FC236}">
+                <a16:creationId xmlns:a16="http://schemas.microsoft.com/office/drawing/2014/main" id="{F678EB67-B3A0-CC30-336A-E035658E77C5}"/>
+              </a:ext>
+            </a:extLst>
+          </p:cNvPr>
+          <p:cNvSpPr txBox="1"/>
+          <p:nvPr/>
+        </p:nvSpPr>
+        <p:spPr>
+          <a:xfrm>
+            <a:off x="5711602" y="5315244"/>
+            <a:ext cx="1307788" cy="646331"/>
+          </a:xfrm>
+          <a:prstGeom prst="rect">
+            <a:avLst/>
+          </a:prstGeom>
+          <a:noFill/>
+        </p:spPr>
+        <p:txBody>
+          <a:bodyPr wrap="square" rtlCol="0">
+            <a:spAutoFit/>
+          </a:bodyPr>
+          <a:lstStyle/>
+          <a:p>
+            <a:r>
+              <a:rPr lang="it-IT" dirty="0" err="1"/>
+              <a:t>Posterior</a:t>
+            </a:r>
+            <a:r>
+              <a:rPr lang="it-IT" dirty="0"/>
+              <a:t> </a:t>
+            </a:r>
+            <a:r>
+              <a:rPr lang="it-IT" dirty="0" err="1"/>
+              <a:t>values</a:t>
+            </a:r>
+            <a:endParaRPr lang="it-IT" dirty="0"/>
+          </a:p>
+        </p:txBody>
+      </p:sp>
+      <p:sp>
+        <p:nvSpPr>
+          <p:cNvPr id="20" name="CasellaDiTesto 19">
+            <a:extLst>
+              <a:ext uri="{FF2B5EF4-FFF2-40B4-BE49-F238E27FC236}">
+                <a16:creationId xmlns:a16="http://schemas.microsoft.com/office/drawing/2014/main" id="{7A5DA5CB-C065-8229-9097-51D9A9BAEAF2}"/>
+              </a:ext>
+            </a:extLst>
+          </p:cNvPr>
+          <p:cNvSpPr txBox="1"/>
+          <p:nvPr/>
+        </p:nvSpPr>
+        <p:spPr>
+          <a:xfrm>
+            <a:off x="5845995" y="6086892"/>
+            <a:ext cx="3154167" cy="646331"/>
+          </a:xfrm>
+          <a:prstGeom prst="rect">
+            <a:avLst/>
+          </a:prstGeom>
+          <a:noFill/>
+        </p:spPr>
+        <p:txBody>
+          <a:bodyPr wrap="square" rtlCol="0">
+            <a:spAutoFit/>
+          </a:bodyPr>
+          <a:lstStyle/>
+          <a:p>
+            <a:r>
+              <a:rPr lang="it-IT" dirty="0" err="1"/>
+              <a:t>Proposal</a:t>
+            </a:r>
+            <a:r>
+              <a:rPr lang="it-IT" dirty="0"/>
+              <a:t> </a:t>
+            </a:r>
+            <a:r>
+              <a:rPr lang="it-IT" dirty="0" err="1"/>
+              <a:t>values</a:t>
+            </a:r>
+            <a:r>
+              <a:rPr lang="it-IT" dirty="0"/>
+              <a:t>, </a:t>
+            </a:r>
+            <a:r>
+              <a:rPr lang="it-IT" dirty="0" err="1"/>
+              <a:t>ours</a:t>
+            </a:r>
+            <a:r>
+              <a:rPr lang="it-IT" dirty="0"/>
+              <a:t> </a:t>
+            </a:r>
+            <a:r>
+              <a:rPr lang="it-IT" dirty="0" err="1"/>
+              <a:t>is</a:t>
+            </a:r>
+            <a:r>
+              <a:rPr lang="it-IT" dirty="0"/>
+              <a:t> </a:t>
+            </a:r>
+            <a:r>
+              <a:rPr lang="it-IT" dirty="0" err="1"/>
+              <a:t>symmetric</a:t>
+            </a:r>
+            <a:r>
+              <a:rPr lang="it-IT" dirty="0"/>
+              <a:t> so it’s 1</a:t>
+            </a:r>
+          </a:p>
+        </p:txBody>
+      </p:sp>
     </p:spTree>
     <p:extLst>
       <p:ext uri="{BB962C8B-B14F-4D97-AF65-F5344CB8AC3E}">

</xml_diff>

<commit_message>
31/03: images of point 1a done
</commit_message>
<xml_diff>
--- a/Seminar.pptx
+++ b/Seminar.pptx
@@ -2132,7 +2132,7 @@
           <a:p>
             <a:fld id="{FAF9D2FB-70D2-43E7-9793-86D8D2F82197}" type="datetimeFigureOut">
               <a:rPr lang="it-IT" smtClean="0"/>
-              <a:t>27/03/2026</a:t>
+              <a:t>31/03/2026</a:t>
             </a:fld>
             <a:endParaRPr lang="it-IT"/>
           </a:p>
@@ -2567,7 +2567,7 @@
           <a:p>
             <a:fld id="{12B2C755-0381-446C-8FF6-9D93CC4F5EBA}" type="datetimeFigureOut">
               <a:rPr lang="it-IT" smtClean="0"/>
-              <a:t>27/03/2026</a:t>
+              <a:t>31/03/2026</a:t>
             </a:fld>
             <a:endParaRPr lang="it-IT"/>
           </a:p>
@@ -2838,7 +2838,7 @@
           <a:p>
             <a:fld id="{12B2C755-0381-446C-8FF6-9D93CC4F5EBA}" type="datetimeFigureOut">
               <a:rPr lang="it-IT" smtClean="0"/>
-              <a:t>27/03/2026</a:t>
+              <a:t>31/03/2026</a:t>
             </a:fld>
             <a:endParaRPr lang="it-IT"/>
           </a:p>
@@ -3018,7 +3018,7 @@
           <a:p>
             <a:fld id="{12B2C755-0381-446C-8FF6-9D93CC4F5EBA}" type="datetimeFigureOut">
               <a:rPr lang="it-IT" smtClean="0"/>
-              <a:t>27/03/2026</a:t>
+              <a:t>31/03/2026</a:t>
             </a:fld>
             <a:endParaRPr lang="it-IT"/>
           </a:p>
@@ -3203,7 +3203,7 @@
           <a:p>
             <a:fld id="{12B2C755-0381-446C-8FF6-9D93CC4F5EBA}" type="datetimeFigureOut">
               <a:rPr lang="it-IT" smtClean="0"/>
-              <a:t>27/03/2026</a:t>
+              <a:t>31/03/2026</a:t>
             </a:fld>
             <a:endParaRPr lang="it-IT"/>
           </a:p>
@@ -3462,7 +3462,7 @@
           <a:p>
             <a:fld id="{12B2C755-0381-446C-8FF6-9D93CC4F5EBA}" type="datetimeFigureOut">
               <a:rPr lang="it-IT" smtClean="0"/>
-              <a:t>27/03/2026</a:t>
+              <a:t>31/03/2026</a:t>
             </a:fld>
             <a:endParaRPr lang="it-IT"/>
           </a:p>
@@ -3795,7 +3795,7 @@
           <a:p>
             <a:fld id="{12B2C755-0381-446C-8FF6-9D93CC4F5EBA}" type="datetimeFigureOut">
               <a:rPr lang="it-IT" smtClean="0"/>
-              <a:t>27/03/2026</a:t>
+              <a:t>31/03/2026</a:t>
             </a:fld>
             <a:endParaRPr lang="it-IT"/>
           </a:p>
@@ -4246,7 +4246,7 @@
           <a:p>
             <a:fld id="{12B2C755-0381-446C-8FF6-9D93CC4F5EBA}" type="datetimeFigureOut">
               <a:rPr lang="it-IT" smtClean="0"/>
-              <a:t>27/03/2026</a:t>
+              <a:t>31/03/2026</a:t>
             </a:fld>
             <a:endParaRPr lang="it-IT"/>
           </a:p>
@@ -4364,7 +4364,7 @@
           <a:p>
             <a:fld id="{12B2C755-0381-446C-8FF6-9D93CC4F5EBA}" type="datetimeFigureOut">
               <a:rPr lang="it-IT" smtClean="0"/>
-              <a:t>27/03/2026</a:t>
+              <a:t>31/03/2026</a:t>
             </a:fld>
             <a:endParaRPr lang="it-IT"/>
           </a:p>
@@ -4459,7 +4459,7 @@
           <a:p>
             <a:fld id="{12B2C755-0381-446C-8FF6-9D93CC4F5EBA}" type="datetimeFigureOut">
               <a:rPr lang="it-IT" smtClean="0"/>
-              <a:t>27/03/2026</a:t>
+              <a:t>31/03/2026</a:t>
             </a:fld>
             <a:endParaRPr lang="it-IT"/>
           </a:p>
@@ -4746,7 +4746,7 @@
           <a:p>
             <a:fld id="{12B2C755-0381-446C-8FF6-9D93CC4F5EBA}" type="datetimeFigureOut">
               <a:rPr lang="it-IT" smtClean="0"/>
-              <a:t>27/03/2026</a:t>
+              <a:t>31/03/2026</a:t>
             </a:fld>
             <a:endParaRPr lang="it-IT"/>
           </a:p>
@@ -5075,7 +5075,7 @@
           <a:p>
             <a:fld id="{12B2C755-0381-446C-8FF6-9D93CC4F5EBA}" type="datetimeFigureOut">
               <a:rPr lang="it-IT" smtClean="0"/>
-              <a:t>27/03/2026</a:t>
+              <a:t>31/03/2026</a:t>
             </a:fld>
             <a:endParaRPr lang="it-IT"/>
           </a:p>
@@ -5336,7 +5336,7 @@
           <a:p>
             <a:fld id="{12B2C755-0381-446C-8FF6-9D93CC4F5EBA}" type="datetimeFigureOut">
               <a:rPr lang="it-IT" smtClean="0"/>
-              <a:t>27/03/2026</a:t>
+              <a:t>31/03/2026</a:t>
             </a:fld>
             <a:endParaRPr lang="it-IT" dirty="0"/>
           </a:p>
@@ -8649,8 +8649,8 @@
           <a:chExt cx="0" cy="0"/>
         </a:xfrm>
       </p:grpSpPr>
-      <mc:AlternateContent xmlns:mc="http://schemas.openxmlformats.org/markup-compatibility/2006">
-        <mc:Choice xmlns:a14="http://schemas.microsoft.com/office/drawing/2010/main" Requires="a14">
+      <mc:AlternateContent xmlns:mc="http://schemas.openxmlformats.org/markup-compatibility/2006" xmlns:a14="http://schemas.microsoft.com/office/drawing/2010/main">
+        <mc:Choice Requires="a14">
           <p:sp>
             <p:nvSpPr>
               <p:cNvPr id="4" name="Titolo 1">
@@ -8759,7 +8759,7 @@
             </p:txBody>
           </p:sp>
         </mc:Choice>
-        <mc:Fallback>
+        <mc:Fallback xmlns="">
           <p:sp>
             <p:nvSpPr>
               <p:cNvPr id="4" name="Titolo 1">
@@ -10413,6 +10413,54 @@
           </a:prstGeom>
         </p:spPr>
       </p:pic>
+      <p:sp>
+        <p:nvSpPr>
+          <p:cNvPr id="3" name="CasellaDiTesto 2">
+            <a:extLst>
+              <a:ext uri="{FF2B5EF4-FFF2-40B4-BE49-F238E27FC236}">
+                <a16:creationId xmlns:a16="http://schemas.microsoft.com/office/drawing/2014/main" id="{6DBAA5E6-9546-A078-A564-895CA5AD8E69}"/>
+              </a:ext>
+            </a:extLst>
+          </p:cNvPr>
+          <p:cNvSpPr txBox="1"/>
+          <p:nvPr/>
+        </p:nvSpPr>
+        <p:spPr>
+          <a:xfrm>
+            <a:off x="1027416" y="5578867"/>
+            <a:ext cx="2938409" cy="923330"/>
+          </a:xfrm>
+          <a:prstGeom prst="rect">
+            <a:avLst/>
+          </a:prstGeom>
+          <a:noFill/>
+        </p:spPr>
+        <p:txBody>
+          <a:bodyPr wrap="square" rtlCol="0">
+            <a:spAutoFit/>
+          </a:bodyPr>
+          <a:lstStyle/>
+          <a:p>
+            <a:r>
+              <a:rPr lang="en-US" dirty="0"/>
+              <a:t>Mean error is: 1.74e-01</a:t>
+            </a:r>
+          </a:p>
+          <a:p>
+            <a:r>
+              <a:rPr lang="en-US" dirty="0"/>
+              <a:t>Median error is: 9.19e-02</a:t>
+            </a:r>
+          </a:p>
+          <a:p>
+            <a:r>
+              <a:rPr lang="en-US" dirty="0"/>
+              <a:t>A bin is large 2.24e-01</a:t>
+            </a:r>
+            <a:endParaRPr lang="it-IT" dirty="0"/>
+          </a:p>
+        </p:txBody>
+      </p:sp>
     </p:spTree>
     <p:extLst>
       <p:ext uri="{BB962C8B-B14F-4D97-AF65-F5344CB8AC3E}">

</xml_diff>

<commit_message>
04/04: presentation on point 1a
</commit_message>
<xml_diff>
--- a/Seminar.pptx
+++ b/Seminar.pptx
@@ -5,7 +5,7 @@
     <p:sldMasterId id="2147483684" r:id="rId1"/>
   </p:sldMasterIdLst>
   <p:notesMasterIdLst>
-    <p:notesMasterId r:id="rId24"/>
+    <p:notesMasterId r:id="rId23"/>
   </p:notesMasterIdLst>
   <p:sldIdLst>
     <p:sldId id="276" r:id="rId2"/>
@@ -24,12 +24,11 @@
     <p:sldId id="337" r:id="rId15"/>
     <p:sldId id="344" r:id="rId16"/>
     <p:sldId id="338" r:id="rId17"/>
-    <p:sldId id="328" r:id="rId18"/>
-    <p:sldId id="339" r:id="rId19"/>
-    <p:sldId id="340" r:id="rId20"/>
-    <p:sldId id="327" r:id="rId21"/>
-    <p:sldId id="289" r:id="rId22"/>
-    <p:sldId id="290" r:id="rId23"/>
+    <p:sldId id="339" r:id="rId18"/>
+    <p:sldId id="340" r:id="rId19"/>
+    <p:sldId id="327" r:id="rId20"/>
+    <p:sldId id="289" r:id="rId21"/>
+    <p:sldId id="290" r:id="rId22"/>
   </p:sldIdLst>
   <p:sldSz cx="12192000" cy="6858000"/>
   <p:notesSz cx="6858000" cy="9144000"/>
@@ -2136,7 +2135,7 @@
           <a:p>
             <a:fld id="{FAF9D2FB-70D2-43E7-9793-86D8D2F82197}" type="datetimeFigureOut">
               <a:rPr lang="it-IT" smtClean="0"/>
-              <a:t>03/04/2026</a:t>
+              <a:t>04/04/2026</a:t>
             </a:fld>
             <a:endParaRPr lang="it-IT"/>
           </a:p>
@@ -2571,7 +2570,7 @@
           <a:p>
             <a:fld id="{12B2C755-0381-446C-8FF6-9D93CC4F5EBA}" type="datetimeFigureOut">
               <a:rPr lang="it-IT" smtClean="0"/>
-              <a:t>03/04/2026</a:t>
+              <a:t>04/04/2026</a:t>
             </a:fld>
             <a:endParaRPr lang="it-IT"/>
           </a:p>
@@ -2842,7 +2841,7 @@
           <a:p>
             <a:fld id="{12B2C755-0381-446C-8FF6-9D93CC4F5EBA}" type="datetimeFigureOut">
               <a:rPr lang="it-IT" smtClean="0"/>
-              <a:t>03/04/2026</a:t>
+              <a:t>04/04/2026</a:t>
             </a:fld>
             <a:endParaRPr lang="it-IT"/>
           </a:p>
@@ -3022,7 +3021,7 @@
           <a:p>
             <a:fld id="{12B2C755-0381-446C-8FF6-9D93CC4F5EBA}" type="datetimeFigureOut">
               <a:rPr lang="it-IT" smtClean="0"/>
-              <a:t>03/04/2026</a:t>
+              <a:t>04/04/2026</a:t>
             </a:fld>
             <a:endParaRPr lang="it-IT"/>
           </a:p>
@@ -3207,7 +3206,7 @@
           <a:p>
             <a:fld id="{12B2C755-0381-446C-8FF6-9D93CC4F5EBA}" type="datetimeFigureOut">
               <a:rPr lang="it-IT" smtClean="0"/>
-              <a:t>03/04/2026</a:t>
+              <a:t>04/04/2026</a:t>
             </a:fld>
             <a:endParaRPr lang="it-IT"/>
           </a:p>
@@ -3466,7 +3465,7 @@
           <a:p>
             <a:fld id="{12B2C755-0381-446C-8FF6-9D93CC4F5EBA}" type="datetimeFigureOut">
               <a:rPr lang="it-IT" smtClean="0"/>
-              <a:t>03/04/2026</a:t>
+              <a:t>04/04/2026</a:t>
             </a:fld>
             <a:endParaRPr lang="it-IT"/>
           </a:p>
@@ -3799,7 +3798,7 @@
           <a:p>
             <a:fld id="{12B2C755-0381-446C-8FF6-9D93CC4F5EBA}" type="datetimeFigureOut">
               <a:rPr lang="it-IT" smtClean="0"/>
-              <a:t>03/04/2026</a:t>
+              <a:t>04/04/2026</a:t>
             </a:fld>
             <a:endParaRPr lang="it-IT"/>
           </a:p>
@@ -4250,7 +4249,7 @@
           <a:p>
             <a:fld id="{12B2C755-0381-446C-8FF6-9D93CC4F5EBA}" type="datetimeFigureOut">
               <a:rPr lang="it-IT" smtClean="0"/>
-              <a:t>03/04/2026</a:t>
+              <a:t>04/04/2026</a:t>
             </a:fld>
             <a:endParaRPr lang="it-IT"/>
           </a:p>
@@ -4368,7 +4367,7 @@
           <a:p>
             <a:fld id="{12B2C755-0381-446C-8FF6-9D93CC4F5EBA}" type="datetimeFigureOut">
               <a:rPr lang="it-IT" smtClean="0"/>
-              <a:t>03/04/2026</a:t>
+              <a:t>04/04/2026</a:t>
             </a:fld>
             <a:endParaRPr lang="it-IT"/>
           </a:p>
@@ -4463,7 +4462,7 @@
           <a:p>
             <a:fld id="{12B2C755-0381-446C-8FF6-9D93CC4F5EBA}" type="datetimeFigureOut">
               <a:rPr lang="it-IT" smtClean="0"/>
-              <a:t>03/04/2026</a:t>
+              <a:t>04/04/2026</a:t>
             </a:fld>
             <a:endParaRPr lang="it-IT"/>
           </a:p>
@@ -4750,7 +4749,7 @@
           <a:p>
             <a:fld id="{12B2C755-0381-446C-8FF6-9D93CC4F5EBA}" type="datetimeFigureOut">
               <a:rPr lang="it-IT" smtClean="0"/>
-              <a:t>03/04/2026</a:t>
+              <a:t>04/04/2026</a:t>
             </a:fld>
             <a:endParaRPr lang="it-IT"/>
           </a:p>
@@ -5079,7 +5078,7 @@
           <a:p>
             <a:fld id="{12B2C755-0381-446C-8FF6-9D93CC4F5EBA}" type="datetimeFigureOut">
               <a:rPr lang="it-IT" smtClean="0"/>
-              <a:t>03/04/2026</a:t>
+              <a:t>04/04/2026</a:t>
             </a:fld>
             <a:endParaRPr lang="it-IT"/>
           </a:p>
@@ -5340,7 +5339,7 @@
           <a:p>
             <a:fld id="{12B2C755-0381-446C-8FF6-9D93CC4F5EBA}" type="datetimeFigureOut">
               <a:rPr lang="it-IT" smtClean="0"/>
-              <a:t>03/04/2026</a:t>
+              <a:t>04/04/2026</a:t>
             </a:fld>
             <a:endParaRPr lang="it-IT" dirty="0"/>
           </a:p>
@@ -6288,8 +6287,8 @@
               <a:chExt cx="3503487" cy="1489120"/>
             </a:xfrm>
           </p:grpSpPr>
-          <mc:AlternateContent xmlns:mc="http://schemas.openxmlformats.org/markup-compatibility/2006">
-            <mc:Choice xmlns:a14="http://schemas.microsoft.com/office/drawing/2010/main" Requires="a14">
+          <mc:AlternateContent xmlns:mc="http://schemas.openxmlformats.org/markup-compatibility/2006" xmlns:a14="http://schemas.microsoft.com/office/drawing/2010/main">
+            <mc:Choice Requires="a14">
               <p:sp>
                 <p:nvSpPr>
                   <p:cNvPr id="14" name="CasellaDiTesto 13">
@@ -6463,7 +6462,7 @@
                 </p:txBody>
               </p:sp>
             </mc:Choice>
-            <mc:Fallback>
+            <mc:Fallback xmlns="">
               <p:sp>
                 <p:nvSpPr>
                   <p:cNvPr id="14" name="CasellaDiTesto 13">
@@ -6587,8 +6586,8 @@
           </a:p>
         </p:txBody>
       </p:sp>
-      <mc:AlternateContent xmlns:mc="http://schemas.openxmlformats.org/markup-compatibility/2006">
-        <mc:Choice xmlns:a14="http://schemas.microsoft.com/office/drawing/2010/main" Requires="a14">
+      <mc:AlternateContent xmlns:mc="http://schemas.openxmlformats.org/markup-compatibility/2006" xmlns:a14="http://schemas.microsoft.com/office/drawing/2010/main">
+        <mc:Choice Requires="a14">
           <p:sp>
             <p:nvSpPr>
               <p:cNvPr id="25" name="CasellaDiTesto 24">
@@ -6898,7 +6897,7 @@
             </p:txBody>
           </p:sp>
         </mc:Choice>
-        <mc:Fallback>
+        <mc:Fallback xmlns="">
           <p:sp>
             <p:nvSpPr>
               <p:cNvPr id="25" name="CasellaDiTesto 24">
@@ -6978,8 +6977,8 @@
           </a:p>
         </p:txBody>
       </p:sp>
-      <mc:AlternateContent xmlns:mc="http://schemas.openxmlformats.org/markup-compatibility/2006">
-        <mc:Choice xmlns:a14="http://schemas.microsoft.com/office/drawing/2010/main" Requires="a14">
+      <mc:AlternateContent xmlns:mc="http://schemas.openxmlformats.org/markup-compatibility/2006" xmlns:a14="http://schemas.microsoft.com/office/drawing/2010/main">
+        <mc:Choice Requires="a14">
           <p:sp>
             <p:nvSpPr>
               <p:cNvPr id="27" name="CasellaDiTesto 26">
@@ -7040,7 +7039,7 @@
             </p:txBody>
           </p:sp>
         </mc:Choice>
-        <mc:Fallback>
+        <mc:Fallback xmlns="">
           <p:sp>
             <p:nvSpPr>
               <p:cNvPr id="27" name="CasellaDiTesto 26">
@@ -7563,8 +7562,8 @@
               <a:chExt cx="4781817" cy="3174698"/>
             </a:xfrm>
           </p:grpSpPr>
-          <mc:AlternateContent xmlns:mc="http://schemas.openxmlformats.org/markup-compatibility/2006">
-            <mc:Choice xmlns:a14="http://schemas.microsoft.com/office/drawing/2010/main" Requires="a14">
+          <mc:AlternateContent xmlns:mc="http://schemas.openxmlformats.org/markup-compatibility/2006" xmlns:a14="http://schemas.microsoft.com/office/drawing/2010/main">
+            <mc:Choice Requires="a14">
               <p:sp>
                 <p:nvSpPr>
                   <p:cNvPr id="14" name="CasellaDiTesto 13">
@@ -7738,7 +7737,7 @@
                 </p:txBody>
               </p:sp>
             </mc:Choice>
-            <mc:Fallback>
+            <mc:Fallback xmlns="">
               <p:sp>
                 <p:nvSpPr>
                   <p:cNvPr id="14" name="CasellaDiTesto 13">
@@ -7806,8 +7805,8 @@
                 <a:chExt cx="4338316" cy="646331"/>
               </a:xfrm>
             </p:grpSpPr>
-            <mc:AlternateContent xmlns:mc="http://schemas.openxmlformats.org/markup-compatibility/2006">
-              <mc:Choice xmlns:a14="http://schemas.microsoft.com/office/drawing/2010/main" Requires="a14">
+            <mc:AlternateContent xmlns:mc="http://schemas.openxmlformats.org/markup-compatibility/2006" xmlns:a14="http://schemas.microsoft.com/office/drawing/2010/main">
+              <mc:Choice Requires="a14">
                 <p:sp>
                   <p:nvSpPr>
                     <p:cNvPr id="15" name="CasellaDiTesto 14">
@@ -7908,7 +7907,7 @@
                   </p:txBody>
                 </p:sp>
               </mc:Choice>
-              <mc:Fallback>
+              <mc:Fallback xmlns="">
                 <p:sp>
                   <p:nvSpPr>
                     <p:cNvPr id="15" name="CasellaDiTesto 14">
@@ -7956,8 +7955,8 @@
                 </p:sp>
               </mc:Fallback>
             </mc:AlternateContent>
-            <mc:AlternateContent xmlns:mc="http://schemas.openxmlformats.org/markup-compatibility/2006">
-              <mc:Choice xmlns:a14="http://schemas.microsoft.com/office/drawing/2010/main" Requires="a14">
+            <mc:AlternateContent xmlns:mc="http://schemas.openxmlformats.org/markup-compatibility/2006" xmlns:a14="http://schemas.microsoft.com/office/drawing/2010/main">
+              <mc:Choice Requires="a14">
                 <p:sp>
                   <p:nvSpPr>
                     <p:cNvPr id="16" name="CasellaDiTesto 15">
@@ -8027,7 +8026,7 @@
                   </p:txBody>
                 </p:sp>
               </mc:Choice>
-              <mc:Fallback>
+              <mc:Fallback xmlns="">
                 <p:sp>
                   <p:nvSpPr>
                     <p:cNvPr id="16" name="CasellaDiTesto 15">
@@ -8076,8 +8075,8 @@
               </mc:Fallback>
             </mc:AlternateContent>
           </p:grpSp>
-          <mc:AlternateContent xmlns:mc="http://schemas.openxmlformats.org/markup-compatibility/2006">
-            <mc:Choice xmlns:a14="http://schemas.microsoft.com/office/drawing/2010/main" Requires="a14">
+          <mc:AlternateContent xmlns:mc="http://schemas.openxmlformats.org/markup-compatibility/2006" xmlns:a14="http://schemas.microsoft.com/office/drawing/2010/main">
+            <mc:Choice Requires="a14">
               <p:sp>
                 <p:nvSpPr>
                   <p:cNvPr id="17" name="CasellaDiTesto 16">
@@ -8132,7 +8131,7 @@
                 </p:txBody>
               </p:sp>
             </mc:Choice>
-            <mc:Fallback>
+            <mc:Fallback xmlns="">
               <p:sp>
                 <p:nvSpPr>
                   <p:cNvPr id="17" name="CasellaDiTesto 16">
@@ -8371,8 +8370,8 @@
           <a:chExt cx="0" cy="0"/>
         </a:xfrm>
       </p:grpSpPr>
-      <mc:AlternateContent xmlns:mc="http://schemas.openxmlformats.org/markup-compatibility/2006">
-        <mc:Choice xmlns:a14="http://schemas.microsoft.com/office/drawing/2010/main" Requires="a14">
+      <mc:AlternateContent xmlns:mc="http://schemas.openxmlformats.org/markup-compatibility/2006" xmlns:a14="http://schemas.microsoft.com/office/drawing/2010/main">
+        <mc:Choice Requires="a14">
           <p:sp>
             <p:nvSpPr>
               <p:cNvPr id="4" name="Titolo 1">
@@ -8475,7 +8474,7 @@
             </p:txBody>
           </p:sp>
         </mc:Choice>
-        <mc:Fallback>
+        <mc:Fallback xmlns="">
           <p:sp>
             <p:nvSpPr>
               <p:cNvPr id="4" name="Titolo 1">
@@ -8626,8 +8625,8 @@
           </a:p>
         </p:txBody>
       </p:sp>
-      <mc:AlternateContent xmlns:mc="http://schemas.openxmlformats.org/markup-compatibility/2006">
-        <mc:Choice xmlns:a14="http://schemas.microsoft.com/office/drawing/2010/main" Requires="a14">
+      <mc:AlternateContent xmlns:mc="http://schemas.openxmlformats.org/markup-compatibility/2006" xmlns:a14="http://schemas.microsoft.com/office/drawing/2010/main">
+        <mc:Choice Requires="a14">
           <p:sp>
             <p:nvSpPr>
               <p:cNvPr id="16" name="CasellaDiTesto 15">
@@ -8678,7 +8677,7 @@
             </p:txBody>
           </p:sp>
         </mc:Choice>
-        <mc:Fallback>
+        <mc:Fallback xmlns="">
           <p:sp>
             <p:nvSpPr>
               <p:cNvPr id="16" name="CasellaDiTesto 15">
@@ -8802,8 +8801,8 @@
           <a:chExt cx="0" cy="0"/>
         </a:xfrm>
       </p:grpSpPr>
-      <mc:AlternateContent xmlns:mc="http://schemas.openxmlformats.org/markup-compatibility/2006">
-        <mc:Choice xmlns:a14="http://schemas.microsoft.com/office/drawing/2010/main" Requires="a14">
+      <mc:AlternateContent xmlns:mc="http://schemas.openxmlformats.org/markup-compatibility/2006" xmlns:a14="http://schemas.microsoft.com/office/drawing/2010/main">
+        <mc:Choice Requires="a14">
           <p:sp>
             <p:nvSpPr>
               <p:cNvPr id="4" name="Titolo 1">
@@ -8906,7 +8905,7 @@
             </p:txBody>
           </p:sp>
         </mc:Choice>
-        <mc:Fallback>
+        <mc:Fallback xmlns="">
           <p:sp>
             <p:nvSpPr>
               <p:cNvPr id="4" name="Titolo 1">
@@ -9021,8 +9020,8 @@
           </a:p>
         </p:txBody>
       </p:sp>
-      <mc:AlternateContent xmlns:mc="http://schemas.openxmlformats.org/markup-compatibility/2006">
-        <mc:Choice xmlns:a14="http://schemas.microsoft.com/office/drawing/2010/main" Requires="a14">
+      <mc:AlternateContent xmlns:mc="http://schemas.openxmlformats.org/markup-compatibility/2006" xmlns:a14="http://schemas.microsoft.com/office/drawing/2010/main">
+        <mc:Choice Requires="a14">
           <p:sp>
             <p:nvSpPr>
               <p:cNvPr id="13" name="CasellaDiTesto 12">
@@ -9073,7 +9072,7 @@
             </p:txBody>
           </p:sp>
         </mc:Choice>
-        <mc:Fallback>
+        <mc:Fallback xmlns="">
           <p:sp>
             <p:nvSpPr>
               <p:cNvPr id="13" name="CasellaDiTesto 12">
@@ -9154,8 +9153,8 @@
           </a:prstGeom>
         </p:spPr>
       </p:pic>
-      <mc:AlternateContent xmlns:mc="http://schemas.openxmlformats.org/markup-compatibility/2006">
-        <mc:Choice xmlns:a14="http://schemas.microsoft.com/office/drawing/2010/main" Requires="a14">
+      <mc:AlternateContent xmlns:mc="http://schemas.openxmlformats.org/markup-compatibility/2006" xmlns:a14="http://schemas.microsoft.com/office/drawing/2010/main">
+        <mc:Choice Requires="a14">
           <p:sp>
             <p:nvSpPr>
               <p:cNvPr id="7" name="CasellaDiTesto 6">
@@ -9210,7 +9209,7 @@
             </p:txBody>
           </p:sp>
         </mc:Choice>
-        <mc:Fallback>
+        <mc:Fallback xmlns="">
           <p:sp>
             <p:nvSpPr>
               <p:cNvPr id="7" name="CasellaDiTesto 6">
@@ -9339,8 +9338,8 @@
           <a:chExt cx="0" cy="0"/>
         </a:xfrm>
       </p:grpSpPr>
-      <mc:AlternateContent xmlns:mc="http://schemas.openxmlformats.org/markup-compatibility/2006">
-        <mc:Choice xmlns:a14="http://schemas.microsoft.com/office/drawing/2010/main" Requires="a14">
+      <mc:AlternateContent xmlns:mc="http://schemas.openxmlformats.org/markup-compatibility/2006" xmlns:a14="http://schemas.microsoft.com/office/drawing/2010/main">
+        <mc:Choice Requires="a14">
           <p:sp>
             <p:nvSpPr>
               <p:cNvPr id="4" name="Titolo 1">
@@ -9443,7 +9442,7 @@
             </p:txBody>
           </p:sp>
         </mc:Choice>
-        <mc:Fallback>
+        <mc:Fallback xmlns="">
           <p:sp>
             <p:nvSpPr>
               <p:cNvPr id="4" name="Titolo 1">
@@ -9522,8 +9521,8 @@
           </a:p>
         </p:txBody>
       </p:sp>
-      <mc:AlternateContent xmlns:mc="http://schemas.openxmlformats.org/markup-compatibility/2006">
-        <mc:Choice xmlns:a14="http://schemas.microsoft.com/office/drawing/2010/main" Requires="a14">
+      <mc:AlternateContent xmlns:mc="http://schemas.openxmlformats.org/markup-compatibility/2006" xmlns:a14="http://schemas.microsoft.com/office/drawing/2010/main">
+        <mc:Choice Requires="a14">
           <p:sp>
             <p:nvSpPr>
               <p:cNvPr id="13" name="CasellaDiTesto 12">
@@ -9574,7 +9573,7 @@
             </p:txBody>
           </p:sp>
         </mc:Choice>
-        <mc:Fallback>
+        <mc:Fallback xmlns="">
           <p:sp>
             <p:nvSpPr>
               <p:cNvPr id="13" name="CasellaDiTesto 12">
@@ -9733,8 +9732,8 @@
           <a:chExt cx="0" cy="0"/>
         </a:xfrm>
       </p:grpSpPr>
-      <mc:AlternateContent xmlns:mc="http://schemas.openxmlformats.org/markup-compatibility/2006">
-        <mc:Choice xmlns:a14="http://schemas.microsoft.com/office/drawing/2010/main" Requires="a14">
+      <mc:AlternateContent xmlns:mc="http://schemas.openxmlformats.org/markup-compatibility/2006" xmlns:a14="http://schemas.microsoft.com/office/drawing/2010/main">
+        <mc:Choice Requires="a14">
           <p:sp>
             <p:nvSpPr>
               <p:cNvPr id="4" name="Titolo 1">
@@ -9837,7 +9836,7 @@
             </p:txBody>
           </p:sp>
         </mc:Choice>
-        <mc:Fallback>
+        <mc:Fallback xmlns="">
           <p:sp>
             <p:nvSpPr>
               <p:cNvPr id="4" name="Titolo 1">
@@ -9917,8 +9916,8 @@
           </a:prstGeom>
         </p:spPr>
       </p:pic>
-      <mc:AlternateContent xmlns:mc="http://schemas.openxmlformats.org/markup-compatibility/2006">
-        <mc:Choice xmlns:a14="http://schemas.microsoft.com/office/drawing/2010/main" Requires="a14">
+      <mc:AlternateContent xmlns:mc="http://schemas.openxmlformats.org/markup-compatibility/2006" xmlns:a14="http://schemas.microsoft.com/office/drawing/2010/main">
+        <mc:Choice Requires="a14">
           <p:sp>
             <p:nvSpPr>
               <p:cNvPr id="5" name="CasellaDiTesto 4">
@@ -9977,7 +9976,7 @@
             </p:txBody>
           </p:sp>
         </mc:Choice>
-        <mc:Fallback>
+        <mc:Fallback xmlns="">
           <p:sp>
             <p:nvSpPr>
               <p:cNvPr id="5" name="CasellaDiTesto 4">
@@ -10062,8 +10061,8 @@
           </a:p>
         </p:txBody>
       </p:sp>
-      <mc:AlternateContent xmlns:mc="http://schemas.openxmlformats.org/markup-compatibility/2006">
-        <mc:Choice xmlns:a14="http://schemas.microsoft.com/office/drawing/2010/main" Requires="a14">
+      <mc:AlternateContent xmlns:mc="http://schemas.openxmlformats.org/markup-compatibility/2006" xmlns:a14="http://schemas.microsoft.com/office/drawing/2010/main">
+        <mc:Choice Requires="a14">
           <p:sp>
             <p:nvSpPr>
               <p:cNvPr id="8" name="CasellaDiTesto 7">
@@ -10114,7 +10113,7 @@
             </p:txBody>
           </p:sp>
         </mc:Choice>
-        <mc:Fallback>
+        <mc:Fallback xmlns="">
           <p:sp>
             <p:nvSpPr>
               <p:cNvPr id="8" name="CasellaDiTesto 7">
@@ -10237,8 +10236,8 @@
           <a:chExt cx="0" cy="0"/>
         </a:xfrm>
       </p:grpSpPr>
-      <mc:AlternateContent xmlns:mc="http://schemas.openxmlformats.org/markup-compatibility/2006">
-        <mc:Choice xmlns:a14="http://schemas.microsoft.com/office/drawing/2010/main" Requires="a14">
+      <mc:AlternateContent xmlns:mc="http://schemas.openxmlformats.org/markup-compatibility/2006" xmlns:a14="http://schemas.microsoft.com/office/drawing/2010/main">
+        <mc:Choice Requires="a14">
           <p:sp>
             <p:nvSpPr>
               <p:cNvPr id="4" name="Titolo 1">
@@ -10341,7 +10340,7 @@
             </p:txBody>
           </p:sp>
         </mc:Choice>
-        <mc:Fallback>
+        <mc:Fallback xmlns="">
           <p:sp>
             <p:nvSpPr>
               <p:cNvPr id="4" name="Titolo 1">
@@ -10456,8 +10455,8 @@
           </a:prstGeom>
         </p:spPr>
       </p:pic>
-      <mc:AlternateContent xmlns:mc="http://schemas.openxmlformats.org/markup-compatibility/2006">
-        <mc:Choice xmlns:a14="http://schemas.microsoft.com/office/drawing/2010/main" Requires="a14">
+      <mc:AlternateContent xmlns:mc="http://schemas.openxmlformats.org/markup-compatibility/2006" xmlns:a14="http://schemas.microsoft.com/office/drawing/2010/main">
+        <mc:Choice Requires="a14">
           <p:graphicFrame>
             <p:nvGraphicFramePr>
               <p:cNvPr id="6" name="Tabella 5">
@@ -10510,6 +10509,7 @@
                         <a:bodyPr/>
                         <a:lstStyle/>
                         <a:p>
+                          <a:pPr/>
                           <a14:m>
                             <m:oMathPara xmlns:m="http://schemas.openxmlformats.org/officeDocument/2006/math">
                               <m:oMathParaPr>
@@ -10554,6 +10554,7 @@
                         <a:bodyPr/>
                         <a:lstStyle/>
                         <a:p>
+                          <a:pPr/>
                           <a14:m>
                             <m:oMathPara xmlns:m="http://schemas.openxmlformats.org/officeDocument/2006/math">
                               <m:oMathParaPr>
@@ -10605,6 +10606,7 @@
                         <a:bodyPr/>
                         <a:lstStyle/>
                         <a:p>
+                          <a:pPr/>
                           <a14:m>
                             <m:oMathPara xmlns:m="http://schemas.openxmlformats.org/officeDocument/2006/math">
                               <m:oMathParaPr>
@@ -10663,6 +10665,7 @@
                         <a:bodyPr/>
                         <a:lstStyle/>
                         <a:p>
+                          <a:pPr/>
                           <a14:m>
                             <m:oMathPara xmlns:m="http://schemas.openxmlformats.org/officeDocument/2006/math">
                               <m:oMathParaPr>
@@ -10721,7 +10724,7 @@
             </a:graphic>
           </p:graphicFrame>
         </mc:Choice>
-        <mc:Fallback>
+        <mc:Fallback xmlns="">
           <p:graphicFrame>
             <p:nvGraphicFramePr>
               <p:cNvPr id="6" name="Tabella 5">
@@ -10856,8 +10859,8 @@
           </p:graphicFrame>
         </mc:Fallback>
       </mc:AlternateContent>
-      <mc:AlternateContent xmlns:mc="http://schemas.openxmlformats.org/markup-compatibility/2006">
-        <mc:Choice xmlns:a14="http://schemas.microsoft.com/office/drawing/2010/main" Requires="a14">
+      <mc:AlternateContent xmlns:mc="http://schemas.openxmlformats.org/markup-compatibility/2006" xmlns:a14="http://schemas.microsoft.com/office/drawing/2010/main">
+        <mc:Choice Requires="a14">
           <p:graphicFrame>
             <p:nvGraphicFramePr>
               <p:cNvPr id="7" name="Tabella 6">
@@ -10995,7 +10998,7 @@
             </a:graphic>
           </p:graphicFrame>
         </mc:Choice>
-        <mc:Fallback>
+        <mc:Fallback xmlns="">
           <p:graphicFrame>
             <p:nvGraphicFramePr>
               <p:cNvPr id="7" name="Tabella 6">
@@ -11089,8 +11092,8 @@
           </p:graphicFrame>
         </mc:Fallback>
       </mc:AlternateContent>
-      <mc:AlternateContent xmlns:mc="http://schemas.openxmlformats.org/markup-compatibility/2006">
-        <mc:Choice xmlns:a14="http://schemas.microsoft.com/office/drawing/2010/main" Requires="a14">
+      <mc:AlternateContent xmlns:mc="http://schemas.openxmlformats.org/markup-compatibility/2006" xmlns:a14="http://schemas.microsoft.com/office/drawing/2010/main">
+        <mc:Choice Requires="a14">
           <p:graphicFrame>
             <p:nvGraphicFramePr>
               <p:cNvPr id="8" name="Tabella 7">
@@ -11352,7 +11355,7 @@
             </a:graphic>
           </p:graphicFrame>
         </mc:Choice>
-        <mc:Fallback>
+        <mc:Fallback xmlns="">
           <p:graphicFrame>
             <p:nvGraphicFramePr>
               <p:cNvPr id="8" name="Tabella 7">
@@ -11505,1014 +11508,6 @@
   <p:cSld>
     <p:spTree>
       <p:nvGrpSpPr>
-        <p:cNvPr id="1" name=""/>
-        <p:cNvGrpSpPr/>
-        <p:nvPr/>
-      </p:nvGrpSpPr>
-      <p:grpSpPr>
-        <a:xfrm>
-          <a:off x="0" y="0"/>
-          <a:ext cx="0" cy="0"/>
-          <a:chOff x="0" y="0"/>
-          <a:chExt cx="0" cy="0"/>
-        </a:xfrm>
-      </p:grpSpPr>
-      <p:sp>
-        <p:nvSpPr>
-          <p:cNvPr id="2" name="Titolo 1">
-            <a:extLst>
-              <a:ext uri="{FF2B5EF4-FFF2-40B4-BE49-F238E27FC236}">
-                <a16:creationId xmlns:a16="http://schemas.microsoft.com/office/drawing/2014/main" id="{32DF931F-0CE4-A645-A0BF-7F3424E181B3}"/>
-              </a:ext>
-            </a:extLst>
-          </p:cNvPr>
-          <p:cNvSpPr>
-            <a:spLocks noGrp="1"/>
-          </p:cNvSpPr>
-          <p:nvPr>
-            <p:ph type="title"/>
-          </p:nvPr>
-        </p:nvSpPr>
-        <p:spPr/>
-        <p:txBody>
-          <a:bodyPr/>
-          <a:lstStyle/>
-          <a:p>
-            <a:endParaRPr lang="en-US" noProof="0" dirty="0"/>
-          </a:p>
-        </p:txBody>
-      </p:sp>
-      <mc:AlternateContent xmlns:mc="http://schemas.openxmlformats.org/markup-compatibility/2006">
-        <mc:Choice xmlns:a14="http://schemas.microsoft.com/office/drawing/2010/main" Requires="a14">
-          <p:graphicFrame>
-            <p:nvGraphicFramePr>
-              <p:cNvPr id="4" name="Tabella 3">
-                <a:extLst>
-                  <a:ext uri="{FF2B5EF4-FFF2-40B4-BE49-F238E27FC236}">
-                    <a16:creationId xmlns:a16="http://schemas.microsoft.com/office/drawing/2014/main" id="{AE0AB884-D705-0F16-784C-E77C80F014EF}"/>
-                  </a:ext>
-                </a:extLst>
-              </p:cNvPr>
-              <p:cNvGraphicFramePr>
-                <a:graphicFrameLocks noGrp="1"/>
-              </p:cNvGraphicFramePr>
-              <p:nvPr>
-                <p:extLst>
-                  <p:ext uri="{D42A27DB-BD31-4B8C-83A1-F6EECF244321}">
-                    <p14:modId xmlns:p14="http://schemas.microsoft.com/office/powerpoint/2010/main" val="97632566"/>
-                  </p:ext>
-                </p:extLst>
-              </p:nvPr>
-            </p:nvGraphicFramePr>
-            <p:xfrm>
-              <a:off x="1918984" y="2687320"/>
-              <a:ext cx="8128000" cy="1118553"/>
-            </p:xfrm>
-            <a:graphic>
-              <a:graphicData uri="http://schemas.openxmlformats.org/drawingml/2006/table">
-                <a:tbl>
-                  <a:tblPr firstRow="1" bandRow="1">
-                    <a:tableStyleId>{5C22544A-7EE6-4342-B048-85BDC9FD1C3A}</a:tableStyleId>
-                  </a:tblPr>
-                  <a:tblGrid>
-                    <a:gridCol w="1625600">
-                      <a:extLst>
-                        <a:ext uri="{9D8B030D-6E8A-4147-A177-3AD203B41FA5}">
-                          <a16:colId xmlns:a16="http://schemas.microsoft.com/office/drawing/2014/main" val="500066530"/>
-                        </a:ext>
-                      </a:extLst>
-                    </a:gridCol>
-                    <a:gridCol w="1625600">
-                      <a:extLst>
-                        <a:ext uri="{9D8B030D-6E8A-4147-A177-3AD203B41FA5}">
-                          <a16:colId xmlns:a16="http://schemas.microsoft.com/office/drawing/2014/main" val="1819855302"/>
-                        </a:ext>
-                      </a:extLst>
-                    </a:gridCol>
-                    <a:gridCol w="1625600">
-                      <a:extLst>
-                        <a:ext uri="{9D8B030D-6E8A-4147-A177-3AD203B41FA5}">
-                          <a16:colId xmlns:a16="http://schemas.microsoft.com/office/drawing/2014/main" val="4011376178"/>
-                        </a:ext>
-                      </a:extLst>
-                    </a:gridCol>
-                    <a:gridCol w="1625600">
-                      <a:extLst>
-                        <a:ext uri="{9D8B030D-6E8A-4147-A177-3AD203B41FA5}">
-                          <a16:colId xmlns:a16="http://schemas.microsoft.com/office/drawing/2014/main" val="1305298267"/>
-                        </a:ext>
-                      </a:extLst>
-                    </a:gridCol>
-                    <a:gridCol w="1625600">
-                      <a:extLst>
-                        <a:ext uri="{9D8B030D-6E8A-4147-A177-3AD203B41FA5}">
-                          <a16:colId xmlns:a16="http://schemas.microsoft.com/office/drawing/2014/main" val="4118232767"/>
-                        </a:ext>
-                      </a:extLst>
-                    </a:gridCol>
-                  </a:tblGrid>
-                  <a:tr h="370840">
-                    <a:tc>
-                      <a:txBody>
-                        <a:bodyPr/>
-                        <a:lstStyle/>
-                        <a:p>
-                          <a:pPr/>
-                          <a14:m>
-                            <m:oMathPara xmlns:m="http://schemas.openxmlformats.org/officeDocument/2006/math">
-                              <m:oMathParaPr>
-                                <m:jc m:val="centerGroup"/>
-                              </m:oMathParaPr>
-                              <m:oMath xmlns:m="http://schemas.openxmlformats.org/officeDocument/2006/math">
-                                <m:r>
-                                  <a:rPr lang="en-US" b="1" i="1" noProof="0" smtClean="0">
-                                    <a:latin typeface="Cambria Math" panose="02040503050406030204" pitchFamily="18" charset="0"/>
-                                  </a:rPr>
-                                  <m:t>𝒘</m:t>
-                                </m:r>
-                              </m:oMath>
-                            </m:oMathPara>
-                          </a14:m>
-                          <a:endParaRPr lang="en-US" b="1" noProof="0" dirty="0"/>
-                        </a:p>
-                      </a:txBody>
-                      <a:tcPr/>
-                    </a:tc>
-                    <a:tc>
-                      <a:txBody>
-                        <a:bodyPr/>
-                        <a:lstStyle/>
-                        <a:p>
-                          <a:pPr/>
-                          <a14:m>
-                            <m:oMathPara xmlns:m="http://schemas.openxmlformats.org/officeDocument/2006/math">
-                              <m:oMathParaPr>
-                                <m:jc m:val="centerGroup"/>
-                              </m:oMathParaPr>
-                              <m:oMath xmlns:m="http://schemas.openxmlformats.org/officeDocument/2006/math">
-                                <m:sSub>
-                                  <m:sSubPr>
-                                    <m:ctrlPr>
-                                      <a:rPr lang="en-US" b="1" i="1" noProof="0" smtClean="0">
-                                        <a:latin typeface="Cambria Math" panose="02040503050406030204" pitchFamily="18" charset="0"/>
-                                      </a:rPr>
-                                    </m:ctrlPr>
-                                  </m:sSubPr>
-                                  <m:e>
-                                    <m:r>
-                                      <a:rPr lang="en-US" b="1" i="1" noProof="0" smtClean="0">
-                                        <a:latin typeface="Cambria Math" panose="02040503050406030204" pitchFamily="18" charset="0"/>
-                                      </a:rPr>
-                                      <m:t>𝝁</m:t>
-                                    </m:r>
-                                  </m:e>
-                                  <m:sub>
-                                    <m:r>
-                                      <a:rPr lang="en-US" b="1" i="1" noProof="0" smtClean="0">
-                                        <a:latin typeface="Cambria Math" panose="02040503050406030204" pitchFamily="18" charset="0"/>
-                                      </a:rPr>
-                                      <m:t>𝟏</m:t>
-                                    </m:r>
-                                  </m:sub>
-                                </m:sSub>
-                              </m:oMath>
-                            </m:oMathPara>
-                          </a14:m>
-                          <a:endParaRPr lang="en-US" b="1" noProof="0" dirty="0"/>
-                        </a:p>
-                      </a:txBody>
-                      <a:tcPr/>
-                    </a:tc>
-                    <a:tc>
-                      <a:txBody>
-                        <a:bodyPr/>
-                        <a:lstStyle/>
-                        <a:p>
-                          <a:pPr marL="0" marR="0" lvl="0" indent="0" algn="l" defTabSz="914400" rtl="0" eaLnBrk="1" fontAlgn="auto" latinLnBrk="0" hangingPunct="1">
-                            <a:lnSpc>
-                              <a:spcPct val="100000"/>
-                            </a:lnSpc>
-                            <a:spcBef>
-                              <a:spcPts val="0"/>
-                            </a:spcBef>
-                            <a:spcAft>
-                              <a:spcPts val="0"/>
-                            </a:spcAft>
-                            <a:buClrTx/>
-                            <a:buSzTx/>
-                            <a:buFontTx/>
-                            <a:buNone/>
-                            <a:tabLst/>
-                            <a:defRPr/>
-                          </a:pPr>
-                          <a14:m>
-                            <m:oMathPara xmlns:m="http://schemas.openxmlformats.org/officeDocument/2006/math">
-                              <m:oMathParaPr>
-                                <m:jc m:val="centerGroup"/>
-                              </m:oMathParaPr>
-                              <m:oMath xmlns:m="http://schemas.openxmlformats.org/officeDocument/2006/math">
-                                <m:sSub>
-                                  <m:sSubPr>
-                                    <m:ctrlPr>
-                                      <a:rPr lang="en-US" b="1" i="1" noProof="0" smtClean="0">
-                                        <a:latin typeface="Cambria Math" panose="02040503050406030204" pitchFamily="18" charset="0"/>
-                                      </a:rPr>
-                                    </m:ctrlPr>
-                                  </m:sSubPr>
-                                  <m:e>
-                                    <m:r>
-                                      <a:rPr lang="en-US" b="1" i="1" noProof="0" smtClean="0">
-                                        <a:latin typeface="Cambria Math" panose="02040503050406030204" pitchFamily="18" charset="0"/>
-                                      </a:rPr>
-                                      <m:t>𝝈</m:t>
-                                    </m:r>
-                                  </m:e>
-                                  <m:sub>
-                                    <m:r>
-                                      <a:rPr lang="en-US" b="1" i="1" noProof="0" smtClean="0">
-                                        <a:latin typeface="Cambria Math" panose="02040503050406030204" pitchFamily="18" charset="0"/>
-                                      </a:rPr>
-                                      <m:t>𝟏</m:t>
-                                    </m:r>
-                                  </m:sub>
-                                </m:sSub>
-                              </m:oMath>
-                            </m:oMathPara>
-                          </a14:m>
-                          <a:endParaRPr lang="en-US" b="1" noProof="0" dirty="0"/>
-                        </a:p>
-                      </a:txBody>
-                      <a:tcPr/>
-                    </a:tc>
-                    <a:tc>
-                      <a:txBody>
-                        <a:bodyPr/>
-                        <a:lstStyle/>
-                        <a:p>
-                          <a:pPr/>
-                          <a14:m>
-                            <m:oMathPara xmlns:m="http://schemas.openxmlformats.org/officeDocument/2006/math">
-                              <m:oMathParaPr>
-                                <m:jc m:val="centerGroup"/>
-                              </m:oMathParaPr>
-                              <m:oMath xmlns:m="http://schemas.openxmlformats.org/officeDocument/2006/math">
-                                <m:sSub>
-                                  <m:sSubPr>
-                                    <m:ctrlPr>
-                                      <a:rPr lang="en-US" b="1" i="1" noProof="0" smtClean="0">
-                                        <a:latin typeface="Cambria Math" panose="02040503050406030204" pitchFamily="18" charset="0"/>
-                                      </a:rPr>
-                                    </m:ctrlPr>
-                                  </m:sSubPr>
-                                  <m:e>
-                                    <m:r>
-                                      <a:rPr lang="en-US" b="1" i="1" noProof="0" smtClean="0">
-                                        <a:latin typeface="Cambria Math" panose="02040503050406030204" pitchFamily="18" charset="0"/>
-                                      </a:rPr>
-                                      <m:t>𝝁</m:t>
-                                    </m:r>
-                                  </m:e>
-                                  <m:sub>
-                                    <m:r>
-                                      <a:rPr lang="en-US" b="1" i="1" noProof="0" smtClean="0">
-                                        <a:latin typeface="Cambria Math" panose="02040503050406030204" pitchFamily="18" charset="0"/>
-                                      </a:rPr>
-                                      <m:t>𝟐</m:t>
-                                    </m:r>
-                                  </m:sub>
-                                </m:sSub>
-                              </m:oMath>
-                            </m:oMathPara>
-                          </a14:m>
-                          <a:endParaRPr lang="en-US" b="1" noProof="0" dirty="0"/>
-                        </a:p>
-                      </a:txBody>
-                      <a:tcPr/>
-                    </a:tc>
-                    <a:tc>
-                      <a:txBody>
-                        <a:bodyPr/>
-                        <a:lstStyle/>
-                        <a:p>
-                          <a:pPr/>
-                          <a14:m>
-                            <m:oMathPara xmlns:m="http://schemas.openxmlformats.org/officeDocument/2006/math">
-                              <m:oMathParaPr>
-                                <m:jc m:val="centerGroup"/>
-                              </m:oMathParaPr>
-                              <m:oMath xmlns:m="http://schemas.openxmlformats.org/officeDocument/2006/math">
-                                <m:sSub>
-                                  <m:sSubPr>
-                                    <m:ctrlPr>
-                                      <a:rPr lang="en-US" b="1" i="1" noProof="0" smtClean="0">
-                                        <a:latin typeface="Cambria Math" panose="02040503050406030204" pitchFamily="18" charset="0"/>
-                                      </a:rPr>
-                                    </m:ctrlPr>
-                                  </m:sSubPr>
-                                  <m:e>
-                                    <m:r>
-                                      <a:rPr lang="en-US" b="1" i="1" noProof="0" smtClean="0">
-                                        <a:latin typeface="Cambria Math" panose="02040503050406030204" pitchFamily="18" charset="0"/>
-                                      </a:rPr>
-                                      <m:t>𝝈</m:t>
-                                    </m:r>
-                                  </m:e>
-                                  <m:sub>
-                                    <m:r>
-                                      <a:rPr lang="en-US" b="1" i="1" noProof="0" smtClean="0">
-                                        <a:latin typeface="Cambria Math" panose="02040503050406030204" pitchFamily="18" charset="0"/>
-                                      </a:rPr>
-                                      <m:t>𝟐</m:t>
-                                    </m:r>
-                                  </m:sub>
-                                </m:sSub>
-                              </m:oMath>
-                            </m:oMathPara>
-                          </a14:m>
-                          <a:endParaRPr lang="en-US" b="1" noProof="0" dirty="0"/>
-                        </a:p>
-                      </a:txBody>
-                      <a:tcPr/>
-                    </a:tc>
-                    <a:extLst>
-                      <a:ext uri="{0D108BD9-81ED-4DB2-BD59-A6C34878D82A}">
-                        <a16:rowId xmlns:a16="http://schemas.microsoft.com/office/drawing/2014/main" val="235488845"/>
-                      </a:ext>
-                    </a:extLst>
-                  </a:tr>
-                  <a:tr h="370840">
-                    <a:tc>
-                      <a:txBody>
-                        <a:bodyPr/>
-                        <a:lstStyle/>
-                        <a:p>
-                          <a:pPr/>
-                          <a14:m>
-                            <m:oMathPara xmlns:m="http://schemas.openxmlformats.org/officeDocument/2006/math">
-                              <m:oMathParaPr>
-                                <m:jc m:val="centerGroup"/>
-                              </m:oMathParaPr>
-                              <m:oMath xmlns:m="http://schemas.openxmlformats.org/officeDocument/2006/math">
-                                <m:sSubSup>
-                                  <m:sSubSupPr>
-                                    <m:ctrlPr>
-                                      <a:rPr lang="en-US" i="1" noProof="0" smtClean="0">
-                                        <a:latin typeface="Cambria Math" panose="02040503050406030204" pitchFamily="18" charset="0"/>
-                                      </a:rPr>
-                                    </m:ctrlPr>
-                                  </m:sSubSupPr>
-                                  <m:e>
-                                    <m:r>
-                                      <a:rPr lang="en-US" i="1" noProof="0" smtClean="0">
-                                        <a:latin typeface="Cambria Math" panose="02040503050406030204" pitchFamily="18" charset="0"/>
-                                      </a:rPr>
-                                      <m:t>0.326</m:t>
-                                    </m:r>
-                                  </m:e>
-                                  <m:sub>
-                                    <m:r>
-                                      <a:rPr lang="en-US" i="1" noProof="0" smtClean="0">
-                                        <a:latin typeface="Cambria Math" panose="02040503050406030204" pitchFamily="18" charset="0"/>
-                                      </a:rPr>
-                                      <m:t>−0.020</m:t>
-                                    </m:r>
-                                  </m:sub>
-                                  <m:sup>
-                                    <m:r>
-                                      <a:rPr lang="en-US" i="1" noProof="0" smtClean="0">
-                                        <a:latin typeface="Cambria Math" panose="02040503050406030204" pitchFamily="18" charset="0"/>
-                                      </a:rPr>
-                                      <m:t>+0.024</m:t>
-                                    </m:r>
-                                  </m:sup>
-                                </m:sSubSup>
-                              </m:oMath>
-                            </m:oMathPara>
-                          </a14:m>
-                          <a:endParaRPr lang="en-US" noProof="0" dirty="0"/>
-                        </a:p>
-                      </a:txBody>
-                      <a:tcPr/>
-                    </a:tc>
-                    <a:tc>
-                      <a:txBody>
-                        <a:bodyPr/>
-                        <a:lstStyle/>
-                        <a:p>
-                          <a:pPr/>
-                          <a14:m>
-                            <m:oMathPara xmlns:m="http://schemas.openxmlformats.org/officeDocument/2006/math">
-                              <m:oMathParaPr>
-                                <m:jc m:val="centerGroup"/>
-                              </m:oMathParaPr>
-                              <m:oMath xmlns:m="http://schemas.openxmlformats.org/officeDocument/2006/math">
-                                <m:r>
-                                  <a:rPr lang="en-US" i="1" noProof="0" smtClean="0">
-                                    <a:latin typeface="Cambria Math" panose="02040503050406030204" pitchFamily="18" charset="0"/>
-                                  </a:rPr>
-                                  <m:t>−</m:t>
-                                </m:r>
-                                <m:sSubSup>
-                                  <m:sSubSupPr>
-                                    <m:ctrlPr>
-                                      <a:rPr lang="en-US" i="1" noProof="0" smtClean="0">
-                                        <a:latin typeface="Cambria Math" panose="02040503050406030204" pitchFamily="18" charset="0"/>
-                                      </a:rPr>
-                                    </m:ctrlPr>
-                                  </m:sSubSupPr>
-                                  <m:e>
-                                    <m:r>
-                                      <a:rPr lang="en-US" i="1" noProof="0" smtClean="0">
-                                        <a:latin typeface="Cambria Math" panose="02040503050406030204" pitchFamily="18" charset="0"/>
-                                      </a:rPr>
-                                      <m:t>0.18</m:t>
-                                    </m:r>
-                                  </m:e>
-                                  <m:sub>
-                                    <m:r>
-                                      <a:rPr lang="en-US" i="1" noProof="0" smtClean="0">
-                                        <a:latin typeface="Cambria Math" panose="02040503050406030204" pitchFamily="18" charset="0"/>
-                                      </a:rPr>
-                                      <m:t>−0.14</m:t>
-                                    </m:r>
-                                  </m:sub>
-                                  <m:sup>
-                                    <m:r>
-                                      <a:rPr lang="en-US" i="1" noProof="0" smtClean="0">
-                                        <a:latin typeface="Cambria Math" panose="02040503050406030204" pitchFamily="18" charset="0"/>
-                                      </a:rPr>
-                                      <m:t>+0.15</m:t>
-                                    </m:r>
-                                  </m:sup>
-                                </m:sSubSup>
-                              </m:oMath>
-                            </m:oMathPara>
-                          </a14:m>
-                          <a:endParaRPr lang="en-US" noProof="0" dirty="0"/>
-                        </a:p>
-                      </a:txBody>
-                      <a:tcPr/>
-                    </a:tc>
-                    <a:tc>
-                      <a:txBody>
-                        <a:bodyPr/>
-                        <a:lstStyle/>
-                        <a:p>
-                          <a:pPr/>
-                          <a14:m>
-                            <m:oMathPara xmlns:m="http://schemas.openxmlformats.org/officeDocument/2006/math">
-                              <m:oMathParaPr>
-                                <m:jc m:val="centerGroup"/>
-                              </m:oMathParaPr>
-                              <m:oMath xmlns:m="http://schemas.openxmlformats.org/officeDocument/2006/math">
-                                <m:sSubSup>
-                                  <m:sSubSupPr>
-                                    <m:ctrlPr>
-                                      <a:rPr lang="en-US" i="1" noProof="0" smtClean="0">
-                                        <a:latin typeface="Cambria Math" panose="02040503050406030204" pitchFamily="18" charset="0"/>
-                                      </a:rPr>
-                                    </m:ctrlPr>
-                                  </m:sSubSupPr>
-                                  <m:e>
-                                    <m:r>
-                                      <a:rPr lang="en-US" i="1" noProof="0" smtClean="0">
-                                        <a:latin typeface="Cambria Math" panose="02040503050406030204" pitchFamily="18" charset="0"/>
-                                      </a:rPr>
-                                      <m:t>1.48</m:t>
-                                    </m:r>
-                                  </m:e>
-                                  <m:sub>
-                                    <m:r>
-                                      <a:rPr lang="en-US" i="1" noProof="0" smtClean="0">
-                                        <a:latin typeface="Cambria Math" panose="02040503050406030204" pitchFamily="18" charset="0"/>
-                                      </a:rPr>
-                                      <m:t>−0.10</m:t>
-                                    </m:r>
-                                  </m:sub>
-                                  <m:sup>
-                                    <m:r>
-                                      <a:rPr lang="en-US" i="1" noProof="0" smtClean="0">
-                                        <a:latin typeface="Cambria Math" panose="02040503050406030204" pitchFamily="18" charset="0"/>
-                                      </a:rPr>
-                                      <m:t>+0.12</m:t>
-                                    </m:r>
-                                  </m:sup>
-                                </m:sSubSup>
-                              </m:oMath>
-                            </m:oMathPara>
-                          </a14:m>
-                          <a:endParaRPr lang="en-US" noProof="0" dirty="0"/>
-                        </a:p>
-                      </a:txBody>
-                      <a:tcPr/>
-                    </a:tc>
-                    <a:tc>
-                      <a:txBody>
-                        <a:bodyPr/>
-                        <a:lstStyle/>
-                        <a:p>
-                          <a:pPr/>
-                          <a14:m>
-                            <m:oMathPara xmlns:m="http://schemas.openxmlformats.org/officeDocument/2006/math">
-                              <m:oMathParaPr>
-                                <m:jc m:val="centerGroup"/>
-                              </m:oMathParaPr>
-                              <m:oMath xmlns:m="http://schemas.openxmlformats.org/officeDocument/2006/math">
-                                <m:sSubSup>
-                                  <m:sSubSupPr>
-                                    <m:ctrlPr>
-                                      <a:rPr lang="en-US" i="1" noProof="0" smtClean="0">
-                                        <a:latin typeface="Cambria Math" panose="02040503050406030204" pitchFamily="18" charset="0"/>
-                                      </a:rPr>
-                                    </m:ctrlPr>
-                                  </m:sSubSupPr>
-                                  <m:e>
-                                    <m:r>
-                                      <a:rPr lang="en-US" i="1" noProof="0" smtClean="0">
-                                        <a:latin typeface="Cambria Math" panose="02040503050406030204" pitchFamily="18" charset="0"/>
-                                      </a:rPr>
-                                      <m:t>3.56</m:t>
-                                    </m:r>
-                                  </m:e>
-                                  <m:sub>
-                                    <m:r>
-                                      <a:rPr lang="en-US" i="1" noProof="0" smtClean="0">
-                                        <a:latin typeface="Cambria Math" panose="02040503050406030204" pitchFamily="18" charset="0"/>
-                                      </a:rPr>
-                                      <m:t>−0.050</m:t>
-                                    </m:r>
-                                  </m:sub>
-                                  <m:sup>
-                                    <m:r>
-                                      <a:rPr lang="en-US" i="1" noProof="0" smtClean="0">
-                                        <a:latin typeface="Cambria Math" panose="02040503050406030204" pitchFamily="18" charset="0"/>
-                                      </a:rPr>
-                                      <m:t>+0.048</m:t>
-                                    </m:r>
-                                  </m:sup>
-                                </m:sSubSup>
-                              </m:oMath>
-                            </m:oMathPara>
-                          </a14:m>
-                          <a:endParaRPr lang="en-US" noProof="0" dirty="0"/>
-                        </a:p>
-                      </a:txBody>
-                      <a:tcPr/>
-                    </a:tc>
-                    <a:tc>
-                      <a:txBody>
-                        <a:bodyPr/>
-                        <a:lstStyle/>
-                        <a:p>
-                          <a:pPr/>
-                          <a14:m>
-                            <m:oMathPara xmlns:m="http://schemas.openxmlformats.org/officeDocument/2006/math">
-                              <m:oMathParaPr>
-                                <m:jc m:val="centerGroup"/>
-                              </m:oMathParaPr>
-                              <m:oMath xmlns:m="http://schemas.openxmlformats.org/officeDocument/2006/math">
-                                <m:sSubSup>
-                                  <m:sSubSupPr>
-                                    <m:ctrlPr>
-                                      <a:rPr lang="en-US" i="1" noProof="0" smtClean="0">
-                                        <a:latin typeface="Cambria Math" panose="02040503050406030204" pitchFamily="18" charset="0"/>
-                                      </a:rPr>
-                                    </m:ctrlPr>
-                                  </m:sSubSupPr>
-                                  <m:e>
-                                    <m:r>
-                                      <a:rPr lang="en-US" i="1" noProof="0" smtClean="0">
-                                        <a:latin typeface="Cambria Math" panose="02040503050406030204" pitchFamily="18" charset="0"/>
-                                      </a:rPr>
-                                      <m:t>0.982</m:t>
-                                    </m:r>
-                                  </m:e>
-                                  <m:sub>
-                                    <m:r>
-                                      <a:rPr lang="en-US" i="1" noProof="0" smtClean="0">
-                                        <a:latin typeface="Cambria Math" panose="02040503050406030204" pitchFamily="18" charset="0"/>
-                                      </a:rPr>
-                                      <m:t>−0.033</m:t>
-                                    </m:r>
-                                  </m:sub>
-                                  <m:sup>
-                                    <m:r>
-                                      <a:rPr lang="en-US" i="1" noProof="0" smtClean="0">
-                                        <a:latin typeface="Cambria Math" panose="02040503050406030204" pitchFamily="18" charset="0"/>
-                                      </a:rPr>
-                                      <m:t>+0.035</m:t>
-                                    </m:r>
-                                  </m:sup>
-                                </m:sSubSup>
-                              </m:oMath>
-                            </m:oMathPara>
-                          </a14:m>
-                          <a:endParaRPr lang="en-US" noProof="0" dirty="0"/>
-                        </a:p>
-                      </a:txBody>
-                      <a:tcPr/>
-                    </a:tc>
-                    <a:extLst>
-                      <a:ext uri="{0D108BD9-81ED-4DB2-BD59-A6C34878D82A}">
-                        <a16:rowId xmlns:a16="http://schemas.microsoft.com/office/drawing/2014/main" val="3320676961"/>
-                      </a:ext>
-                    </a:extLst>
-                  </a:tr>
-                  <a:tr h="370840">
-                    <a:tc>
-                      <a:txBody>
-                        <a:bodyPr/>
-                        <a:lstStyle/>
-                        <a:p>
-                          <a:endParaRPr lang="en-US" noProof="0" dirty="0"/>
-                        </a:p>
-                      </a:txBody>
-                      <a:tcPr/>
-                    </a:tc>
-                    <a:tc>
-                      <a:txBody>
-                        <a:bodyPr/>
-                        <a:lstStyle/>
-                        <a:p>
-                          <a:endParaRPr lang="en-US" noProof="0" dirty="0"/>
-                        </a:p>
-                      </a:txBody>
-                      <a:tcPr/>
-                    </a:tc>
-                    <a:tc>
-                      <a:txBody>
-                        <a:bodyPr/>
-                        <a:lstStyle/>
-                        <a:p>
-                          <a:endParaRPr lang="en-US" noProof="0" dirty="0"/>
-                        </a:p>
-                      </a:txBody>
-                      <a:tcPr/>
-                    </a:tc>
-                    <a:tc>
-                      <a:txBody>
-                        <a:bodyPr/>
-                        <a:lstStyle/>
-                        <a:p>
-                          <a:endParaRPr lang="en-US" noProof="0" dirty="0"/>
-                        </a:p>
-                      </a:txBody>
-                      <a:tcPr/>
-                    </a:tc>
-                    <a:tc>
-                      <a:txBody>
-                        <a:bodyPr/>
-                        <a:lstStyle/>
-                        <a:p>
-                          <a:endParaRPr lang="en-US" noProof="0" dirty="0"/>
-                        </a:p>
-                      </a:txBody>
-                      <a:tcPr/>
-                    </a:tc>
-                    <a:extLst>
-                      <a:ext uri="{0D108BD9-81ED-4DB2-BD59-A6C34878D82A}">
-                        <a16:rowId xmlns:a16="http://schemas.microsoft.com/office/drawing/2014/main" val="3412315347"/>
-                      </a:ext>
-                    </a:extLst>
-                  </a:tr>
-                </a:tbl>
-              </a:graphicData>
-            </a:graphic>
-          </p:graphicFrame>
-        </mc:Choice>
-        <mc:Fallback>
-          <p:graphicFrame>
-            <p:nvGraphicFramePr>
-              <p:cNvPr id="4" name="Tabella 3">
-                <a:extLst>
-                  <a:ext uri="{FF2B5EF4-FFF2-40B4-BE49-F238E27FC236}">
-                    <a16:creationId xmlns:a16="http://schemas.microsoft.com/office/drawing/2014/main" id="{AE0AB884-D705-0F16-784C-E77C80F014EF}"/>
-                  </a:ext>
-                </a:extLst>
-              </p:cNvPr>
-              <p:cNvGraphicFramePr>
-                <a:graphicFrameLocks noGrp="1"/>
-              </p:cNvGraphicFramePr>
-              <p:nvPr>
-                <p:extLst>
-                  <p:ext uri="{D42A27DB-BD31-4B8C-83A1-F6EECF244321}">
-                    <p14:modId xmlns:p14="http://schemas.microsoft.com/office/powerpoint/2010/main" val="97632566"/>
-                  </p:ext>
-                </p:extLst>
-              </p:nvPr>
-            </p:nvGraphicFramePr>
-            <p:xfrm>
-              <a:off x="1918984" y="2687320"/>
-              <a:ext cx="8128000" cy="1118553"/>
-            </p:xfrm>
-            <a:graphic>
-              <a:graphicData uri="http://schemas.openxmlformats.org/drawingml/2006/table">
-                <a:tbl>
-                  <a:tblPr firstRow="1" bandRow="1">
-                    <a:tableStyleId>{5C22544A-7EE6-4342-B048-85BDC9FD1C3A}</a:tableStyleId>
-                  </a:tblPr>
-                  <a:tblGrid>
-                    <a:gridCol w="1625600">
-                      <a:extLst>
-                        <a:ext uri="{9D8B030D-6E8A-4147-A177-3AD203B41FA5}">
-                          <a16:colId xmlns:a16="http://schemas.microsoft.com/office/drawing/2014/main" val="500066530"/>
-                        </a:ext>
-                      </a:extLst>
-                    </a:gridCol>
-                    <a:gridCol w="1625600">
-                      <a:extLst>
-                        <a:ext uri="{9D8B030D-6E8A-4147-A177-3AD203B41FA5}">
-                          <a16:colId xmlns:a16="http://schemas.microsoft.com/office/drawing/2014/main" val="1819855302"/>
-                        </a:ext>
-                      </a:extLst>
-                    </a:gridCol>
-                    <a:gridCol w="1625600">
-                      <a:extLst>
-                        <a:ext uri="{9D8B030D-6E8A-4147-A177-3AD203B41FA5}">
-                          <a16:colId xmlns:a16="http://schemas.microsoft.com/office/drawing/2014/main" val="4011376178"/>
-                        </a:ext>
-                      </a:extLst>
-                    </a:gridCol>
-                    <a:gridCol w="1625600">
-                      <a:extLst>
-                        <a:ext uri="{9D8B030D-6E8A-4147-A177-3AD203B41FA5}">
-                          <a16:colId xmlns:a16="http://schemas.microsoft.com/office/drawing/2014/main" val="1305298267"/>
-                        </a:ext>
-                      </a:extLst>
-                    </a:gridCol>
-                    <a:gridCol w="1625600">
-                      <a:extLst>
-                        <a:ext uri="{9D8B030D-6E8A-4147-A177-3AD203B41FA5}">
-                          <a16:colId xmlns:a16="http://schemas.microsoft.com/office/drawing/2014/main" val="4118232767"/>
-                        </a:ext>
-                      </a:extLst>
-                    </a:gridCol>
-                  </a:tblGrid>
-                  <a:tr h="370840">
-                    <a:tc>
-                      <a:txBody>
-                        <a:bodyPr/>
-                        <a:lstStyle/>
-                        <a:p>
-                          <a:endParaRPr lang="it-IT"/>
-                        </a:p>
-                      </a:txBody>
-                      <a:tcPr>
-                        <a:blipFill>
-                          <a:blip r:embed="rId2"/>
-                          <a:stretch>
-                            <a:fillRect l="-375" t="-1639" r="-401498" b="-206557"/>
-                          </a:stretch>
-                        </a:blipFill>
-                      </a:tcPr>
-                    </a:tc>
-                    <a:tc>
-                      <a:txBody>
-                        <a:bodyPr/>
-                        <a:lstStyle/>
-                        <a:p>
-                          <a:endParaRPr lang="it-IT"/>
-                        </a:p>
-                      </a:txBody>
-                      <a:tcPr>
-                        <a:blipFill>
-                          <a:blip r:embed="rId2"/>
-                          <a:stretch>
-                            <a:fillRect l="-100375" t="-1639" r="-301498" b="-206557"/>
-                          </a:stretch>
-                        </a:blipFill>
-                      </a:tcPr>
-                    </a:tc>
-                    <a:tc>
-                      <a:txBody>
-                        <a:bodyPr/>
-                        <a:lstStyle/>
-                        <a:p>
-                          <a:endParaRPr lang="it-IT"/>
-                        </a:p>
-                      </a:txBody>
-                      <a:tcPr>
-                        <a:blipFill>
-                          <a:blip r:embed="rId2"/>
-                          <a:stretch>
-                            <a:fillRect l="-200375" t="-1639" r="-201498" b="-206557"/>
-                          </a:stretch>
-                        </a:blipFill>
-                      </a:tcPr>
-                    </a:tc>
-                    <a:tc>
-                      <a:txBody>
-                        <a:bodyPr/>
-                        <a:lstStyle/>
-                        <a:p>
-                          <a:endParaRPr lang="it-IT"/>
-                        </a:p>
-                      </a:txBody>
-                      <a:tcPr>
-                        <a:blipFill>
-                          <a:blip r:embed="rId2"/>
-                          <a:stretch>
-                            <a:fillRect l="-300375" t="-1639" r="-101498" b="-206557"/>
-                          </a:stretch>
-                        </a:blipFill>
-                      </a:tcPr>
-                    </a:tc>
-                    <a:tc>
-                      <a:txBody>
-                        <a:bodyPr/>
-                        <a:lstStyle/>
-                        <a:p>
-                          <a:endParaRPr lang="it-IT"/>
-                        </a:p>
-                      </a:txBody>
-                      <a:tcPr>
-                        <a:blipFill>
-                          <a:blip r:embed="rId2"/>
-                          <a:stretch>
-                            <a:fillRect l="-400375" t="-1639" r="-1498" b="-206557"/>
-                          </a:stretch>
-                        </a:blipFill>
-                      </a:tcPr>
-                    </a:tc>
-                    <a:extLst>
-                      <a:ext uri="{0D108BD9-81ED-4DB2-BD59-A6C34878D82A}">
-                        <a16:rowId xmlns:a16="http://schemas.microsoft.com/office/drawing/2014/main" val="235488845"/>
-                      </a:ext>
-                    </a:extLst>
-                  </a:tr>
-                  <a:tr h="376873">
-                    <a:tc>
-                      <a:txBody>
-                        <a:bodyPr/>
-                        <a:lstStyle/>
-                        <a:p>
-                          <a:endParaRPr lang="it-IT"/>
-                        </a:p>
-                      </a:txBody>
-                      <a:tcPr>
-                        <a:blipFill>
-                          <a:blip r:embed="rId2"/>
-                          <a:stretch>
-                            <a:fillRect l="-375" t="-98413" r="-401498" b="-100000"/>
-                          </a:stretch>
-                        </a:blipFill>
-                      </a:tcPr>
-                    </a:tc>
-                    <a:tc>
-                      <a:txBody>
-                        <a:bodyPr/>
-                        <a:lstStyle/>
-                        <a:p>
-                          <a:endParaRPr lang="it-IT"/>
-                        </a:p>
-                      </a:txBody>
-                      <a:tcPr>
-                        <a:blipFill>
-                          <a:blip r:embed="rId2"/>
-                          <a:stretch>
-                            <a:fillRect l="-100375" t="-98413" r="-301498" b="-100000"/>
-                          </a:stretch>
-                        </a:blipFill>
-                      </a:tcPr>
-                    </a:tc>
-                    <a:tc>
-                      <a:txBody>
-                        <a:bodyPr/>
-                        <a:lstStyle/>
-                        <a:p>
-                          <a:endParaRPr lang="it-IT"/>
-                        </a:p>
-                      </a:txBody>
-                      <a:tcPr>
-                        <a:blipFill>
-                          <a:blip r:embed="rId2"/>
-                          <a:stretch>
-                            <a:fillRect l="-200375" t="-98413" r="-201498" b="-100000"/>
-                          </a:stretch>
-                        </a:blipFill>
-                      </a:tcPr>
-                    </a:tc>
-                    <a:tc>
-                      <a:txBody>
-                        <a:bodyPr/>
-                        <a:lstStyle/>
-                        <a:p>
-                          <a:endParaRPr lang="it-IT"/>
-                        </a:p>
-                      </a:txBody>
-                      <a:tcPr>
-                        <a:blipFill>
-                          <a:blip r:embed="rId2"/>
-                          <a:stretch>
-                            <a:fillRect l="-300375" t="-98413" r="-101498" b="-100000"/>
-                          </a:stretch>
-                        </a:blipFill>
-                      </a:tcPr>
-                    </a:tc>
-                    <a:tc>
-                      <a:txBody>
-                        <a:bodyPr/>
-                        <a:lstStyle/>
-                        <a:p>
-                          <a:endParaRPr lang="it-IT"/>
-                        </a:p>
-                      </a:txBody>
-                      <a:tcPr>
-                        <a:blipFill>
-                          <a:blip r:embed="rId2"/>
-                          <a:stretch>
-                            <a:fillRect l="-400375" t="-98413" r="-1498" b="-100000"/>
-                          </a:stretch>
-                        </a:blipFill>
-                      </a:tcPr>
-                    </a:tc>
-                    <a:extLst>
-                      <a:ext uri="{0D108BD9-81ED-4DB2-BD59-A6C34878D82A}">
-                        <a16:rowId xmlns:a16="http://schemas.microsoft.com/office/drawing/2014/main" val="3320676961"/>
-                      </a:ext>
-                    </a:extLst>
-                  </a:tr>
-                  <a:tr h="370840">
-                    <a:tc>
-                      <a:txBody>
-                        <a:bodyPr/>
-                        <a:lstStyle/>
-                        <a:p>
-                          <a:endParaRPr lang="en-US" noProof="0" dirty="0"/>
-                        </a:p>
-                      </a:txBody>
-                      <a:tcPr/>
-                    </a:tc>
-                    <a:tc>
-                      <a:txBody>
-                        <a:bodyPr/>
-                        <a:lstStyle/>
-                        <a:p>
-                          <a:endParaRPr lang="en-US" noProof="0" dirty="0"/>
-                        </a:p>
-                      </a:txBody>
-                      <a:tcPr/>
-                    </a:tc>
-                    <a:tc>
-                      <a:txBody>
-                        <a:bodyPr/>
-                        <a:lstStyle/>
-                        <a:p>
-                          <a:endParaRPr lang="en-US" noProof="0" dirty="0"/>
-                        </a:p>
-                      </a:txBody>
-                      <a:tcPr/>
-                    </a:tc>
-                    <a:tc>
-                      <a:txBody>
-                        <a:bodyPr/>
-                        <a:lstStyle/>
-                        <a:p>
-                          <a:endParaRPr lang="en-US" noProof="0" dirty="0"/>
-                        </a:p>
-                      </a:txBody>
-                      <a:tcPr/>
-                    </a:tc>
-                    <a:tc>
-                      <a:txBody>
-                        <a:bodyPr/>
-                        <a:lstStyle/>
-                        <a:p>
-                          <a:endParaRPr lang="en-US" noProof="0" dirty="0"/>
-                        </a:p>
-                      </a:txBody>
-                      <a:tcPr/>
-                    </a:tc>
-                    <a:extLst>
-                      <a:ext uri="{0D108BD9-81ED-4DB2-BD59-A6C34878D82A}">
-                        <a16:rowId xmlns:a16="http://schemas.microsoft.com/office/drawing/2014/main" val="3412315347"/>
-                      </a:ext>
-                    </a:extLst>
-                  </a:tr>
-                </a:tbl>
-              </a:graphicData>
-            </a:graphic>
-          </p:graphicFrame>
-        </mc:Fallback>
-      </mc:AlternateContent>
-    </p:spTree>
-    <p:extLst>
-      <p:ext uri="{BB962C8B-B14F-4D97-AF65-F5344CB8AC3E}">
-        <p14:creationId xmlns:p14="http://schemas.microsoft.com/office/powerpoint/2010/main" val="2246216297"/>
-      </p:ext>
-    </p:extLst>
-  </p:cSld>
-  <p:clrMapOvr>
-    <a:masterClrMapping/>
-  </p:clrMapOvr>
-</p:sld>
-</file>
-
-<file path=ppt/slides/slide18.xml><?xml version="1.0" encoding="utf-8"?>
-<p:sld xmlns:a="http://schemas.openxmlformats.org/drawingml/2006/main" xmlns:r="http://schemas.openxmlformats.org/officeDocument/2006/relationships" xmlns:p="http://schemas.openxmlformats.org/presentationml/2006/main">
-  <p:cSld>
-    <p:spTree>
-      <p:nvGrpSpPr>
         <p:cNvPr id="1" name="">
           <a:extLst>
             <a:ext uri="{FF2B5EF4-FFF2-40B4-BE49-F238E27FC236}">
@@ -12531,8 +11526,44 @@
           <a:chExt cx="0" cy="0"/>
         </a:xfrm>
       </p:grpSpPr>
-      <mc:AlternateContent xmlns:mc="http://schemas.openxmlformats.org/markup-compatibility/2006">
-        <mc:Choice xmlns:a14="http://schemas.microsoft.com/office/drawing/2010/main" Requires="a14">
+      <p:pic>
+        <p:nvPicPr>
+          <p:cNvPr id="5" name="Immagine 4">
+            <a:extLst>
+              <a:ext uri="{FF2B5EF4-FFF2-40B4-BE49-F238E27FC236}">
+                <a16:creationId xmlns:a16="http://schemas.microsoft.com/office/drawing/2014/main" id="{9D5EDB21-2A82-6CF9-F1F6-EA5143FC1CF8}"/>
+              </a:ext>
+            </a:extLst>
+          </p:cNvPr>
+          <p:cNvPicPr>
+            <a:picLocks noChangeAspect="1"/>
+          </p:cNvPicPr>
+          <p:nvPr/>
+        </p:nvPicPr>
+        <p:blipFill>
+          <a:blip r:embed="rId2">
+            <a:extLst>
+              <a:ext uri="{28A0092B-C50C-407E-A947-70E740481C1C}">
+                <a14:useLocalDpi xmlns:a14="http://schemas.microsoft.com/office/drawing/2010/main" val="0"/>
+              </a:ext>
+            </a:extLst>
+          </a:blip>
+          <a:stretch>
+            <a:fillRect/>
+          </a:stretch>
+        </p:blipFill>
+        <p:spPr>
+          <a:xfrm>
+            <a:off x="2969231" y="932379"/>
+            <a:ext cx="7900827" cy="5925621"/>
+          </a:xfrm>
+          <a:prstGeom prst="rect">
+            <a:avLst/>
+          </a:prstGeom>
+        </p:spPr>
+      </p:pic>
+      <mc:AlternateContent xmlns:mc="http://schemas.openxmlformats.org/markup-compatibility/2006" xmlns:a14="http://schemas.microsoft.com/office/drawing/2010/main">
+        <mc:Choice Requires="a14">
           <p:sp>
             <p:nvSpPr>
               <p:cNvPr id="4" name="Titolo 1">
@@ -12635,7 +11666,7 @@
             </p:txBody>
           </p:sp>
         </mc:Choice>
-        <mc:Fallback>
+        <mc:Fallback xmlns="">
           <p:sp>
             <p:nvSpPr>
               <p:cNvPr id="4" name="Titolo 1">
@@ -12658,7 +11689,7 @@
                 <a:ext cx="10227120" cy="1235075"/>
               </a:xfrm>
               <a:blipFill>
-                <a:blip r:embed="rId2"/>
+                <a:blip r:embed="rId3"/>
                 <a:stretch>
                   <a:fillRect l="-2384" t="-15271"/>
                 </a:stretch>
@@ -12693,8 +11724,8 @@
         </p:nvSpPr>
         <p:spPr>
           <a:xfrm>
-            <a:off x="642938" y="1517151"/>
-            <a:ext cx="3387047" cy="3139321"/>
+            <a:off x="642938" y="2228671"/>
+            <a:ext cx="2233826" cy="1200329"/>
           </a:xfrm>
           <a:prstGeom prst="rect">
             <a:avLst/>
@@ -12709,64 +11740,8 @@
           <a:p>
             <a:r>
               <a:rPr lang="en-US" noProof="0" dirty="0"/>
-              <a:t>Finally we look at the final model, computed as the median of the models computed on each sample (and not the model on the median values) and we also plot the interval </a:t>
+              <a:t>The final model, so the median of the models computed on each sample</a:t>
             </a:r>
-            <a:r>
-              <a:rPr lang="en-US" noProof="0" dirty="0" err="1"/>
-              <a:t>corrisponding</a:t>
-            </a:r>
-            <a:r>
-              <a:rPr lang="en-US" noProof="0" dirty="0"/>
-              <a:t> to 68% level of confidence. We also show the two </a:t>
-            </a:r>
-            <a:r>
-              <a:rPr lang="en-US" noProof="0" dirty="0" err="1"/>
-              <a:t>separete</a:t>
-            </a:r>
-            <a:r>
-              <a:rPr lang="en-US" noProof="0" dirty="0"/>
-              <a:t> components of the model</a:t>
-            </a:r>
-          </a:p>
-        </p:txBody>
-      </p:sp>
-      <p:sp>
-        <p:nvSpPr>
-          <p:cNvPr id="2" name="CasellaDiTesto 1">
-            <a:extLst>
-              <a:ext uri="{FF2B5EF4-FFF2-40B4-BE49-F238E27FC236}">
-                <a16:creationId xmlns:a16="http://schemas.microsoft.com/office/drawing/2014/main" id="{A813098C-0858-D030-C73E-CCE714DEEA2F}"/>
-              </a:ext>
-            </a:extLst>
-          </p:cNvPr>
-          <p:cNvSpPr txBox="1"/>
-          <p:nvPr/>
-        </p:nvSpPr>
-        <p:spPr>
-          <a:xfrm>
-            <a:off x="6688476" y="2178121"/>
-            <a:ext cx="2630185" cy="369332"/>
-          </a:xfrm>
-          <a:prstGeom prst="rect">
-            <a:avLst/>
-          </a:prstGeom>
-          <a:noFill/>
-        </p:spPr>
-        <p:txBody>
-          <a:bodyPr wrap="square" rtlCol="0">
-            <a:spAutoFit/>
-          </a:bodyPr>
-          <a:lstStyle/>
-          <a:p>
-            <a:r>
-              <a:rPr lang="en-US" noProof="0" dirty="0"/>
-              <a:t>Final model </a:t>
-            </a:r>
-            <a:r>
-              <a:rPr lang="en-US" noProof="0" dirty="0" err="1"/>
-              <a:t>img</a:t>
-            </a:r>
-            <a:endParaRPr lang="en-US" noProof="0" dirty="0"/>
           </a:p>
         </p:txBody>
       </p:sp>
@@ -12783,7 +11758,7 @@
 </p:sld>
 </file>
 
-<file path=ppt/slides/slide19.xml><?xml version="1.0" encoding="utf-8"?>
+<file path=ppt/slides/slide18.xml><?xml version="1.0" encoding="utf-8"?>
 <p:sld xmlns:a="http://schemas.openxmlformats.org/drawingml/2006/main" xmlns:r="http://schemas.openxmlformats.org/officeDocument/2006/relationships" xmlns:p="http://schemas.openxmlformats.org/presentationml/2006/main">
   <p:cSld>
     <p:spTree>
@@ -12806,8 +11781,8 @@
           <a:chExt cx="0" cy="0"/>
         </a:xfrm>
       </p:grpSpPr>
-      <mc:AlternateContent xmlns:mc="http://schemas.openxmlformats.org/markup-compatibility/2006">
-        <mc:Choice xmlns:a14="http://schemas.microsoft.com/office/drawing/2010/main" Requires="a14">
+      <mc:AlternateContent xmlns:mc="http://schemas.openxmlformats.org/markup-compatibility/2006" xmlns:a14="http://schemas.microsoft.com/office/drawing/2010/main">
+        <mc:Choice Requires="a14">
           <p:sp>
             <p:nvSpPr>
               <p:cNvPr id="4" name="Titolo 1">
@@ -12910,7 +11885,7 @@
             </p:txBody>
           </p:sp>
         </mc:Choice>
-        <mc:Fallback>
+        <mc:Fallback xmlns="">
           <p:sp>
             <p:nvSpPr>
               <p:cNvPr id="4" name="Titolo 1">
@@ -12968,8 +11943,8 @@
         </p:nvSpPr>
         <p:spPr>
           <a:xfrm>
-            <a:off x="642938" y="1517151"/>
-            <a:ext cx="3387047" cy="369332"/>
+            <a:off x="642938" y="1339334"/>
+            <a:ext cx="3387047" cy="923330"/>
           </a:xfrm>
           <a:prstGeom prst="rect">
             <a:avLst/>
@@ -12983,8 +11958,16 @@
           <a:lstStyle/>
           <a:p>
             <a:r>
+              <a:rPr lang="en-US" dirty="0"/>
+              <a:t>Now c</a:t>
+            </a:r>
+            <a:r>
+              <a:rPr lang="en-US" noProof="0" dirty="0" err="1"/>
+              <a:t>onsider</a:t>
+            </a:r>
+            <a:r>
               <a:rPr lang="en-US" noProof="0" dirty="0"/>
-              <a:t>Consider </a:t>
+              <a:t> the errors as gaussian errors on each measure</a:t>
             </a:r>
           </a:p>
         </p:txBody>
@@ -12993,6 +11976,110 @@
     <p:extLst>
       <p:ext uri="{BB962C8B-B14F-4D97-AF65-F5344CB8AC3E}">
         <p14:creationId xmlns:p14="http://schemas.microsoft.com/office/powerpoint/2010/main" val="2651039601"/>
+      </p:ext>
+    </p:extLst>
+  </p:cSld>
+  <p:clrMapOvr>
+    <a:masterClrMapping/>
+  </p:clrMapOvr>
+</p:sld>
+</file>
+
+<file path=ppt/slides/slide19.xml><?xml version="1.0" encoding="utf-8"?>
+<p:sld xmlns:a="http://schemas.openxmlformats.org/drawingml/2006/main" xmlns:r="http://schemas.openxmlformats.org/officeDocument/2006/relationships" xmlns:p="http://schemas.openxmlformats.org/presentationml/2006/main">
+  <p:cSld>
+    <p:spTree>
+      <p:nvGrpSpPr>
+        <p:cNvPr id="1" name="">
+          <a:extLst>
+            <a:ext uri="{FF2B5EF4-FFF2-40B4-BE49-F238E27FC236}">
+              <a16:creationId xmlns:a16="http://schemas.microsoft.com/office/drawing/2014/main" id="{94B4B57A-6293-2976-B48B-555FE2F44DE3}"/>
+            </a:ext>
+          </a:extLst>
+        </p:cNvPr>
+        <p:cNvGrpSpPr/>
+        <p:nvPr/>
+      </p:nvGrpSpPr>
+      <p:grpSpPr>
+        <a:xfrm>
+          <a:off x="0" y="0"/>
+          <a:ext cx="0" cy="0"/>
+          <a:chOff x="0" y="0"/>
+          <a:chExt cx="0" cy="0"/>
+        </a:xfrm>
+      </p:grpSpPr>
+      <p:sp>
+        <p:nvSpPr>
+          <p:cNvPr id="2" name="Titolo 1">
+            <a:extLst>
+              <a:ext uri="{FF2B5EF4-FFF2-40B4-BE49-F238E27FC236}">
+                <a16:creationId xmlns:a16="http://schemas.microsoft.com/office/drawing/2014/main" id="{43B18B03-F308-DD92-1281-8B17984DC3E6}"/>
+              </a:ext>
+            </a:extLst>
+          </p:cNvPr>
+          <p:cNvSpPr>
+            <a:spLocks noGrp="1"/>
+          </p:cNvSpPr>
+          <p:nvPr>
+            <p:ph type="title"/>
+          </p:nvPr>
+        </p:nvSpPr>
+        <p:spPr/>
+        <p:txBody>
+          <a:bodyPr/>
+          <a:lstStyle/>
+          <a:p>
+            <a:r>
+              <a:rPr lang="en-US" noProof="0" dirty="0"/>
+              <a:t>Conclusions</a:t>
+            </a:r>
+          </a:p>
+        </p:txBody>
+      </p:sp>
+      <p:sp>
+        <p:nvSpPr>
+          <p:cNvPr id="4" name="Segnaposto contenuto 4">
+            <a:extLst>
+              <a:ext uri="{FF2B5EF4-FFF2-40B4-BE49-F238E27FC236}">
+                <a16:creationId xmlns:a16="http://schemas.microsoft.com/office/drawing/2014/main" id="{F9B62D35-990E-4023-5A62-EB1014B42B8B}"/>
+              </a:ext>
+            </a:extLst>
+          </p:cNvPr>
+          <p:cNvSpPr>
+            <a:spLocks noGrp="1"/>
+          </p:cNvSpPr>
+          <p:nvPr>
+            <p:ph idx="1"/>
+          </p:nvPr>
+        </p:nvSpPr>
+        <p:spPr>
+          <a:xfrm>
+            <a:off x="642746" y="1714500"/>
+            <a:ext cx="9625203" cy="4502149"/>
+          </a:xfrm>
+        </p:spPr>
+        <p:txBody>
+          <a:bodyPr>
+            <a:normAutofit/>
+          </a:bodyPr>
+          <a:lstStyle/>
+          <a:p>
+            <a:pPr>
+              <a:buSzPct val="90000"/>
+              <a:buFont typeface="Wingdings" panose="05000000000000000000" pitchFamily="2" charset="2"/>
+              <a:buChar char="Ø"/>
+            </a:pPr>
+            <a:r>
+              <a:rPr lang="en-US" sz="2400" noProof="0" dirty="0"/>
+              <a:t> </a:t>
+            </a:r>
+          </a:p>
+        </p:txBody>
+      </p:sp>
+    </p:spTree>
+    <p:extLst>
+      <p:ext uri="{BB962C8B-B14F-4D97-AF65-F5344CB8AC3E}">
+        <p14:creationId xmlns:p14="http://schemas.microsoft.com/office/powerpoint/2010/main" val="976120280"/>
       </p:ext>
     </p:extLst>
   </p:cSld>
@@ -13047,8 +12134,8 @@
           </a:p>
         </p:txBody>
       </p:sp>
-      <mc:AlternateContent xmlns:mc="http://schemas.openxmlformats.org/markup-compatibility/2006">
-        <mc:Choice xmlns:a14="http://schemas.microsoft.com/office/drawing/2010/main" Requires="a14">
+      <mc:AlternateContent xmlns:mc="http://schemas.openxmlformats.org/markup-compatibility/2006" xmlns:a14="http://schemas.microsoft.com/office/drawing/2010/main">
+        <mc:Choice Requires="a14">
           <p:sp>
             <p:nvSpPr>
               <p:cNvPr id="5" name="Segnaposto contenuto 4">
@@ -13334,7 +12421,7 @@
             </p:txBody>
           </p:sp>
         </mc:Choice>
-        <mc:Fallback>
+        <mc:Fallback xmlns="">
           <p:sp>
             <p:nvSpPr>
               <p:cNvPr id="5" name="Segnaposto contenuto 4">
@@ -13388,110 +12475,6 @@
 </file>
 
 <file path=ppt/slides/slide20.xml><?xml version="1.0" encoding="utf-8"?>
-<p:sld xmlns:a="http://schemas.openxmlformats.org/drawingml/2006/main" xmlns:r="http://schemas.openxmlformats.org/officeDocument/2006/relationships" xmlns:p="http://schemas.openxmlformats.org/presentationml/2006/main">
-  <p:cSld>
-    <p:spTree>
-      <p:nvGrpSpPr>
-        <p:cNvPr id="1" name="">
-          <a:extLst>
-            <a:ext uri="{FF2B5EF4-FFF2-40B4-BE49-F238E27FC236}">
-              <a16:creationId xmlns:a16="http://schemas.microsoft.com/office/drawing/2014/main" id="{94B4B57A-6293-2976-B48B-555FE2F44DE3}"/>
-            </a:ext>
-          </a:extLst>
-        </p:cNvPr>
-        <p:cNvGrpSpPr/>
-        <p:nvPr/>
-      </p:nvGrpSpPr>
-      <p:grpSpPr>
-        <a:xfrm>
-          <a:off x="0" y="0"/>
-          <a:ext cx="0" cy="0"/>
-          <a:chOff x="0" y="0"/>
-          <a:chExt cx="0" cy="0"/>
-        </a:xfrm>
-      </p:grpSpPr>
-      <p:sp>
-        <p:nvSpPr>
-          <p:cNvPr id="2" name="Titolo 1">
-            <a:extLst>
-              <a:ext uri="{FF2B5EF4-FFF2-40B4-BE49-F238E27FC236}">
-                <a16:creationId xmlns:a16="http://schemas.microsoft.com/office/drawing/2014/main" id="{43B18B03-F308-DD92-1281-8B17984DC3E6}"/>
-              </a:ext>
-            </a:extLst>
-          </p:cNvPr>
-          <p:cNvSpPr>
-            <a:spLocks noGrp="1"/>
-          </p:cNvSpPr>
-          <p:nvPr>
-            <p:ph type="title"/>
-          </p:nvPr>
-        </p:nvSpPr>
-        <p:spPr/>
-        <p:txBody>
-          <a:bodyPr/>
-          <a:lstStyle/>
-          <a:p>
-            <a:r>
-              <a:rPr lang="en-US" noProof="0" dirty="0"/>
-              <a:t>Conclusions</a:t>
-            </a:r>
-          </a:p>
-        </p:txBody>
-      </p:sp>
-      <p:sp>
-        <p:nvSpPr>
-          <p:cNvPr id="4" name="Segnaposto contenuto 4">
-            <a:extLst>
-              <a:ext uri="{FF2B5EF4-FFF2-40B4-BE49-F238E27FC236}">
-                <a16:creationId xmlns:a16="http://schemas.microsoft.com/office/drawing/2014/main" id="{F9B62D35-990E-4023-5A62-EB1014B42B8B}"/>
-              </a:ext>
-            </a:extLst>
-          </p:cNvPr>
-          <p:cNvSpPr>
-            <a:spLocks noGrp="1"/>
-          </p:cNvSpPr>
-          <p:nvPr>
-            <p:ph idx="1"/>
-          </p:nvPr>
-        </p:nvSpPr>
-        <p:spPr>
-          <a:xfrm>
-            <a:off x="642746" y="1714500"/>
-            <a:ext cx="9625203" cy="4502149"/>
-          </a:xfrm>
-        </p:spPr>
-        <p:txBody>
-          <a:bodyPr>
-            <a:normAutofit/>
-          </a:bodyPr>
-          <a:lstStyle/>
-          <a:p>
-            <a:pPr>
-              <a:buSzPct val="90000"/>
-              <a:buFont typeface="Wingdings" panose="05000000000000000000" pitchFamily="2" charset="2"/>
-              <a:buChar char="Ø"/>
-            </a:pPr>
-            <a:r>
-              <a:rPr lang="en-US" sz="2400" noProof="0" dirty="0"/>
-              <a:t> </a:t>
-            </a:r>
-          </a:p>
-        </p:txBody>
-      </p:sp>
-    </p:spTree>
-    <p:extLst>
-      <p:ext uri="{BB962C8B-B14F-4D97-AF65-F5344CB8AC3E}">
-        <p14:creationId xmlns:p14="http://schemas.microsoft.com/office/powerpoint/2010/main" val="976120280"/>
-      </p:ext>
-    </p:extLst>
-  </p:cSld>
-  <p:clrMapOvr>
-    <a:masterClrMapping/>
-  </p:clrMapOvr>
-</p:sld>
-</file>
-
-<file path=ppt/slides/slide21.xml><?xml version="1.0" encoding="utf-8"?>
 <p:sld xmlns:a="http://schemas.openxmlformats.org/drawingml/2006/main" xmlns:r="http://schemas.openxmlformats.org/officeDocument/2006/relationships" xmlns:p="http://schemas.openxmlformats.org/presentationml/2006/main">
   <p:cSld>
     <p:spTree>
@@ -13696,7 +12679,7 @@
 </p:sld>
 </file>
 
-<file path=ppt/slides/slide22.xml><?xml version="1.0" encoding="utf-8"?>
+<file path=ppt/slides/slide21.xml><?xml version="1.0" encoding="utf-8"?>
 <p:sld xmlns:a="http://schemas.openxmlformats.org/drawingml/2006/main" xmlns:r="http://schemas.openxmlformats.org/officeDocument/2006/relationships" xmlns:p="http://schemas.openxmlformats.org/presentationml/2006/main">
   <p:cSld>
     <p:spTree>
@@ -13847,8 +12830,8 @@
           </a:p>
         </p:txBody>
       </p:sp>
-      <mc:AlternateContent xmlns:mc="http://schemas.openxmlformats.org/markup-compatibility/2006">
-        <mc:Choice xmlns:a14="http://schemas.microsoft.com/office/drawing/2010/main" Requires="a14">
+      <mc:AlternateContent xmlns:mc="http://schemas.openxmlformats.org/markup-compatibility/2006" xmlns:a14="http://schemas.microsoft.com/office/drawing/2010/main">
+        <mc:Choice Requires="a14">
           <p:sp>
             <p:nvSpPr>
               <p:cNvPr id="5" name="CasellaDiTesto 4">
@@ -13953,7 +12936,7 @@
             </p:txBody>
           </p:sp>
         </mc:Choice>
-        <mc:Fallback>
+        <mc:Fallback xmlns="">
           <p:sp>
             <p:nvSpPr>
               <p:cNvPr id="5" name="CasellaDiTesto 4">
@@ -14072,8 +13055,8 @@
           </a:p>
         </p:txBody>
       </p:sp>
-      <mc:AlternateContent xmlns:mc="http://schemas.openxmlformats.org/markup-compatibility/2006">
-        <mc:Choice xmlns:a14="http://schemas.microsoft.com/office/drawing/2010/main" Requires="a14">
+      <mc:AlternateContent xmlns:mc="http://schemas.openxmlformats.org/markup-compatibility/2006" xmlns:a14="http://schemas.microsoft.com/office/drawing/2010/main">
+        <mc:Choice Requires="a14">
           <p:sp>
             <p:nvSpPr>
               <p:cNvPr id="8" name="CasellaDiTesto 7">
@@ -14131,7 +13114,7 @@
             </p:txBody>
           </p:sp>
         </mc:Choice>
-        <mc:Fallback>
+        <mc:Fallback xmlns="">
           <p:sp>
             <p:nvSpPr>
               <p:cNvPr id="8" name="CasellaDiTesto 7">
@@ -14277,8 +13260,8 @@
           </a:prstGeom>
         </p:spPr>
       </p:pic>
-      <mc:AlternateContent xmlns:mc="http://schemas.openxmlformats.org/markup-compatibility/2006">
-        <mc:Choice xmlns:a14="http://schemas.microsoft.com/office/drawing/2010/main" Requires="a14">
+      <mc:AlternateContent xmlns:mc="http://schemas.openxmlformats.org/markup-compatibility/2006" xmlns:a14="http://schemas.microsoft.com/office/drawing/2010/main">
+        <mc:Choice Requires="a14">
           <p:sp>
             <p:nvSpPr>
               <p:cNvPr id="2" name="Titolo 1">
@@ -14374,7 +13357,7 @@
             </p:txBody>
           </p:sp>
         </mc:Choice>
-        <mc:Fallback>
+        <mc:Fallback xmlns="">
           <p:sp>
             <p:nvSpPr>
               <p:cNvPr id="2" name="Titolo 1">
@@ -14414,8 +13397,8 @@
           </p:sp>
         </mc:Fallback>
       </mc:AlternateContent>
-      <mc:AlternateContent xmlns:mc="http://schemas.openxmlformats.org/markup-compatibility/2006">
-        <mc:Choice xmlns:a14="http://schemas.microsoft.com/office/drawing/2010/main" Requires="a14">
+      <mc:AlternateContent xmlns:mc="http://schemas.openxmlformats.org/markup-compatibility/2006" xmlns:a14="http://schemas.microsoft.com/office/drawing/2010/main">
+        <mc:Choice Requires="a14">
           <p:sp>
             <p:nvSpPr>
               <p:cNvPr id="4" name="CasellaDiTesto 3">
@@ -14562,7 +13545,7 @@
             </p:txBody>
           </p:sp>
         </mc:Choice>
-        <mc:Fallback>
+        <mc:Fallback xmlns="">
           <p:sp>
             <p:nvSpPr>
               <p:cNvPr id="4" name="CasellaDiTesto 3">
@@ -14607,8 +13590,8 @@
           </p:sp>
         </mc:Fallback>
       </mc:AlternateContent>
-      <mc:AlternateContent xmlns:mc="http://schemas.openxmlformats.org/markup-compatibility/2006">
-        <mc:Choice xmlns:a14="http://schemas.microsoft.com/office/drawing/2010/main" Requires="a14">
+      <mc:AlternateContent xmlns:mc="http://schemas.openxmlformats.org/markup-compatibility/2006" xmlns:a14="http://schemas.microsoft.com/office/drawing/2010/main">
+        <mc:Choice Requires="a14">
           <p:sp>
             <p:nvSpPr>
               <p:cNvPr id="5" name="CasellaDiTesto 4">
@@ -14673,7 +13656,7 @@
             </p:txBody>
           </p:sp>
         </mc:Choice>
-        <mc:Fallback>
+        <mc:Fallback xmlns="">
           <p:sp>
             <p:nvSpPr>
               <p:cNvPr id="5" name="CasellaDiTesto 4">
@@ -14718,8 +13701,8 @@
           </p:sp>
         </mc:Fallback>
       </mc:AlternateContent>
-      <mc:AlternateContent xmlns:mc="http://schemas.openxmlformats.org/markup-compatibility/2006">
-        <mc:Choice xmlns:a14="http://schemas.microsoft.com/office/drawing/2010/main" Requires="a14">
+      <mc:AlternateContent xmlns:mc="http://schemas.openxmlformats.org/markup-compatibility/2006" xmlns:a14="http://schemas.microsoft.com/office/drawing/2010/main">
+        <mc:Choice Requires="a14">
           <p:sp>
             <p:nvSpPr>
               <p:cNvPr id="6" name="CasellaDiTesto 5">
@@ -14797,7 +13780,7 @@
             </p:txBody>
           </p:sp>
         </mc:Choice>
-        <mc:Fallback>
+        <mc:Fallback xmlns="">
           <p:sp>
             <p:nvSpPr>
               <p:cNvPr id="6" name="CasellaDiTesto 5">
@@ -14889,8 +13872,8 @@
           </a:p>
         </p:txBody>
       </p:sp>
-      <mc:AlternateContent xmlns:mc="http://schemas.openxmlformats.org/markup-compatibility/2006">
-        <mc:Choice xmlns:a14="http://schemas.microsoft.com/office/drawing/2010/main" Requires="a14">
+      <mc:AlternateContent xmlns:mc="http://schemas.openxmlformats.org/markup-compatibility/2006" xmlns:a14="http://schemas.microsoft.com/office/drawing/2010/main">
+        <mc:Choice Requires="a14">
           <p:sp>
             <p:nvSpPr>
               <p:cNvPr id="12" name="CasellaDiTesto 11">
@@ -14990,7 +13973,7 @@
             </p:txBody>
           </p:sp>
         </mc:Choice>
-        <mc:Fallback>
+        <mc:Fallback xmlns="">
           <p:sp>
             <p:nvSpPr>
               <p:cNvPr id="12" name="CasellaDiTesto 11">
@@ -15107,8 +14090,8 @@
           <a:chExt cx="0" cy="0"/>
         </a:xfrm>
       </p:grpSpPr>
-      <mc:AlternateContent xmlns:mc="http://schemas.openxmlformats.org/markup-compatibility/2006">
-        <mc:Choice xmlns:a14="http://schemas.microsoft.com/office/drawing/2010/main" Requires="a14">
+      <mc:AlternateContent xmlns:mc="http://schemas.openxmlformats.org/markup-compatibility/2006" xmlns:a14="http://schemas.microsoft.com/office/drawing/2010/main">
+        <mc:Choice Requires="a14">
           <p:sp>
             <p:nvSpPr>
               <p:cNvPr id="4" name="Titolo 1">
@@ -15209,7 +14192,7 @@
             </p:txBody>
           </p:sp>
         </mc:Choice>
-        <mc:Fallback>
+        <mc:Fallback xmlns="">
           <p:sp>
             <p:nvSpPr>
               <p:cNvPr id="4" name="Titolo 1">
@@ -15253,8 +14236,8 @@
           </p:sp>
         </mc:Fallback>
       </mc:AlternateContent>
-      <mc:AlternateContent xmlns:mc="http://schemas.openxmlformats.org/markup-compatibility/2006">
-        <mc:Choice xmlns:a14="http://schemas.microsoft.com/office/drawing/2010/main" Requires="a14">
+      <mc:AlternateContent xmlns:mc="http://schemas.openxmlformats.org/markup-compatibility/2006" xmlns:a14="http://schemas.microsoft.com/office/drawing/2010/main">
+        <mc:Choice Requires="a14">
           <p:sp>
             <p:nvSpPr>
               <p:cNvPr id="5" name="CasellaDiTesto 4">
@@ -15680,7 +14663,7 @@
             </p:txBody>
           </p:sp>
         </mc:Choice>
-        <mc:Fallback>
+        <mc:Fallback xmlns="">
           <p:sp>
             <p:nvSpPr>
               <p:cNvPr id="5" name="CasellaDiTesto 4">
@@ -15760,8 +14743,8 @@
           </a:p>
         </p:txBody>
       </p:sp>
-      <mc:AlternateContent xmlns:mc="http://schemas.openxmlformats.org/markup-compatibility/2006">
-        <mc:Choice xmlns:a14="http://schemas.microsoft.com/office/drawing/2010/main" Requires="a14">
+      <mc:AlternateContent xmlns:mc="http://schemas.openxmlformats.org/markup-compatibility/2006" xmlns:a14="http://schemas.microsoft.com/office/drawing/2010/main">
+        <mc:Choice Requires="a14">
           <p:sp>
             <p:nvSpPr>
               <p:cNvPr id="7" name="CasellaDiTesto 6">
@@ -15994,7 +14977,7 @@
             </p:txBody>
           </p:sp>
         </mc:Choice>
-        <mc:Fallback>
+        <mc:Fallback xmlns="">
           <p:sp>
             <p:nvSpPr>
               <p:cNvPr id="7" name="CasellaDiTesto 6">
@@ -16075,8 +15058,8 @@
           <a:chExt cx="0" cy="0"/>
         </a:xfrm>
       </p:grpSpPr>
-      <mc:AlternateContent xmlns:mc="http://schemas.openxmlformats.org/markup-compatibility/2006">
-        <mc:Choice xmlns:a14="http://schemas.microsoft.com/office/drawing/2010/main" Requires="a14">
+      <mc:AlternateContent xmlns:mc="http://schemas.openxmlformats.org/markup-compatibility/2006" xmlns:a14="http://schemas.microsoft.com/office/drawing/2010/main">
+        <mc:Choice Requires="a14">
           <p:sp>
             <p:nvSpPr>
               <p:cNvPr id="4" name="Titolo 1">
@@ -16179,7 +15162,7 @@
             </p:txBody>
           </p:sp>
         </mc:Choice>
-        <mc:Fallback>
+        <mc:Fallback xmlns="">
           <p:sp>
             <p:nvSpPr>
               <p:cNvPr id="4" name="Titolo 1">
@@ -16223,8 +15206,8 @@
           </p:sp>
         </mc:Fallback>
       </mc:AlternateContent>
-      <mc:AlternateContent xmlns:mc="http://schemas.openxmlformats.org/markup-compatibility/2006">
-        <mc:Choice xmlns:a14="http://schemas.microsoft.com/office/drawing/2010/main" Requires="a14">
+      <mc:AlternateContent xmlns:mc="http://schemas.openxmlformats.org/markup-compatibility/2006" xmlns:a14="http://schemas.microsoft.com/office/drawing/2010/main">
+        <mc:Choice Requires="a14">
           <p:sp>
             <p:nvSpPr>
               <p:cNvPr id="2" name="CasellaDiTesto 1">
@@ -16381,7 +15364,7 @@
             </p:txBody>
           </p:sp>
         </mc:Choice>
-        <mc:Fallback>
+        <mc:Fallback xmlns="">
           <p:sp>
             <p:nvSpPr>
               <p:cNvPr id="2" name="CasellaDiTesto 1">
@@ -16426,8 +15409,8 @@
           </p:sp>
         </mc:Fallback>
       </mc:AlternateContent>
-      <mc:AlternateContent xmlns:mc="http://schemas.openxmlformats.org/markup-compatibility/2006">
-        <mc:Choice xmlns:a14="http://schemas.microsoft.com/office/drawing/2010/main" Requires="a14">
+      <mc:AlternateContent xmlns:mc="http://schemas.openxmlformats.org/markup-compatibility/2006" xmlns:a14="http://schemas.microsoft.com/office/drawing/2010/main">
+        <mc:Choice Requires="a14">
           <p:sp>
             <p:nvSpPr>
               <p:cNvPr id="3" name="CasellaDiTesto 2">
@@ -16620,7 +15603,7 @@
             </p:txBody>
           </p:sp>
         </mc:Choice>
-        <mc:Fallback>
+        <mc:Fallback xmlns="">
           <p:sp>
             <p:nvSpPr>
               <p:cNvPr id="3" name="CasellaDiTesto 2">
@@ -16700,8 +15683,8 @@
           </a:p>
         </p:txBody>
       </p:sp>
-      <mc:AlternateContent xmlns:mc="http://schemas.openxmlformats.org/markup-compatibility/2006">
-        <mc:Choice xmlns:a14="http://schemas.microsoft.com/office/drawing/2010/main" Requires="a14">
+      <mc:AlternateContent xmlns:mc="http://schemas.openxmlformats.org/markup-compatibility/2006" xmlns:a14="http://schemas.microsoft.com/office/drawing/2010/main">
+        <mc:Choice Requires="a14">
           <p:sp>
             <p:nvSpPr>
               <p:cNvPr id="7" name="CasellaDiTesto 6">
@@ -16981,7 +15964,7 @@
             </p:txBody>
           </p:sp>
         </mc:Choice>
-        <mc:Fallback>
+        <mc:Fallback xmlns="">
           <p:sp>
             <p:nvSpPr>
               <p:cNvPr id="7" name="CasellaDiTesto 6">
@@ -17324,8 +16307,8 @@
           <a:chExt cx="0" cy="0"/>
         </a:xfrm>
       </p:grpSpPr>
-      <mc:AlternateContent xmlns:mc="http://schemas.openxmlformats.org/markup-compatibility/2006">
-        <mc:Choice xmlns:a14="http://schemas.microsoft.com/office/drawing/2010/main" Requires="a14">
+      <mc:AlternateContent xmlns:mc="http://schemas.openxmlformats.org/markup-compatibility/2006" xmlns:a14="http://schemas.microsoft.com/office/drawing/2010/main">
+        <mc:Choice Requires="a14">
           <p:sp>
             <p:nvSpPr>
               <p:cNvPr id="4" name="Titolo 1">
@@ -17428,7 +16411,7 @@
             </p:txBody>
           </p:sp>
         </mc:Choice>
-        <mc:Fallback>
+        <mc:Fallback xmlns="">
           <p:sp>
             <p:nvSpPr>
               <p:cNvPr id="4" name="Titolo 1">
@@ -17472,8 +16455,8 @@
           </p:sp>
         </mc:Fallback>
       </mc:AlternateContent>
-      <mc:AlternateContent xmlns:mc="http://schemas.openxmlformats.org/markup-compatibility/2006">
-        <mc:Choice xmlns:a14="http://schemas.microsoft.com/office/drawing/2010/main" Requires="a14">
+      <mc:AlternateContent xmlns:mc="http://schemas.openxmlformats.org/markup-compatibility/2006" xmlns:a14="http://schemas.microsoft.com/office/drawing/2010/main">
+        <mc:Choice Requires="a14">
           <p:sp>
             <p:nvSpPr>
               <p:cNvPr id="3" name="CasellaDiTesto 2">
@@ -17548,7 +16531,7 @@
             </p:txBody>
           </p:sp>
         </mc:Choice>
-        <mc:Fallback>
+        <mc:Fallback xmlns="">
           <p:sp>
             <p:nvSpPr>
               <p:cNvPr id="3" name="CasellaDiTesto 2">
@@ -17663,8 +16646,8 @@
           </a:p>
         </p:txBody>
       </p:sp>
-      <mc:AlternateContent xmlns:mc="http://schemas.openxmlformats.org/markup-compatibility/2006">
-        <mc:Choice xmlns:a14="http://schemas.microsoft.com/office/drawing/2010/main" Requires="a14">
+      <mc:AlternateContent xmlns:mc="http://schemas.openxmlformats.org/markup-compatibility/2006" xmlns:a14="http://schemas.microsoft.com/office/drawing/2010/main">
+        <mc:Choice Requires="a14">
           <p:sp>
             <p:nvSpPr>
               <p:cNvPr id="7" name="CasellaDiTesto 6">
@@ -17726,7 +16709,7 @@
             </p:txBody>
           </p:sp>
         </mc:Choice>
-        <mc:Fallback>
+        <mc:Fallback xmlns="">
           <p:sp>
             <p:nvSpPr>
               <p:cNvPr id="7" name="CasellaDiTesto 6">
@@ -17771,8 +16754,8 @@
           </p:sp>
         </mc:Fallback>
       </mc:AlternateContent>
-      <mc:AlternateContent xmlns:mc="http://schemas.openxmlformats.org/markup-compatibility/2006">
-        <mc:Choice xmlns:a14="http://schemas.microsoft.com/office/drawing/2010/main" Requires="a14">
+      <mc:AlternateContent xmlns:mc="http://schemas.openxmlformats.org/markup-compatibility/2006" xmlns:a14="http://schemas.microsoft.com/office/drawing/2010/main">
+        <mc:Choice Requires="a14">
           <p:sp>
             <p:nvSpPr>
               <p:cNvPr id="8" name="CasellaDiTesto 7">
@@ -17853,7 +16836,7 @@
             </p:txBody>
           </p:sp>
         </mc:Choice>
-        <mc:Fallback>
+        <mc:Fallback xmlns="">
           <p:sp>
             <p:nvSpPr>
               <p:cNvPr id="8" name="CasellaDiTesto 7">
@@ -17941,8 +16924,8 @@
           </a:p>
         </p:txBody>
       </p:sp>
-      <mc:AlternateContent xmlns:mc="http://schemas.openxmlformats.org/markup-compatibility/2006">
-        <mc:Choice xmlns:a14="http://schemas.microsoft.com/office/drawing/2010/main" Requires="a14">
+      <mc:AlternateContent xmlns:mc="http://schemas.openxmlformats.org/markup-compatibility/2006" xmlns:a14="http://schemas.microsoft.com/office/drawing/2010/main">
+        <mc:Choice Requires="a14">
           <p:sp>
             <p:nvSpPr>
               <p:cNvPr id="10" name="CasellaDiTesto 9">
@@ -17998,7 +16981,7 @@
             </p:txBody>
           </p:sp>
         </mc:Choice>
-        <mc:Fallback>
+        <mc:Fallback xmlns="">
           <p:sp>
             <p:nvSpPr>
               <p:cNvPr id="10" name="CasellaDiTesto 9">
@@ -18043,8 +17026,8 @@
           </p:sp>
         </mc:Fallback>
       </mc:AlternateContent>
-      <mc:AlternateContent xmlns:mc="http://schemas.openxmlformats.org/markup-compatibility/2006">
-        <mc:Choice xmlns:a14="http://schemas.microsoft.com/office/drawing/2010/main" Requires="a14">
+      <mc:AlternateContent xmlns:mc="http://schemas.openxmlformats.org/markup-compatibility/2006" xmlns:a14="http://schemas.microsoft.com/office/drawing/2010/main">
+        <mc:Choice Requires="a14">
           <p:sp>
             <p:nvSpPr>
               <p:cNvPr id="11" name="CasellaDiTesto 10">
@@ -18125,7 +17108,7 @@
             </p:txBody>
           </p:sp>
         </mc:Choice>
-        <mc:Fallback>
+        <mc:Fallback xmlns="">
           <p:sp>
             <p:nvSpPr>
               <p:cNvPr id="11" name="CasellaDiTesto 10">
@@ -18170,8 +17153,8 @@
           </p:sp>
         </mc:Fallback>
       </mc:AlternateContent>
-      <mc:AlternateContent xmlns:mc="http://schemas.openxmlformats.org/markup-compatibility/2006">
-        <mc:Choice xmlns:a14="http://schemas.microsoft.com/office/drawing/2010/main" Requires="a14">
+      <mc:AlternateContent xmlns:mc="http://schemas.openxmlformats.org/markup-compatibility/2006" xmlns:a14="http://schemas.microsoft.com/office/drawing/2010/main">
+        <mc:Choice Requires="a14">
           <p:sp>
             <p:nvSpPr>
               <p:cNvPr id="12" name="CasellaDiTesto 11">
@@ -18242,7 +17225,7 @@
             </p:txBody>
           </p:sp>
         </mc:Choice>
-        <mc:Fallback>
+        <mc:Fallback xmlns="">
           <p:sp>
             <p:nvSpPr>
               <p:cNvPr id="12" name="CasellaDiTesto 11">
@@ -18323,8 +17306,8 @@
           <a:chExt cx="0" cy="0"/>
         </a:xfrm>
       </p:grpSpPr>
-      <mc:AlternateContent xmlns:mc="http://schemas.openxmlformats.org/markup-compatibility/2006">
-        <mc:Choice xmlns:a14="http://schemas.microsoft.com/office/drawing/2010/main" Requires="a14">
+      <mc:AlternateContent xmlns:mc="http://schemas.openxmlformats.org/markup-compatibility/2006" xmlns:a14="http://schemas.microsoft.com/office/drawing/2010/main">
+        <mc:Choice Requires="a14">
           <p:sp>
             <p:nvSpPr>
               <p:cNvPr id="4" name="Titolo 1">
@@ -18427,7 +17410,7 @@
             </p:txBody>
           </p:sp>
         </mc:Choice>
-        <mc:Fallback>
+        <mc:Fallback xmlns="">
           <p:sp>
             <p:nvSpPr>
               <p:cNvPr id="4" name="Titolo 1">
@@ -18506,8 +17489,8 @@
           </a:p>
         </p:txBody>
       </p:sp>
-      <mc:AlternateContent xmlns:mc="http://schemas.openxmlformats.org/markup-compatibility/2006">
-        <mc:Choice xmlns:a14="http://schemas.microsoft.com/office/drawing/2010/main" Requires="a14">
+      <mc:AlternateContent xmlns:mc="http://schemas.openxmlformats.org/markup-compatibility/2006" xmlns:a14="http://schemas.microsoft.com/office/drawing/2010/main">
+        <mc:Choice Requires="a14">
           <p:sp>
             <p:nvSpPr>
               <p:cNvPr id="2" name="CasellaDiTesto 1">
@@ -18588,7 +17571,7 @@
             </p:txBody>
           </p:sp>
         </mc:Choice>
-        <mc:Fallback>
+        <mc:Fallback xmlns="">
           <p:sp>
             <p:nvSpPr>
               <p:cNvPr id="2" name="CasellaDiTesto 1">
@@ -18668,8 +17651,8 @@
           </a:p>
         </p:txBody>
       </p:sp>
-      <mc:AlternateContent xmlns:mc="http://schemas.openxmlformats.org/markup-compatibility/2006">
-        <mc:Choice xmlns:a14="http://schemas.microsoft.com/office/drawing/2010/main" Requires="a14">
+      <mc:AlternateContent xmlns:mc="http://schemas.openxmlformats.org/markup-compatibility/2006" xmlns:a14="http://schemas.microsoft.com/office/drawing/2010/main">
+        <mc:Choice Requires="a14">
           <p:sp>
             <p:nvSpPr>
               <p:cNvPr id="6" name="CasellaDiTesto 5">
@@ -18862,7 +17845,7 @@
             </p:txBody>
           </p:sp>
         </mc:Choice>
-        <mc:Fallback>
+        <mc:Fallback xmlns="">
           <p:sp>
             <p:nvSpPr>
               <p:cNvPr id="6" name="CasellaDiTesto 5">
@@ -18907,8 +17890,8 @@
           </p:sp>
         </mc:Fallback>
       </mc:AlternateContent>
-      <mc:AlternateContent xmlns:mc="http://schemas.openxmlformats.org/markup-compatibility/2006">
-        <mc:Choice xmlns:a14="http://schemas.microsoft.com/office/drawing/2010/main" Requires="a14">
+      <mc:AlternateContent xmlns:mc="http://schemas.openxmlformats.org/markup-compatibility/2006" xmlns:a14="http://schemas.microsoft.com/office/drawing/2010/main">
+        <mc:Choice Requires="a14">
           <p:sp>
             <p:nvSpPr>
               <p:cNvPr id="7" name="CasellaDiTesto 6">
@@ -19011,7 +17994,7 @@
             </p:txBody>
           </p:sp>
         </mc:Choice>
-        <mc:Fallback>
+        <mc:Fallback xmlns="">
           <p:sp>
             <p:nvSpPr>
               <p:cNvPr id="7" name="CasellaDiTesto 6">
@@ -19056,8 +18039,8 @@
           </p:sp>
         </mc:Fallback>
       </mc:AlternateContent>
-      <mc:AlternateContent xmlns:mc="http://schemas.openxmlformats.org/markup-compatibility/2006">
-        <mc:Choice xmlns:a14="http://schemas.microsoft.com/office/drawing/2010/main" Requires="a14">
+      <mc:AlternateContent xmlns:mc="http://schemas.openxmlformats.org/markup-compatibility/2006" xmlns:a14="http://schemas.microsoft.com/office/drawing/2010/main">
+        <mc:Choice Requires="a14">
           <p:sp>
             <p:nvSpPr>
               <p:cNvPr id="8" name="CasellaDiTesto 7">
@@ -19328,7 +18311,7 @@
             </p:txBody>
           </p:sp>
         </mc:Choice>
-        <mc:Fallback>
+        <mc:Fallback xmlns="">
           <p:sp>
             <p:nvSpPr>
               <p:cNvPr id="8" name="CasellaDiTesto 7">
@@ -19408,8 +18391,8 @@
           </a:p>
         </p:txBody>
       </p:sp>
-      <mc:AlternateContent xmlns:mc="http://schemas.openxmlformats.org/markup-compatibility/2006">
-        <mc:Choice xmlns:a14="http://schemas.microsoft.com/office/drawing/2010/main" Requires="a14">
+      <mc:AlternateContent xmlns:mc="http://schemas.openxmlformats.org/markup-compatibility/2006" xmlns:a14="http://schemas.microsoft.com/office/drawing/2010/main">
+        <mc:Choice Requires="a14">
           <p:sp>
             <p:nvSpPr>
               <p:cNvPr id="10" name="CasellaDiTesto 9">
@@ -19571,7 +18554,7 @@
             </p:txBody>
           </p:sp>
         </mc:Choice>
-        <mc:Fallback>
+        <mc:Fallback xmlns="">
           <p:sp>
             <p:nvSpPr>
               <p:cNvPr id="10" name="CasellaDiTesto 9">
@@ -19792,8 +18775,8 @@
           </a:p>
         </p:txBody>
       </p:sp>
-      <mc:AlternateContent xmlns:mc="http://schemas.openxmlformats.org/markup-compatibility/2006">
-        <mc:Choice xmlns:a14="http://schemas.microsoft.com/office/drawing/2010/main" Requires="a14">
+      <mc:AlternateContent xmlns:mc="http://schemas.openxmlformats.org/markup-compatibility/2006" xmlns:a14="http://schemas.microsoft.com/office/drawing/2010/main">
+        <mc:Choice Requires="a14">
           <p:sp>
             <p:nvSpPr>
               <p:cNvPr id="8" name="CasellaDiTesto 7">
@@ -19858,7 +18841,7 @@
             </p:txBody>
           </p:sp>
         </mc:Choice>
-        <mc:Fallback>
+        <mc:Fallback xmlns="">
           <p:sp>
             <p:nvSpPr>
               <p:cNvPr id="8" name="CasellaDiTesto 7">
@@ -20000,8 +18983,8 @@
               <a:chExt cx="3503487" cy="935122"/>
             </a:xfrm>
           </p:grpSpPr>
-          <mc:AlternateContent xmlns:mc="http://schemas.openxmlformats.org/markup-compatibility/2006">
-            <mc:Choice xmlns:a14="http://schemas.microsoft.com/office/drawing/2010/main" Requires="a14">
+          <mc:AlternateContent xmlns:mc="http://schemas.openxmlformats.org/markup-compatibility/2006" xmlns:a14="http://schemas.microsoft.com/office/drawing/2010/main">
+            <mc:Choice Requires="a14">
               <p:sp>
                 <p:nvSpPr>
                   <p:cNvPr id="24" name="CasellaDiTesto 23">
@@ -20125,7 +19108,7 @@
                 </p:txBody>
               </p:sp>
             </mc:Choice>
-            <mc:Fallback>
+            <mc:Fallback xmlns="">
               <p:sp>
                 <p:nvSpPr>
                   <p:cNvPr id="24" name="CasellaDiTesto 23">
@@ -20248,8 +19231,8 @@
           </a:p>
         </p:txBody>
       </p:sp>
-      <mc:AlternateContent xmlns:mc="http://schemas.openxmlformats.org/markup-compatibility/2006">
-        <mc:Choice xmlns:a14="http://schemas.microsoft.com/office/drawing/2010/main" Requires="a14">
+      <mc:AlternateContent xmlns:mc="http://schemas.openxmlformats.org/markup-compatibility/2006" xmlns:a14="http://schemas.microsoft.com/office/drawing/2010/main">
+        <mc:Choice Requires="a14">
           <p:sp>
             <p:nvSpPr>
               <p:cNvPr id="31" name="CasellaDiTesto 30">
@@ -20307,7 +19290,7 @@
             </p:txBody>
           </p:sp>
         </mc:Choice>
-        <mc:Fallback>
+        <mc:Fallback xmlns="">
           <p:sp>
             <p:nvSpPr>
               <p:cNvPr id="31" name="CasellaDiTesto 30">

</xml_diff>